<commit_message>
Apply Eva's revisions to Q3 2026 ED Operations & Impact Update draft
Co-Authored-By: Claude Opus 5.5 <noreply@anthropic.com>
Co-authored-by: multica-agent <github@multica.ai>
</commit_message>
<xml_diff>
--- a/2026/Q3/ED-Operations-Impact-Q3-2026-DRAFT.pptx
+++ b/2026/Q3/ED-Operations-Impact-Q3-2026-DRAFT.pptx
@@ -17,7 +17,6 @@
     <p:sldId id="276" r:id="rId27"/>
     <p:sldId id="277" r:id="rId28"/>
     <p:sldId id="278" r:id="rId29"/>
-    <p:sldId id="279" r:id="rId30"/>
   </p:sldIdLst>
   <p:sldSz cx="12191695" cy="6858000" type="screen4x3"/>
   <p:notesSz cx="6858000" cy="9144000"/>
@@ -3377,25 +3376,7 @@
                 </a:solidFill>
                 <a:latin typeface="Inter"/>
               </a:rPr>
-              <a:t>Sponsor: Eva Buzo, Executive Director  ·  Agenda item </a:t>
-            </a:r>
-            <a:r>
-              <a:rPr sz="1000" b="0" i="1">
-                <a:solidFill>
-                  <a:srgbClr val="E12D64"/>
-                </a:solidFill>
-                <a:latin typeface="Inter"/>
-              </a:rPr>
-              <a:t>[Eva to confirm]</a:t>
-            </a:r>
-            <a:r>
-              <a:rPr sz="1000" b="0" i="1">
-                <a:solidFill>
-                  <a:srgbClr val="96FF14"/>
-                </a:solidFill>
-                <a:latin typeface="Inter"/>
-              </a:rPr>
-              <a:t>  ·  15 minutes  ·  Discussion  ·  DRAFT for ED sign-off</a:t>
+              <a:t>Sponsor: Eva Buzo, Executive Director  ·  Agenda item TBC  ·  15 minutes  ·  Discussion  ·  DRAFT for ED sign-off</a:t>
             </a:r>
           </a:p>
         </p:txBody>
@@ -4007,16 +3988,7 @@
                 </a:solidFill>
                 <a:latin typeface="Inter"/>
               </a:rPr>
-              <a:t>The September retreat proposed broadening our framing from serious international crimes to human rights violations (slide 10). </a:t>
-            </a:r>
-            <a:r>
-              <a:rPr sz="1200" b="0" i="1">
-                <a:solidFill>
-                  <a:srgbClr val="E12D64"/>
-                </a:solidFill>
-                <a:latin typeface="Inter"/>
-              </a:rPr>
-              <a:t>[Eva to confirm: Note or Endorse on 29 Oct agenda]</a:t>
+              <a:t>The September retreat broadened our framing from serious international crimes to human rights violations (slide 10).</a:t>
             </a:r>
           </a:p>
         </p:txBody>
@@ -4094,7 +4066,7 @@
                 </a:solidFill>
                 <a:latin typeface="Inter"/>
               </a:rPr>
-              <a:t>2 / 13</a:t>
+              <a:t>2 / 12</a:t>
             </a:r>
           </a:p>
         </p:txBody>
@@ -4921,7 +4893,7 @@
                 </a:solidFill>
                 <a:latin typeface="Inter"/>
               </a:rPr>
-              <a:t>Rohingya dialogue continuing; RCC roundtable on conditions for return at UNGA (25 Sep).</a:t>
+              <a:t>Rohingya dialogue continuing; FDFA head grant and joint workplan requested from Stimson.</a:t>
             </a:r>
           </a:p>
         </p:txBody>
@@ -5082,7 +5054,7 @@
                 </a:solidFill>
                 <a:latin typeface="Inter"/>
               </a:rPr>
-              <a:t>Meta response to our case; Amnesty × hūmānus UNGA side event; Adani research dossier.</a:t>
+              <a:t>Meta response to our case; Amnesty × hūmānus UNGA side event (25 Sep); Adani coordination and investigation continuing.</a:t>
             </a:r>
           </a:p>
         </p:txBody>
@@ -5243,7 +5215,7 @@
                 </a:solidFill>
                 <a:latin typeface="Inter"/>
               </a:rPr>
-              <a:t>Against the Tide swim (Small Islands Coalition, Seychelles, UNGA); Berkeley keynote (28 Sep).</a:t>
+              <a:t>Against the Tide swim (Small Islands Coalition, Seychelles, UNGA); Berkeley keynote (28 Sep); OSF partner retreat, Mexico.</a:t>
             </a:r>
           </a:p>
         </p:txBody>
@@ -5404,7 +5376,7 @@
                 </a:solidFill>
                 <a:latin typeface="Inter"/>
               </a:rPr>
-              <a:t>Sawyeddollah's analysis reports on Rohingya; website in development.</a:t>
+              <a:t>Sawyadullah's 10 analysis reports; website launching November 2026.</a:t>
             </a:r>
           </a:p>
         </p:txBody>
@@ -5443,25 +5415,7 @@
                 </a:solidFill>
                 <a:latin typeface="Inter"/>
               </a:rPr>
-              <a:t>Women's Dialogue (SDC) closed 30 April 2026; no activity this period. </a:t>
-            </a:r>
-            <a:r>
-              <a:rPr sz="1000" b="0" i="1">
-                <a:solidFill>
-                  <a:srgbClr val="E12D64"/>
-                </a:solidFill>
-                <a:latin typeface="Inter"/>
-              </a:rPr>
-              <a:t>[Eva to confirm]</a:t>
-            </a:r>
-            <a:r>
-              <a:rPr sz="1000" b="0" i="1">
-                <a:solidFill>
-                  <a:srgbClr val="410F37"/>
-                </a:solidFill>
-                <a:latin typeface="Inter"/>
-              </a:rPr>
-              <a:t> Finance: see Stacy McGill's Q3 Board Finance Report and Forecast Report.</a:t>
+              <a:t>Women's Dialogue (SDC) grant ended 30 April 2026, as reported at Q2. Finance: see Stacy McGill's Q3 Board Finance Report and Forecast Report.</a:t>
             </a:r>
           </a:p>
         </p:txBody>
@@ -5539,7 +5493,7 @@
                 </a:solidFill>
                 <a:latin typeface="Inter"/>
               </a:rPr>
-              <a:t>3 / 13</a:t>
+              <a:t>3 / 12</a:t>
             </a:r>
           </a:p>
         </p:txBody>
@@ -5800,7 +5754,7 @@
                 </a:solidFill>
                 <a:latin typeface="Inter"/>
               </a:rPr>
-              <a:t>4 / 13</a:t>
+              <a:t>4 / 12</a:t>
             </a:r>
           </a:p>
         </p:txBody>
@@ -6327,16 +6281,7 @@
                 </a:solidFill>
                 <a:latin typeface="Inter"/>
               </a:rPr>
-              <a:t>The retreat agreed to continue the lawyer-network approach and reassess the Rohingya project after six months (slide 10). </a:t>
-            </a:r>
-            <a:r>
-              <a:rPr sz="1200" b="0" i="0">
-                <a:solidFill>
-                  <a:srgbClr val="E12D64"/>
-                </a:solidFill>
-                <a:latin typeface="Inter"/>
-              </a:rPr>
-              <a:t>[Eva to confirm: report the review in writing or verbally]</a:t>
+              <a:t>The retreat agreed to continue the lawyer-network and coordination approach and to take stock of the Rohingya work after six months, around March 2027 (slide 10). The ED will report the outcome to the board.</a:t>
             </a:r>
           </a:p>
         </p:txBody>
@@ -6597,7 +6542,7 @@
                 </a:solidFill>
                 <a:latin typeface="Inter"/>
               </a:rPr>
-              <a:t>5 / 13</a:t>
+              <a:t>5 / 12</a:t>
             </a:r>
           </a:p>
         </p:txBody>
@@ -7307,7 +7252,7 @@
                 </a:solidFill>
                 <a:latin typeface="Inter"/>
               </a:rPr>
-              <a:t>6 / 13</a:t>
+              <a:t>6 / 12</a:t>
             </a:r>
           </a:p>
         </p:txBody>
@@ -7590,7 +7535,7 @@
                 </a:solidFill>
                 <a:latin typeface="Inter"/>
               </a:rPr>
-              <a:t>UNGA week — RCC High-Level Roundtable, The Conditions for Return: A Rohingya-Led Dialogue (25 September).</a:t>
+              <a:t>Request made to Stimson for the FDFA head grant and the approved joint workplan.</a:t>
             </a:r>
           </a:p>
         </p:txBody>
@@ -7673,99 +7618,7 @@
                 </a:solidFill>
                 <a:latin typeface="Inter"/>
               </a:rPr>
-              <a:t>Request made to Stimson for the FDFA head grant and the approved joint workplan.</a:t>
-            </a:r>
-          </a:p>
-        </p:txBody>
-      </p:sp>
-      <p:sp>
-        <p:nvSpPr>
-          <p:cNvPr id="9" name="Rectangle 8"/>
-          <p:cNvSpPr/>
-          <p:nvPr/>
-        </p:nvSpPr>
-        <p:spPr>
-          <a:xfrm>
-            <a:off x="640080" y="4546490"/>
-            <a:ext cx="109728" cy="109728"/>
-          </a:xfrm>
-          <a:prstGeom prst="rect">
-            <a:avLst/>
-          </a:prstGeom>
-          <a:solidFill>
-            <a:srgbClr val="96FF14"/>
-          </a:solidFill>
-          <a:ln>
-            <a:noFill/>
-          </a:ln>
-          <a:effectLst/>
-        </p:spPr>
-        <p:style>
-          <a:lnRef idx="1">
-            <a:schemeClr val="accent1"/>
-          </a:lnRef>
-          <a:fillRef idx="3">
-            <a:schemeClr val="accent1"/>
-          </a:fillRef>
-          <a:effectRef idx="2">
-            <a:schemeClr val="accent1"/>
-          </a:effectRef>
-          <a:fontRef idx="minor">
-            <a:schemeClr val="lt1"/>
-          </a:fontRef>
-        </p:style>
-        <p:txBody>
-          <a:bodyPr rtlCol="0" anchor="ctr"/>
-          <a:lstStyle/>
-          <a:p>
-            <a:pPr algn="ctr"/>
-          </a:p>
-        </p:txBody>
-      </p:sp>
-      <p:sp>
-        <p:nvSpPr>
-          <p:cNvPr id="10" name="TextBox 9"/>
-          <p:cNvSpPr txBox="1"/>
-          <p:nvPr/>
-        </p:nvSpPr>
-        <p:spPr>
-          <a:xfrm>
-            <a:off x="914400" y="4427618"/>
-            <a:ext cx="10698480" cy="693419"/>
-          </a:xfrm>
-          <a:prstGeom prst="rect">
-            <a:avLst/>
-          </a:prstGeom>
-          <a:noFill/>
-        </p:spPr>
-        <p:txBody>
-          <a:bodyPr wrap="square" anchor="t" lIns="0" rIns="0" tIns="0" bIns="0">
-            <a:spAutoFit/>
-          </a:bodyPr>
-          <a:lstStyle/>
-          <a:p>
-            <a:pPr algn="l">
-              <a:lnSpc>
-                <a:spcPct val="125000"/>
-              </a:lnSpc>
-            </a:pPr>
-            <a:r>
-              <a:rPr sz="1300" b="0" i="0">
-                <a:solidFill>
-                  <a:srgbClr val="410F37"/>
-                </a:solidFill>
-                <a:latin typeface="Inter"/>
-              </a:rPr>
-              <a:t>Related peace-network engagement — PHRD Myanmar partner discussion (16 July); Pre-Gathering online sessions, Finding Each Other on Shifting Ground (13 and 16 July); Swiss Peace Partners Network, Geneva (6 August). </a:t>
-            </a:r>
-            <a:r>
-              <a:rPr sz="1300" b="0" i="0">
-                <a:solidFill>
-                  <a:srgbClr val="E12D64"/>
-                </a:solidFill>
-                <a:latin typeface="Inter"/>
-              </a:rPr>
-              <a:t>[Eva to confirm placement]</a:t>
+              <a:t>Partner engagement — PHRD Myanmar partner discussion (16 July); Swiss Peace Partners Network, Geneva (6 August).</a:t>
             </a:r>
           </a:p>
         </p:txBody>
@@ -8161,7 +8014,7 @@
                 </a:solidFill>
                 <a:latin typeface="Inter"/>
               </a:rPr>
-              <a:t> Amnesty × hūmānus and Meta Inc. side events at UNGA (25 Sep); documentary narrative and video series in production.</a:t>
+              <a:t> Amnesty × hūmānus side event at UNGA (25 Sep); documentary narrative and video series in production.</a:t>
             </a:r>
           </a:p>
         </p:txBody>
@@ -8200,7 +8053,7 @@
                 </a:solidFill>
                 <a:latin typeface="Fagun Bold"/>
               </a:rPr>
-              <a:t>Adani / UniSuper / APRA</a:t>
+              <a:t>Adani</a:t>
             </a:r>
           </a:p>
         </p:txBody>
@@ -8239,7 +8092,7 @@
                 </a:solidFill>
                 <a:latin typeface="Inter"/>
               </a:rPr>
-              <a:t>Team research dossier progressing: UniSuper holdings disclosure, super-fund exposure and GQG mandates, Cbus deep dive, OFAC civil probe, Australian fiduciary-duty case law, thermal-coal revenue share, Adani Defence.</a:t>
+              <a:t>Coordination and investigation work continuing, including research on Australian super-fund exposure, fiduciary-duty case law, the OFAC civil probe and Adani Defence.</a:t>
             </a:r>
           </a:p>
         </p:txBody>
@@ -8395,16 +8248,7 @@
                 </a:solidFill>
                 <a:latin typeface="Inter"/>
               </a:rPr>
-              <a:t>At Q2 we proposed a dedicated Adani / UniSuper paper for this meeting. </a:t>
-            </a:r>
-            <a:r>
-              <a:rPr sz="1100" b="0" i="1">
-                <a:solidFill>
-                  <a:srgbClr val="E12D64"/>
-                </a:solidFill>
-                <a:latin typeface="Inter"/>
-              </a:rPr>
-              <a:t>[Eva to confirm: delivered, deferred (with reason) or dropped]</a:t>
+              <a:t>At Q2 we proposed a dedicated Adani paper for this meeting. Coordination and investigation work is continuing; the board is updated through this report.</a:t>
             </a:r>
           </a:p>
         </p:txBody>
@@ -8482,7 +8326,7 @@
                 </a:solidFill>
                 <a:latin typeface="Inter"/>
               </a:rPr>
-              <a:t>7 / 13</a:t>
+              <a:t>7 / 12</a:t>
             </a:r>
           </a:p>
         </p:txBody>
@@ -8665,7 +8509,7 @@
                 </a:solidFill>
                 <a:latin typeface="Inter"/>
               </a:rPr>
-              <a:t>Core funded  ·  Against the Tide, speaking and advocacy</a:t>
+              <a:t>Core funded  ·  Against the Tide, speaking and donor relations</a:t>
             </a:r>
           </a:p>
         </p:txBody>
@@ -8743,7 +8587,7 @@
                 </a:solidFill>
                 <a:latin typeface="Inter"/>
               </a:rPr>
-              <a:t>8 / 13</a:t>
+              <a:t>8 / 12</a:t>
             </a:r>
           </a:p>
         </p:txBody>
@@ -8904,7 +8748,7 @@
                 </a:solidFill>
                 <a:latin typeface="Fagun Medium"/>
               </a:rPr>
-              <a:t>Speaking and advocacy</a:t>
+              <a:t>Speaking</a:t>
             </a:r>
           </a:p>
         </p:txBody>
@@ -8994,13 +8838,52 @@
       </p:sp>
       <p:sp>
         <p:nvSpPr>
+          <p:cNvPr id="6" name="TextBox 5"/>
+          <p:cNvSpPr txBox="1"/>
+          <p:nvPr/>
+        </p:nvSpPr>
+        <p:spPr>
+          <a:xfrm>
+            <a:off x="640080" y="3922039"/>
+            <a:ext cx="10972800" cy="457200"/>
+          </a:xfrm>
+          <a:prstGeom prst="rect">
+            <a:avLst/>
+          </a:prstGeom>
+          <a:noFill/>
+        </p:spPr>
+        <p:txBody>
+          <a:bodyPr wrap="square" anchor="t" lIns="0" rIns="0" tIns="0" bIns="0">
+            <a:spAutoFit/>
+          </a:bodyPr>
+          <a:lstStyle/>
+          <a:p>
+            <a:pPr algn="l">
+              <a:lnSpc>
+                <a:spcPct val="115000"/>
+              </a:lnSpc>
+            </a:pPr>
+            <a:r>
+              <a:rPr sz="1500" b="0" i="0">
+                <a:solidFill>
+                  <a:srgbClr val="410F37"/>
+                </a:solidFill>
+                <a:latin typeface="Fagun Medium"/>
+              </a:rPr>
+              <a:t>Donor relations</a:t>
+            </a:r>
+          </a:p>
+        </p:txBody>
+      </p:sp>
+      <p:sp>
+        <p:nvSpPr>
           <p:cNvPr id="9" name="Rectangle 8"/>
           <p:cNvSpPr/>
           <p:nvPr/>
         </p:nvSpPr>
         <p:spPr>
           <a:xfrm>
-            <a:off x="640080" y="4040911"/>
+            <a:off x="640080" y="4452391"/>
             <a:ext cx="109728" cy="109728"/>
           </a:xfrm>
           <a:prstGeom prst="rect">
@@ -9044,7 +8927,7 @@
         </p:nvSpPr>
         <p:spPr>
           <a:xfrm>
-            <a:off x="914400" y="3922039"/>
+            <a:off x="914400" y="4333519"/>
             <a:ext cx="10698480" cy="462280"/>
           </a:xfrm>
           <a:prstGeom prst="rect">
@@ -9070,173 +8953,7 @@
                 </a:solidFill>
                 <a:latin typeface="Inter"/>
               </a:rPr>
-              <a:t>UNGA week (21–25 September) — Afrobarometer–OSF side event Beyond Borders (24 Sep), OSF reception and network partners dinner, alongside the Amnesty, Meta and RCC events on slides 6 and 7.</a:t>
-            </a:r>
-          </a:p>
-        </p:txBody>
-      </p:sp>
-      <p:sp>
-        <p:nvSpPr>
-          <p:cNvPr id="9" name="Rectangle 8"/>
-          <p:cNvSpPr/>
-          <p:nvPr/>
-        </p:nvSpPr>
-        <p:spPr>
-          <a:xfrm>
-            <a:off x="640080" y="4653191"/>
-            <a:ext cx="109728" cy="109728"/>
-          </a:xfrm>
-          <a:prstGeom prst="rect">
-            <a:avLst/>
-          </a:prstGeom>
-          <a:solidFill>
-            <a:srgbClr val="96FF14"/>
-          </a:solidFill>
-          <a:ln>
-            <a:noFill/>
-          </a:ln>
-          <a:effectLst/>
-        </p:spPr>
-        <p:style>
-          <a:lnRef idx="1">
-            <a:schemeClr val="accent1"/>
-          </a:lnRef>
-          <a:fillRef idx="3">
-            <a:schemeClr val="accent1"/>
-          </a:fillRef>
-          <a:effectRef idx="2">
-            <a:schemeClr val="accent1"/>
-          </a:effectRef>
-          <a:fontRef idx="minor">
-            <a:schemeClr val="lt1"/>
-          </a:fontRef>
-        </p:style>
-        <p:txBody>
-          <a:bodyPr rtlCol="0" anchor="ctr"/>
-          <a:lstStyle/>
-          <a:p>
-            <a:pPr algn="ctr"/>
-          </a:p>
-        </p:txBody>
-      </p:sp>
-      <p:sp>
-        <p:nvSpPr>
-          <p:cNvPr id="10" name="TextBox 9"/>
-          <p:cNvSpPr txBox="1"/>
-          <p:nvPr/>
-        </p:nvSpPr>
-        <p:spPr>
-          <a:xfrm>
-            <a:off x="914400" y="4534319"/>
-            <a:ext cx="10698480" cy="231140"/>
-          </a:xfrm>
-          <a:prstGeom prst="rect">
-            <a:avLst/>
-          </a:prstGeom>
-          <a:noFill/>
-        </p:spPr>
-        <p:txBody>
-          <a:bodyPr wrap="square" anchor="t" lIns="0" rIns="0" tIns="0" bIns="0">
-            <a:spAutoFit/>
-          </a:bodyPr>
-          <a:lstStyle/>
-          <a:p>
-            <a:pPr algn="l">
-              <a:lnSpc>
-                <a:spcPct val="125000"/>
-              </a:lnSpc>
-            </a:pPr>
-            <a:r>
-              <a:rPr sz="1300" b="0" i="0">
-                <a:solidFill>
-                  <a:srgbClr val="410F37"/>
-                </a:solidFill>
-                <a:latin typeface="Inter"/>
-              </a:rPr>
-              <a:t>9th anniversary of the Rohingya genocide (24 August) — communications moment.</a:t>
-            </a:r>
-          </a:p>
-        </p:txBody>
-      </p:sp>
-      <p:sp>
-        <p:nvSpPr>
-          <p:cNvPr id="9" name="Rectangle 8"/>
-          <p:cNvSpPr/>
-          <p:nvPr/>
-        </p:nvSpPr>
-        <p:spPr>
-          <a:xfrm>
-            <a:off x="640080" y="5034331"/>
-            <a:ext cx="109728" cy="109728"/>
-          </a:xfrm>
-          <a:prstGeom prst="rect">
-            <a:avLst/>
-          </a:prstGeom>
-          <a:solidFill>
-            <a:srgbClr val="96FF14"/>
-          </a:solidFill>
-          <a:ln>
-            <a:noFill/>
-          </a:ln>
-          <a:effectLst/>
-        </p:spPr>
-        <p:style>
-          <a:lnRef idx="1">
-            <a:schemeClr val="accent1"/>
-          </a:lnRef>
-          <a:fillRef idx="3">
-            <a:schemeClr val="accent1"/>
-          </a:fillRef>
-          <a:effectRef idx="2">
-            <a:schemeClr val="accent1"/>
-          </a:effectRef>
-          <a:fontRef idx="minor">
-            <a:schemeClr val="lt1"/>
-          </a:fontRef>
-        </p:style>
-        <p:txBody>
-          <a:bodyPr rtlCol="0" anchor="ctr"/>
-          <a:lstStyle/>
-          <a:p>
-            <a:pPr algn="ctr"/>
-          </a:p>
-        </p:txBody>
-      </p:sp>
-      <p:sp>
-        <p:nvSpPr>
-          <p:cNvPr id="10" name="TextBox 9"/>
-          <p:cNvSpPr txBox="1"/>
-          <p:nvPr/>
-        </p:nvSpPr>
-        <p:spPr>
-          <a:xfrm>
-            <a:off x="914400" y="4915459"/>
-            <a:ext cx="10698480" cy="231140"/>
-          </a:xfrm>
-          <a:prstGeom prst="rect">
-            <a:avLst/>
-          </a:prstGeom>
-          <a:noFill/>
-        </p:spPr>
-        <p:txBody>
-          <a:bodyPr wrap="square" anchor="t" lIns="0" rIns="0" tIns="0" bIns="0">
-            <a:spAutoFit/>
-          </a:bodyPr>
-          <a:lstStyle/>
-          <a:p>
-            <a:pPr algn="l">
-              <a:lnSpc>
-                <a:spcPct val="125000"/>
-              </a:lnSpc>
-            </a:pPr>
-            <a:r>
-              <a:rPr sz="1300" b="0" i="0">
-                <a:solidFill>
-                  <a:srgbClr val="410F37"/>
-                </a:solidFill>
-                <a:latin typeface="Inter"/>
-              </a:rPr>
-              <a:t>Media bank (B-roll and photography) being built for future communications.</a:t>
+              <a:t>OSF partner retreat, Mexico — Finding Each Other on Shifting Ground, bringing together around 100 OSF partners; good connections made. Preceded by online pre-gathering sessions in July.</a:t>
             </a:r>
           </a:p>
         </p:txBody>
@@ -9419,34 +9136,7 @@
                 </a:solidFill>
                 <a:latin typeface="Inter"/>
               </a:rPr>
-              <a:t>M. Sawyeddollah </a:t>
-            </a:r>
-            <a:r>
-              <a:rPr sz="1300" b="0" i="1">
-                <a:solidFill>
-                  <a:srgbClr val="E12D64"/>
-                </a:solidFill>
-                <a:latin typeface="Inter"/>
-              </a:rPr>
-              <a:t>[Eva to confirm spelling]</a:t>
-            </a:r>
-            <a:r>
-              <a:rPr sz="1300" b="0" i="1">
-                <a:solidFill>
-                  <a:srgbClr val="E12D64"/>
-                </a:solidFill>
-                <a:latin typeface="Inter"/>
-              </a:rPr>
-              <a:t>  ·  funding line </a:t>
-            </a:r>
-            <a:r>
-              <a:rPr sz="1300" b="0" i="1">
-                <a:solidFill>
-                  <a:srgbClr val="E12D64"/>
-                </a:solidFill>
-                <a:latin typeface="Inter"/>
-              </a:rPr>
-              <a:t>[Eva to confirm]</a:t>
+              <a:t>Sawyadullah  ·  supporting dialogue activities and Rohingya leadership</a:t>
             </a:r>
           </a:p>
         </p:txBody>
@@ -9524,7 +9214,7 @@
                 </a:solidFill>
                 <a:latin typeface="Inter"/>
               </a:rPr>
-              <a:t>9 / 13</a:t>
+              <a:t>9 / 12</a:t>
             </a:r>
           </a:p>
         </p:txBody>
@@ -9602,16 +9292,7 @@
                 </a:solidFill>
                 <a:latin typeface="Inter"/>
               </a:rPr>
-              <a:t>Analysis reports on the Rohingya situation by M. Sawyeddollah, and a website he is building to host the work. </a:t>
-            </a:r>
-            <a:r>
-              <a:rPr sz="1200" b="0" i="0">
-                <a:solidFill>
-                  <a:srgbClr val="E12D64"/>
-                </a:solidFill>
-                <a:latin typeface="Inter"/>
-              </a:rPr>
-              <a:t>[Eva to confirm framing]</a:t>
+              <a:t>Ten analysis reports by Sawyadullah on Rohingya relationships with the United States, China, Bangladesh, India and Pakistan — to aid our dialogue activities and support Rohingya leadership.</a:t>
             </a:r>
           </a:p>
         </p:txBody>
@@ -9733,7 +9414,7 @@
                 </a:solidFill>
                 <a:latin typeface="Inter"/>
               </a:rPr>
-              <a:t>Analysis papers discussed with him in New York during UNGA week (23 September).</a:t>
+              <a:t>Website to host the work in development, launching November 2026.</a:t>
             </a:r>
           </a:p>
         </p:txBody>
@@ -9816,108 +9497,7 @@
                 </a:solidFill>
                 <a:latin typeface="Inter"/>
               </a:rPr>
-              <a:t>Website in development. </a:t>
-            </a:r>
-            <a:r>
-              <a:rPr sz="1300" b="0" i="0">
-                <a:solidFill>
-                  <a:srgbClr val="E12D64"/>
-                </a:solidFill>
-                <a:latin typeface="Inter"/>
-              </a:rPr>
-              <a:t>[Eva to confirm launch timing]</a:t>
-            </a:r>
-          </a:p>
-        </p:txBody>
-      </p:sp>
-      <p:sp>
-        <p:nvSpPr>
-          <p:cNvPr id="9" name="Rectangle 8"/>
-          <p:cNvSpPr/>
-          <p:nvPr/>
-        </p:nvSpPr>
-        <p:spPr>
-          <a:xfrm>
-            <a:off x="640080" y="4165350"/>
-            <a:ext cx="109728" cy="109728"/>
-          </a:xfrm>
-          <a:prstGeom prst="rect">
-            <a:avLst/>
-          </a:prstGeom>
-          <a:solidFill>
-            <a:srgbClr val="96FF14"/>
-          </a:solidFill>
-          <a:ln>
-            <a:noFill/>
-          </a:ln>
-          <a:effectLst/>
-        </p:spPr>
-        <p:style>
-          <a:lnRef idx="1">
-            <a:schemeClr val="accent1"/>
-          </a:lnRef>
-          <a:fillRef idx="3">
-            <a:schemeClr val="accent1"/>
-          </a:fillRef>
-          <a:effectRef idx="2">
-            <a:schemeClr val="accent1"/>
-          </a:effectRef>
-          <a:fontRef idx="minor">
-            <a:schemeClr val="lt1"/>
-          </a:fontRef>
-        </p:style>
-        <p:txBody>
-          <a:bodyPr rtlCol="0" anchor="ctr"/>
-          <a:lstStyle/>
-          <a:p>
-            <a:pPr algn="ctr"/>
-          </a:p>
-        </p:txBody>
-      </p:sp>
-      <p:sp>
-        <p:nvSpPr>
-          <p:cNvPr id="10" name="TextBox 9"/>
-          <p:cNvSpPr txBox="1"/>
-          <p:nvPr/>
-        </p:nvSpPr>
-        <p:spPr>
-          <a:xfrm>
-            <a:off x="914400" y="4046478"/>
-            <a:ext cx="10698480" cy="231140"/>
-          </a:xfrm>
-          <a:prstGeom prst="rect">
-            <a:avLst/>
-          </a:prstGeom>
-          <a:noFill/>
-        </p:spPr>
-        <p:txBody>
-          <a:bodyPr wrap="square" anchor="t" lIns="0" rIns="0" tIns="0" bIns="0">
-            <a:spAutoFit/>
-          </a:bodyPr>
-          <a:lstStyle/>
-          <a:p>
-            <a:pPr algn="l">
-              <a:lnSpc>
-                <a:spcPct val="125000"/>
-              </a:lnSpc>
-            </a:pPr>
-            <a:r>
-              <a:rPr sz="1300" b="0" i="0">
-                <a:solidFill>
-                  <a:srgbClr val="410F37"/>
-                </a:solidFill>
-                <a:latin typeface="Inter"/>
-              </a:rPr>
-              <a:t>Scope and audience of the reports. </a:t>
-            </a:r>
-            <a:r>
-              <a:rPr sz="1300" b="0" i="0">
-                <a:solidFill>
-                  <a:srgbClr val="E12D64"/>
-                </a:solidFill>
-                <a:latin typeface="Inter"/>
-              </a:rPr>
-              <a:t>[Eva to confirm]</a:t>
+              <a:t>A workshop on the content will be run in the Rohingya language.</a:t>
             </a:r>
           </a:p>
         </p:txBody>
@@ -10100,7 +9680,7 @@
                 </a:solidFill>
                 <a:latin typeface="Inter"/>
               </a:rPr>
-              <a:t>Team retreat, September 2026  ·  Day 1: strategy, impact and organisational focus</a:t>
+              <a:t>Team retreat, September 2026  ·  strategy, impact and organisational focus</a:t>
             </a:r>
           </a:p>
         </p:txBody>
@@ -10178,7 +9758,7 @@
                 </a:solidFill>
                 <a:latin typeface="Inter"/>
               </a:rPr>
-              <a:t>10 / 13</a:t>
+              <a:t>10 / 12</a:t>
             </a:r>
           </a:p>
         </p:txBody>
@@ -10383,16 +9963,7 @@
                 </a:solidFill>
                 <a:latin typeface="Inter"/>
               </a:rPr>
-              <a:t>Broaden the framing from serious international crimes to human rights violations; stay people-focused and prioritise systemic change. </a:t>
-            </a:r>
-            <a:r>
-              <a:rPr sz="1300" b="0" i="0">
-                <a:solidFill>
-                  <a:srgbClr val="E12D64"/>
-                </a:solidFill>
-                <a:latin typeface="Inter"/>
-              </a:rPr>
-              <a:t>[Eva to confirm: Note or Endorse on 29 Oct agenda]</a:t>
+              <a:t>Broaden the framing from serious international crimes to human rights violations; stay people-focused and prioritise systemic change.</a:t>
             </a:r>
           </a:p>
         </p:txBody>
@@ -10533,7 +10104,7 @@
         <p:spPr>
           <a:xfrm>
             <a:off x="914400" y="3682796"/>
-            <a:ext cx="10698480" cy="426719"/>
+            <a:ext cx="10698480" cy="213359"/>
           </a:xfrm>
           <a:prstGeom prst="rect">
             <a:avLst/>
@@ -10558,16 +10129,7 @@
                 </a:solidFill>
                 <a:latin typeface="Inter"/>
               </a:rPr>
-              <a:t>Rohingya — continue the lawyer-network and coordination approach; reassess after six months. </a:t>
-            </a:r>
-            <a:r>
-              <a:rPr sz="1300" b="0" i="0">
-                <a:solidFill>
-                  <a:srgbClr val="E12D64"/>
-                </a:solidFill>
-                <a:latin typeface="Inter"/>
-              </a:rPr>
-              <a:t>[Eva to confirm: written or verbal]</a:t>
+              <a:t>Rohingya — continue the lawyer-network and coordination approach, and take stock of progress after six months.</a:t>
             </a:r>
           </a:p>
         </p:txBody>
@@ -10580,7 +10142,7 @@
         </p:nvSpPr>
         <p:spPr>
           <a:xfrm>
-            <a:off x="640080" y="4219515"/>
+            <a:off x="640080" y="4006155"/>
             <a:ext cx="10972800" cy="457200"/>
           </a:xfrm>
           <a:prstGeom prst="rect">
@@ -10606,7 +10168,7 @@
                 </a:solidFill>
                 <a:latin typeface="Fagun Medium"/>
               </a:rPr>
-              <a:t>Organisational choices</a:t>
+              <a:t>Priorities</a:t>
             </a:r>
           </a:p>
         </p:txBody>
@@ -10619,7 +10181,7 @@
         </p:nvSpPr>
         <p:spPr>
           <a:xfrm>
-            <a:off x="640080" y="4749867"/>
+            <a:off x="640080" y="4536507"/>
             <a:ext cx="109728" cy="109728"/>
           </a:xfrm>
           <a:prstGeom prst="rect">
@@ -10663,8 +10225,8 @@
         </p:nvSpPr>
         <p:spPr>
           <a:xfrm>
-            <a:off x="914400" y="4630995"/>
-            <a:ext cx="10698480" cy="426719"/>
+            <a:off x="914400" y="4417635"/>
+            <a:ext cx="10698480" cy="213359"/>
           </a:xfrm>
           <a:prstGeom prst="rect">
             <a:avLst/>
@@ -10689,16 +10251,7 @@
                 </a:solidFill>
                 <a:latin typeface="Inter"/>
               </a:rPr>
-              <a:t>Be realistic about capacity; close or refocus dormant or ineffective projects without a credible path to impact. </a:t>
-            </a:r>
-            <a:r>
-              <a:rPr sz="1300" b="0" i="0">
-                <a:solidFill>
-                  <a:srgbClr val="E12D64"/>
-                </a:solidFill>
-                <a:latin typeface="Inter"/>
-              </a:rPr>
-              <a:t>[Eva to confirm: name projects or keep principled]</a:t>
+              <a:t>Keep excellence, rigour and clear accountability central; new geographies only where needs-driven.</a:t>
             </a:r>
           </a:p>
         </p:txBody>
@@ -10711,7 +10264,7 @@
         </p:nvSpPr>
         <p:spPr>
           <a:xfrm>
-            <a:off x="640080" y="5286586"/>
+            <a:off x="640080" y="4859866"/>
             <a:ext cx="109728" cy="109728"/>
           </a:xfrm>
           <a:prstGeom prst="rect">
@@ -10755,7 +10308,7 @@
         </p:nvSpPr>
         <p:spPr>
           <a:xfrm>
-            <a:off x="914400" y="5167714"/>
+            <a:off x="914400" y="4740994"/>
             <a:ext cx="10698480" cy="213359"/>
           </a:xfrm>
           <a:prstGeom prst="rect">
@@ -10781,99 +10334,7 @@
                 </a:solidFill>
                 <a:latin typeface="Inter"/>
               </a:rPr>
-              <a:t>Keep excellence, rigour and clear accountability central; new geographies only where needs-driven.</a:t>
-            </a:r>
-          </a:p>
-        </p:txBody>
-      </p:sp>
-      <p:sp>
-        <p:nvSpPr>
-          <p:cNvPr id="9" name="Rectangle 8"/>
-          <p:cNvSpPr/>
-          <p:nvPr/>
-        </p:nvSpPr>
-        <p:spPr>
-          <a:xfrm>
-            <a:off x="640080" y="5609945"/>
-            <a:ext cx="109728" cy="109728"/>
-          </a:xfrm>
-          <a:prstGeom prst="rect">
-            <a:avLst/>
-          </a:prstGeom>
-          <a:solidFill>
-            <a:srgbClr val="96FF14"/>
-          </a:solidFill>
-          <a:ln>
-            <a:noFill/>
-          </a:ln>
-          <a:effectLst/>
-        </p:spPr>
-        <p:style>
-          <a:lnRef idx="1">
-            <a:schemeClr val="accent1"/>
-          </a:lnRef>
-          <a:fillRef idx="3">
-            <a:schemeClr val="accent1"/>
-          </a:fillRef>
-          <a:effectRef idx="2">
-            <a:schemeClr val="accent1"/>
-          </a:effectRef>
-          <a:fontRef idx="minor">
-            <a:schemeClr val="lt1"/>
-          </a:fontRef>
-        </p:style>
-        <p:txBody>
-          <a:bodyPr rtlCol="0" anchor="ctr"/>
-          <a:lstStyle/>
-          <a:p>
-            <a:pPr algn="ctr"/>
-          </a:p>
-        </p:txBody>
-      </p:sp>
-      <p:sp>
-        <p:nvSpPr>
-          <p:cNvPr id="10" name="TextBox 9"/>
-          <p:cNvSpPr txBox="1"/>
-          <p:nvPr/>
-        </p:nvSpPr>
-        <p:spPr>
-          <a:xfrm>
-            <a:off x="914400" y="5491073"/>
-            <a:ext cx="10698480" cy="426719"/>
-          </a:xfrm>
-          <a:prstGeom prst="rect">
-            <a:avLst/>
-          </a:prstGeom>
-          <a:noFill/>
-        </p:spPr>
-        <p:txBody>
-          <a:bodyPr wrap="square" anchor="t" lIns="0" rIns="0" tIns="0" bIns="0">
-            <a:spAutoFit/>
-          </a:bodyPr>
-          <a:lstStyle/>
-          <a:p>
-            <a:pPr algn="l">
-              <a:lnSpc>
-                <a:spcPct val="125000"/>
-              </a:lnSpc>
-            </a:pPr>
-            <a:r>
-              <a:rPr sz="1300" b="0" i="0">
-                <a:solidFill>
-                  <a:srgbClr val="410F37"/>
-                </a:solidFill>
-                <a:latin typeface="Inter"/>
-              </a:rPr>
-              <a:t>Tell the organisation's story well, show impact to clients and funders; consider dedicated fundraising capacity. </a:t>
-            </a:r>
-            <a:r>
-              <a:rPr sz="1300" b="0" i="0">
-                <a:solidFill>
-                  <a:srgbClr val="E12D64"/>
-                </a:solidFill>
-                <a:latin typeface="Inter"/>
-              </a:rPr>
-              <a:t>[Eva to confirm: decided or exploratory]</a:t>
+              <a:t>Tell the organisation's story well and show impact to clients and funders; consider dedicated fundraising capacity.</a:t>
             </a:r>
           </a:p>
         </p:txBody>
@@ -10973,7 +10434,7 @@
                 </a:solidFill>
                 <a:latin typeface="Fagun Bold"/>
               </a:rPr>
-              <a:t>Strategy retreat — how we work</a:t>
+              <a:t>Strategic outlook and watch-items</a:t>
             </a:r>
           </a:p>
         </p:txBody>
@@ -11056,144 +10517,27 @@
                 </a:solidFill>
                 <a:latin typeface="Inter"/>
               </a:rPr>
-              <a:t>Team retreat, September 2026  ·  Day 2: culture, collaboration and ways of working</a:t>
-            </a:r>
-          </a:p>
-        </p:txBody>
-      </p:sp>
-      <p:sp>
-        <p:nvSpPr>
-          <p:cNvPr id="19" name="TextBox 18"/>
-          <p:cNvSpPr txBox="1"/>
-          <p:nvPr/>
-        </p:nvSpPr>
-        <p:spPr>
-          <a:xfrm>
-            <a:off x="640080" y="6492240"/>
-            <a:ext cx="7315200" cy="274320"/>
-          </a:xfrm>
-          <a:prstGeom prst="rect">
-            <a:avLst/>
-          </a:prstGeom>
-          <a:noFill/>
-        </p:spPr>
-        <p:txBody>
-          <a:bodyPr wrap="square" anchor="t" lIns="0" rIns="0" tIns="0" bIns="0">
-            <a:spAutoFit/>
-          </a:bodyPr>
-          <a:lstStyle/>
-          <a:p>
-            <a:pPr algn="l">
-              <a:lnSpc>
-                <a:spcPct val="115000"/>
-              </a:lnSpc>
-            </a:pPr>
-            <a:r>
-              <a:rPr sz="900" b="0" i="0">
-                <a:solidFill>
-                  <a:srgbClr val="410F37"/>
-                </a:solidFill>
-                <a:latin typeface="Inter"/>
-              </a:rPr>
-              <a:t>hūmānus  ·  Q3 2026 Board Meeting  ·  Operations &amp; Impact Update  ·  DRAFT</a:t>
-            </a:r>
-          </a:p>
-        </p:txBody>
-      </p:sp>
-      <p:sp>
-        <p:nvSpPr>
-          <p:cNvPr id="20" name="TextBox 19"/>
-          <p:cNvSpPr txBox="1"/>
-          <p:nvPr/>
-        </p:nvSpPr>
-        <p:spPr>
-          <a:xfrm>
-            <a:off x="10332720" y="6492240"/>
-            <a:ext cx="1371600" cy="274320"/>
-          </a:xfrm>
-          <a:prstGeom prst="rect">
-            <a:avLst/>
-          </a:prstGeom>
-          <a:noFill/>
-        </p:spPr>
-        <p:txBody>
-          <a:bodyPr wrap="square" anchor="t" lIns="0" rIns="0" tIns="0" bIns="0">
-            <a:spAutoFit/>
-          </a:bodyPr>
-          <a:lstStyle/>
-          <a:p>
-            <a:pPr algn="r">
-              <a:lnSpc>
-                <a:spcPct val="115000"/>
-              </a:lnSpc>
-            </a:pPr>
-            <a:r>
-              <a:rPr sz="900" b="0" i="0">
-                <a:solidFill>
-                  <a:srgbClr val="410F37"/>
-                </a:solidFill>
-                <a:latin typeface="Inter"/>
-              </a:rPr>
-              <a:t>11 / 13</a:t>
-            </a:r>
-          </a:p>
-        </p:txBody>
-      </p:sp>
-      <p:sp>
-        <p:nvSpPr>
-          <p:cNvPr id="6" name="TextBox 5"/>
-          <p:cNvSpPr txBox="1"/>
-          <p:nvPr/>
-        </p:nvSpPr>
-        <p:spPr>
-          <a:xfrm>
-            <a:off x="640080" y="1874519"/>
-            <a:ext cx="10972800" cy="457200"/>
-          </a:xfrm>
-          <a:prstGeom prst="rect">
-            <a:avLst/>
-          </a:prstGeom>
-          <a:noFill/>
-        </p:spPr>
-        <p:txBody>
-          <a:bodyPr wrap="square" anchor="t" lIns="0" rIns="0" tIns="0" bIns="0">
-            <a:spAutoFit/>
-          </a:bodyPr>
-          <a:lstStyle/>
-          <a:p>
-            <a:pPr algn="l">
-              <a:lnSpc>
-                <a:spcPct val="115000"/>
-              </a:lnSpc>
-            </a:pPr>
-            <a:r>
-              <a:rPr sz="1500" b="0" i="0">
-                <a:solidFill>
-                  <a:srgbClr val="410F37"/>
-                </a:solidFill>
-                <a:latin typeface="Fagun Medium"/>
-              </a:rPr>
-              <a:t>Ways of working</a:t>
-            </a:r>
-          </a:p>
-        </p:txBody>
-      </p:sp>
-      <p:sp>
-        <p:nvSpPr>
-          <p:cNvPr id="9" name="Rectangle 8"/>
+              <a:t>Things to keep in view between now and the February 2027 meeting.</a:t>
+            </a:r>
+          </a:p>
+        </p:txBody>
+      </p:sp>
+      <p:sp>
+        <p:nvSpPr>
+          <p:cNvPr id="6" name="Rectangle 5"/>
           <p:cNvSpPr/>
           <p:nvPr/>
         </p:nvSpPr>
         <p:spPr>
           <a:xfrm>
-            <a:off x="640080" y="2404871"/>
-            <a:ext cx="109728" cy="109728"/>
+            <a:off x="640080" y="1737360"/>
+            <a:ext cx="137160" cy="685800"/>
           </a:xfrm>
           <a:prstGeom prst="rect">
             <a:avLst/>
           </a:prstGeom>
           <a:solidFill>
-            <a:srgbClr val="96FF14"/>
+            <a:srgbClr val="E12D64"/>
           </a:solidFill>
           <a:ln>
             <a:noFill/>
@@ -11224,39 +10568,78 @@
       </p:sp>
       <p:sp>
         <p:nvSpPr>
-          <p:cNvPr id="10" name="TextBox 9"/>
-          <p:cNvSpPr txBox="1"/>
-          <p:nvPr/>
-        </p:nvSpPr>
-        <p:spPr>
-          <a:xfrm>
-            <a:off x="914400" y="2285999"/>
-            <a:ext cx="10698480" cy="213359"/>
-          </a:xfrm>
-          <a:prstGeom prst="rect">
-            <a:avLst/>
-          </a:prstGeom>
-          <a:noFill/>
-        </p:spPr>
-        <p:txBody>
-          <a:bodyPr wrap="square" anchor="t" lIns="0" rIns="0" tIns="0" bIns="0">
-            <a:spAutoFit/>
-          </a:bodyPr>
-          <a:lstStyle/>
-          <a:p>
-            <a:pPr algn="l">
-              <a:lnSpc>
-                <a:spcPct val="125000"/>
-              </a:lnSpc>
-            </a:pPr>
-            <a:r>
-              <a:rPr sz="1300" b="0" i="0">
+          <p:cNvPr id="7" name="TextBox 6"/>
+          <p:cNvSpPr txBox="1"/>
+          <p:nvPr/>
+        </p:nvSpPr>
+        <p:spPr>
+          <a:xfrm>
+            <a:off x="914400" y="1737360"/>
+            <a:ext cx="10698480" cy="320040"/>
+          </a:xfrm>
+          <a:prstGeom prst="rect">
+            <a:avLst/>
+          </a:prstGeom>
+          <a:noFill/>
+        </p:spPr>
+        <p:txBody>
+          <a:bodyPr wrap="square" anchor="t" lIns="0" rIns="0" tIns="0" bIns="0">
+            <a:spAutoFit/>
+          </a:bodyPr>
+          <a:lstStyle/>
+          <a:p>
+            <a:pPr algn="l">
+              <a:lnSpc>
+                <a:spcPct val="115000"/>
+              </a:lnSpc>
+            </a:pPr>
+            <a:r>
+              <a:rPr sz="1200" b="1" i="0">
                 <a:solidFill>
                   <a:srgbClr val="410F37"/>
                 </a:solidFill>
+                <a:latin typeface="Fagun Bold"/>
+              </a:rPr>
+              <a:t>Cash position</a:t>
+            </a:r>
+          </a:p>
+        </p:txBody>
+      </p:sp>
+      <p:sp>
+        <p:nvSpPr>
+          <p:cNvPr id="8" name="TextBox 7"/>
+          <p:cNvSpPr txBox="1"/>
+          <p:nvPr/>
+        </p:nvSpPr>
+        <p:spPr>
+          <a:xfrm>
+            <a:off x="914400" y="2011680"/>
+            <a:ext cx="10698480" cy="457200"/>
+          </a:xfrm>
+          <a:prstGeom prst="rect">
+            <a:avLst/>
+          </a:prstGeom>
+          <a:noFill/>
+        </p:spPr>
+        <p:txBody>
+          <a:bodyPr wrap="square" anchor="t" lIns="0" rIns="0" tIns="0" bIns="0">
+            <a:spAutoFit/>
+          </a:bodyPr>
+          <a:lstStyle/>
+          <a:p>
+            <a:pPr algn="l">
+              <a:lnSpc>
+                <a:spcPct val="115000"/>
+              </a:lnSpc>
+            </a:pPr>
+            <a:r>
+              <a:rPr sz="1000" b="0" i="0">
+                <a:solidFill>
+                  <a:srgbClr val="410F37"/>
+                </a:solidFill>
                 <a:latin typeface="Inter"/>
               </a:rPr>
-              <a:t>Channels — Motion for tasks and coordination, Signal for quick contact, email for external and out-of-hours.</a:t>
+              <a:t>Cash USD 33,679 at 30 September; no contracted receipts until the FCDO Phase II claim (indicatively November) and OSF Year 3 (January 2027). Per Stacy McGill's Q3 Board Finance Report.</a:t>
             </a:r>
           </a:p>
         </p:txBody>
@@ -11269,14 +10652,14 @@
         </p:nvSpPr>
         <p:spPr>
           <a:xfrm>
-            <a:off x="640080" y="2728230"/>
-            <a:ext cx="109728" cy="109728"/>
+            <a:off x="640080" y="2487168"/>
+            <a:ext cx="137160" cy="685800"/>
           </a:xfrm>
           <a:prstGeom prst="rect">
             <a:avLst/>
           </a:prstGeom>
           <a:solidFill>
-            <a:srgbClr val="96FF14"/>
+            <a:srgbClr val="E12D64"/>
           </a:solidFill>
           <a:ln>
             <a:noFill/>
@@ -11313,53 +10696,92 @@
         </p:nvSpPr>
         <p:spPr>
           <a:xfrm>
-            <a:off x="914400" y="2609358"/>
-            <a:ext cx="10698480" cy="213359"/>
-          </a:xfrm>
-          <a:prstGeom prst="rect">
-            <a:avLst/>
-          </a:prstGeom>
-          <a:noFill/>
-        </p:spPr>
-        <p:txBody>
-          <a:bodyPr wrap="square" anchor="t" lIns="0" rIns="0" tIns="0" bIns="0">
-            <a:spAutoFit/>
-          </a:bodyPr>
-          <a:lstStyle/>
-          <a:p>
-            <a:pPr algn="l">
-              <a:lnSpc>
-                <a:spcPct val="125000"/>
-              </a:lnSpc>
-            </a:pPr>
-            <a:r>
-              <a:rPr sz="1300" b="0" i="0">
+            <a:off x="914400" y="2487168"/>
+            <a:ext cx="10698480" cy="320040"/>
+          </a:xfrm>
+          <a:prstGeom prst="rect">
+            <a:avLst/>
+          </a:prstGeom>
+          <a:noFill/>
+        </p:spPr>
+        <p:txBody>
+          <a:bodyPr wrap="square" anchor="t" lIns="0" rIns="0" tIns="0" bIns="0">
+            <a:spAutoFit/>
+          </a:bodyPr>
+          <a:lstStyle/>
+          <a:p>
+            <a:pPr algn="l">
+              <a:lnSpc>
+                <a:spcPct val="115000"/>
+              </a:lnSpc>
+            </a:pPr>
+            <a:r>
+              <a:rPr sz="1200" b="1" i="0">
                 <a:solidFill>
                   <a:srgbClr val="410F37"/>
                 </a:solidFill>
+                <a:latin typeface="Fagun Bold"/>
+              </a:rPr>
+              <a:t>Strategic framing</a:t>
+            </a:r>
+          </a:p>
+        </p:txBody>
+      </p:sp>
+      <p:sp>
+        <p:nvSpPr>
+          <p:cNvPr id="11" name="TextBox 10"/>
+          <p:cNvSpPr txBox="1"/>
+          <p:nvPr/>
+        </p:nvSpPr>
+        <p:spPr>
+          <a:xfrm>
+            <a:off x="914400" y="2761488"/>
+            <a:ext cx="10698480" cy="457200"/>
+          </a:xfrm>
+          <a:prstGeom prst="rect">
+            <a:avLst/>
+          </a:prstGeom>
+          <a:noFill/>
+        </p:spPr>
+        <p:txBody>
+          <a:bodyPr wrap="square" anchor="t" lIns="0" rIns="0" tIns="0" bIns="0">
+            <a:spAutoFit/>
+          </a:bodyPr>
+          <a:lstStyle/>
+          <a:p>
+            <a:pPr algn="l">
+              <a:lnSpc>
+                <a:spcPct val="115000"/>
+              </a:lnSpc>
+            </a:pPr>
+            <a:r>
+              <a:rPr sz="1000" b="0" i="0">
+                <a:solidFill>
+                  <a:srgbClr val="410F37"/>
+                </a:solidFill>
                 <a:latin typeface="Inter"/>
               </a:rPr>
-              <a:t>Rhythm — full-team meetings fortnightly, project meetings on alternate weeks, 15-minute calls for quick clarification.</a:t>
-            </a:r>
-          </a:p>
-        </p:txBody>
-      </p:sp>
-      <p:sp>
-        <p:nvSpPr>
-          <p:cNvPr id="9" name="Rectangle 8"/>
+              <a:t>The retreat broadened the framing of the board-approved 2024–29 strategy from serious international crimes to human rights violations — brought to the board for discussion.</a:t>
+            </a:r>
+          </a:p>
+        </p:txBody>
+      </p:sp>
+      <p:sp>
+        <p:nvSpPr>
+          <p:cNvPr id="12" name="Rectangle 11"/>
           <p:cNvSpPr/>
           <p:nvPr/>
         </p:nvSpPr>
         <p:spPr>
           <a:xfrm>
-            <a:off x="640080" y="3051589"/>
-            <a:ext cx="109728" cy="109728"/>
+            <a:off x="640080" y="3236976"/>
+            <a:ext cx="137160" cy="685800"/>
           </a:xfrm>
           <a:prstGeom prst="rect">
             <a:avLst/>
           </a:prstGeom>
           <a:solidFill>
-            <a:srgbClr val="96FF14"/>
+            <a:srgbClr val="E12D64"/>
           </a:solidFill>
           <a:ln>
             <a:noFill/>
@@ -11390,59 +10812,98 @@
       </p:sp>
       <p:sp>
         <p:nvSpPr>
-          <p:cNvPr id="10" name="TextBox 9"/>
-          <p:cNvSpPr txBox="1"/>
-          <p:nvPr/>
-        </p:nvSpPr>
-        <p:spPr>
-          <a:xfrm>
-            <a:off x="914400" y="2932717"/>
-            <a:ext cx="10698480" cy="426719"/>
-          </a:xfrm>
-          <a:prstGeom prst="rect">
-            <a:avLst/>
-          </a:prstGeom>
-          <a:noFill/>
-        </p:spPr>
-        <p:txBody>
-          <a:bodyPr wrap="square" anchor="t" lIns="0" rIns="0" tIns="0" bIns="0">
-            <a:spAutoFit/>
-          </a:bodyPr>
-          <a:lstStyle/>
-          <a:p>
-            <a:pPr algn="l">
-              <a:lnSpc>
-                <a:spcPct val="125000"/>
-              </a:lnSpc>
-            </a:pPr>
-            <a:r>
-              <a:rPr sz="1300" b="0" i="0">
+          <p:cNvPr id="13" name="TextBox 12"/>
+          <p:cNvSpPr txBox="1"/>
+          <p:nvPr/>
+        </p:nvSpPr>
+        <p:spPr>
+          <a:xfrm>
+            <a:off x="914400" y="3236976"/>
+            <a:ext cx="10698480" cy="320040"/>
+          </a:xfrm>
+          <a:prstGeom prst="rect">
+            <a:avLst/>
+          </a:prstGeom>
+          <a:noFill/>
+        </p:spPr>
+        <p:txBody>
+          <a:bodyPr wrap="square" anchor="t" lIns="0" rIns="0" tIns="0" bIns="0">
+            <a:spAutoFit/>
+          </a:bodyPr>
+          <a:lstStyle/>
+          <a:p>
+            <a:pPr algn="l">
+              <a:lnSpc>
+                <a:spcPct val="115000"/>
+              </a:lnSpc>
+            </a:pPr>
+            <a:r>
+              <a:rPr sz="1200" b="1" i="0">
                 <a:solidFill>
                   <a:srgbClr val="410F37"/>
                 </a:solidFill>
+                <a:latin typeface="Fagun Bold"/>
+              </a:rPr>
+              <a:t>Rohingya work</a:t>
+            </a:r>
+          </a:p>
+        </p:txBody>
+      </p:sp>
+      <p:sp>
+        <p:nvSpPr>
+          <p:cNvPr id="14" name="TextBox 13"/>
+          <p:cNvSpPr txBox="1"/>
+          <p:nvPr/>
+        </p:nvSpPr>
+        <p:spPr>
+          <a:xfrm>
+            <a:off x="914400" y="3511296"/>
+            <a:ext cx="10698480" cy="457200"/>
+          </a:xfrm>
+          <a:prstGeom prst="rect">
+            <a:avLst/>
+          </a:prstGeom>
+          <a:noFill/>
+        </p:spPr>
+        <p:txBody>
+          <a:bodyPr wrap="square" anchor="t" lIns="0" rIns="0" tIns="0" bIns="0">
+            <a:spAutoFit/>
+          </a:bodyPr>
+          <a:lstStyle/>
+          <a:p>
+            <a:pPr algn="l">
+              <a:lnSpc>
+                <a:spcPct val="115000"/>
+              </a:lnSpc>
+            </a:pPr>
+            <a:r>
+              <a:rPr sz="1000" b="0" i="0">
+                <a:solidFill>
+                  <a:srgbClr val="410F37"/>
+                </a:solidFill>
                 <a:latin typeface="Inter"/>
               </a:rPr>
-              <a:t>Supportive accountability — flag delays and dependencies early; clear owners, timelines and expectations; setbacks treated as learning.</a:t>
-            </a:r>
-          </a:p>
-        </p:txBody>
-      </p:sp>
-      <p:sp>
-        <p:nvSpPr>
-          <p:cNvPr id="9" name="Rectangle 8"/>
+              <a:t>Progress to be taken stock of around March 2027, between board meetings; the ED will report the outcome to the board.</a:t>
+            </a:r>
+          </a:p>
+        </p:txBody>
+      </p:sp>
+      <p:sp>
+        <p:nvSpPr>
+          <p:cNvPr id="15" name="Rectangle 14"/>
           <p:cNvSpPr/>
           <p:nvPr/>
         </p:nvSpPr>
         <p:spPr>
           <a:xfrm>
-            <a:off x="640080" y="3588308"/>
-            <a:ext cx="109728" cy="109728"/>
+            <a:off x="640080" y="3986784"/>
+            <a:ext cx="137160" cy="685800"/>
           </a:xfrm>
           <a:prstGeom prst="rect">
             <a:avLst/>
           </a:prstGeom>
           <a:solidFill>
-            <a:srgbClr val="96FF14"/>
+            <a:srgbClr val="E12D64"/>
           </a:solidFill>
           <a:ln>
             <a:noFill/>
@@ -11473,59 +10934,98 @@
       </p:sp>
       <p:sp>
         <p:nvSpPr>
-          <p:cNvPr id="10" name="TextBox 9"/>
-          <p:cNvSpPr txBox="1"/>
-          <p:nvPr/>
-        </p:nvSpPr>
-        <p:spPr>
-          <a:xfrm>
-            <a:off x="914400" y="3469436"/>
-            <a:ext cx="10698480" cy="426719"/>
-          </a:xfrm>
-          <a:prstGeom prst="rect">
-            <a:avLst/>
-          </a:prstGeom>
-          <a:noFill/>
-        </p:spPr>
-        <p:txBody>
-          <a:bodyPr wrap="square" anchor="t" lIns="0" rIns="0" tIns="0" bIns="0">
-            <a:spAutoFit/>
-          </a:bodyPr>
-          <a:lstStyle/>
-          <a:p>
-            <a:pPr algn="l">
-              <a:lnSpc>
-                <a:spcPct val="125000"/>
-              </a:lnSpc>
-            </a:pPr>
-            <a:r>
-              <a:rPr sz="1300" b="0" i="0">
+          <p:cNvPr id="16" name="TextBox 15"/>
+          <p:cNvSpPr txBox="1"/>
+          <p:nvPr/>
+        </p:nvSpPr>
+        <p:spPr>
+          <a:xfrm>
+            <a:off x="914400" y="3986784"/>
+            <a:ext cx="10698480" cy="320040"/>
+          </a:xfrm>
+          <a:prstGeom prst="rect">
+            <a:avLst/>
+          </a:prstGeom>
+          <a:noFill/>
+        </p:spPr>
+        <p:txBody>
+          <a:bodyPr wrap="square" anchor="t" lIns="0" rIns="0" tIns="0" bIns="0">
+            <a:spAutoFit/>
+          </a:bodyPr>
+          <a:lstStyle/>
+          <a:p>
+            <a:pPr algn="l">
+              <a:lnSpc>
+                <a:spcPct val="115000"/>
+              </a:lnSpc>
+            </a:pPr>
+            <a:r>
+              <a:rPr sz="1200" b="1" i="0">
                 <a:solidFill>
                   <a:srgbClr val="410F37"/>
                 </a:solidFill>
+                <a:latin typeface="Fagun Bold"/>
+              </a:rPr>
+              <a:t>Fundraising and post-OSF horizon</a:t>
+            </a:r>
+          </a:p>
+        </p:txBody>
+      </p:sp>
+      <p:sp>
+        <p:nvSpPr>
+          <p:cNvPr id="17" name="TextBox 16"/>
+          <p:cNvSpPr txBox="1"/>
+          <p:nvPr/>
+        </p:nvSpPr>
+        <p:spPr>
+          <a:xfrm>
+            <a:off x="914400" y="4261104"/>
+            <a:ext cx="10698480" cy="457200"/>
+          </a:xfrm>
+          <a:prstGeom prst="rect">
+            <a:avLst/>
+          </a:prstGeom>
+          <a:noFill/>
+        </p:spPr>
+        <p:txBody>
+          <a:bodyPr wrap="square" anchor="t" lIns="0" rIns="0" tIns="0" bIns="0">
+            <a:spAutoFit/>
+          </a:bodyPr>
+          <a:lstStyle/>
+          <a:p>
+            <a:pPr algn="l">
+              <a:lnSpc>
+                <a:spcPct val="115000"/>
+              </a:lnSpc>
+            </a:pPr>
+            <a:r>
+              <a:rPr sz="1000" b="0" i="0">
+                <a:solidFill>
+                  <a:srgbClr val="410F37"/>
+                </a:solidFill>
                 <a:latin typeface="Inter"/>
               </a:rPr>
-              <a:t>Audiences — "humanizing justice" for clients seeking remedies and funders seeking measurable impact; policymakers, lawyers and media as multipliers.</a:t>
-            </a:r>
-          </a:p>
-        </p:txBody>
-      </p:sp>
-      <p:sp>
-        <p:nvSpPr>
-          <p:cNvPr id="9" name="Rectangle 8"/>
+              <a:t>Dedicated fundraising capacity under consideration — continues the Q2 item 6 discussion on matching ambition to fundraising.</a:t>
+            </a:r>
+          </a:p>
+        </p:txBody>
+      </p:sp>
+      <p:sp>
+        <p:nvSpPr>
+          <p:cNvPr id="18" name="Rectangle 17"/>
           <p:cNvSpPr/>
           <p:nvPr/>
         </p:nvSpPr>
         <p:spPr>
           <a:xfrm>
-            <a:off x="640080" y="4125027"/>
-            <a:ext cx="109728" cy="109728"/>
+            <a:off x="640080" y="4736592"/>
+            <a:ext cx="137160" cy="685800"/>
           </a:xfrm>
           <a:prstGeom prst="rect">
             <a:avLst/>
           </a:prstGeom>
           <a:solidFill>
-            <a:srgbClr val="96FF14"/>
+            <a:srgbClr val="E12D64"/>
           </a:solidFill>
           <a:ln>
             <a:noFill/>
@@ -11556,53 +11056,92 @@
       </p:sp>
       <p:sp>
         <p:nvSpPr>
-          <p:cNvPr id="10" name="TextBox 9"/>
-          <p:cNvSpPr txBox="1"/>
-          <p:nvPr/>
-        </p:nvSpPr>
-        <p:spPr>
-          <a:xfrm>
-            <a:off x="914400" y="4006155"/>
-            <a:ext cx="10698480" cy="213359"/>
-          </a:xfrm>
-          <a:prstGeom prst="rect">
-            <a:avLst/>
-          </a:prstGeom>
-          <a:noFill/>
-        </p:spPr>
-        <p:txBody>
-          <a:bodyPr wrap="square" anchor="t" lIns="0" rIns="0" tIns="0" bIns="0">
-            <a:spAutoFit/>
-          </a:bodyPr>
-          <a:lstStyle/>
-          <a:p>
-            <a:pPr algn="l">
-              <a:lnSpc>
-                <a:spcPct val="125000"/>
-              </a:lnSpc>
-            </a:pPr>
-            <a:r>
-              <a:rPr sz="1300" b="0" i="0">
+          <p:cNvPr id="19" name="TextBox 18"/>
+          <p:cNvSpPr txBox="1"/>
+          <p:nvPr/>
+        </p:nvSpPr>
+        <p:spPr>
+          <a:xfrm>
+            <a:off x="914400" y="4736592"/>
+            <a:ext cx="10698480" cy="320040"/>
+          </a:xfrm>
+          <a:prstGeom prst="rect">
+            <a:avLst/>
+          </a:prstGeom>
+          <a:noFill/>
+        </p:spPr>
+        <p:txBody>
+          <a:bodyPr wrap="square" anchor="t" lIns="0" rIns="0" tIns="0" bIns="0">
+            <a:spAutoFit/>
+          </a:bodyPr>
+          <a:lstStyle/>
+          <a:p>
+            <a:pPr algn="l">
+              <a:lnSpc>
+                <a:spcPct val="115000"/>
+              </a:lnSpc>
+            </a:pPr>
+            <a:r>
+              <a:rPr sz="1200" b="1" i="0">
                 <a:solidFill>
                   <a:srgbClr val="410F37"/>
                 </a:solidFill>
+                <a:latin typeface="Fagun Bold"/>
+              </a:rPr>
+              <a:t>Governance and entity</a:t>
+            </a:r>
+          </a:p>
+        </p:txBody>
+      </p:sp>
+      <p:sp>
+        <p:nvSpPr>
+          <p:cNvPr id="20" name="TextBox 19"/>
+          <p:cNvSpPr txBox="1"/>
+          <p:nvPr/>
+        </p:nvSpPr>
+        <p:spPr>
+          <a:xfrm>
+            <a:off x="914400" y="5010912"/>
+            <a:ext cx="10698480" cy="457200"/>
+          </a:xfrm>
+          <a:prstGeom prst="rect">
+            <a:avLst/>
+          </a:prstGeom>
+          <a:noFill/>
+        </p:spPr>
+        <p:txBody>
+          <a:bodyPr wrap="square" anchor="t" lIns="0" rIns="0" tIns="0" bIns="0">
+            <a:spAutoFit/>
+          </a:bodyPr>
+          <a:lstStyle/>
+          <a:p>
+            <a:pPr algn="l">
+              <a:lnSpc>
+                <a:spcPct val="115000"/>
+              </a:lnSpc>
+            </a:pPr>
+            <a:r>
+              <a:rPr sz="1000" b="0" i="0">
+                <a:solidFill>
+                  <a:srgbClr val="410F37"/>
+                </a:solidFill>
                 <a:latin typeface="Inter"/>
               </a:rPr>
-              <a:t>People — regionally grounded recruitment, internships and fellowships; external mentors and internal peer support.</a:t>
-            </a:r>
-          </a:p>
-        </p:txBody>
-      </p:sp>
-      <p:sp>
-        <p:nvSpPr>
-          <p:cNvPr id="6" name="TextBox 5"/>
-          <p:cNvSpPr txBox="1"/>
-          <p:nvPr/>
-        </p:nvSpPr>
-        <p:spPr>
-          <a:xfrm>
-            <a:off x="640080" y="4329514"/>
-            <a:ext cx="10972800" cy="457200"/>
+              <a:t>Legal name change VAI → hūmānus notified to OSF grant contacts; staff contract renewals in progress. Finance detail in Stacy McGill's papers.</a:t>
+            </a:r>
+          </a:p>
+        </p:txBody>
+      </p:sp>
+      <p:sp>
+        <p:nvSpPr>
+          <p:cNvPr id="24" name="TextBox 23"/>
+          <p:cNvSpPr txBox="1"/>
+          <p:nvPr/>
+        </p:nvSpPr>
+        <p:spPr>
+          <a:xfrm>
+            <a:off x="640080" y="6492240"/>
+            <a:ext cx="7315200" cy="274320"/>
           </a:xfrm>
           <a:prstGeom prst="rect">
             <a:avLst/>
@@ -11621,52 +11160,52 @@
               </a:lnSpc>
             </a:pPr>
             <a:r>
-              <a:rPr sz="1500" b="0" i="0">
+              <a:rPr sz="900" b="0" i="0">
                 <a:solidFill>
                   <a:srgbClr val="410F37"/>
                 </a:solidFill>
-                <a:latin typeface="Fagun Medium"/>
-              </a:rPr>
-              <a:t>Follow-up themes</a:t>
-            </a:r>
-          </a:p>
-        </p:txBody>
-      </p:sp>
-      <p:sp>
-        <p:nvSpPr>
-          <p:cNvPr id="7" name="TextBox 6"/>
-          <p:cNvSpPr txBox="1"/>
-          <p:nvPr/>
-        </p:nvSpPr>
-        <p:spPr>
-          <a:xfrm>
-            <a:off x="640080" y="4740994"/>
-            <a:ext cx="10972800" cy="426719"/>
-          </a:xfrm>
-          <a:prstGeom prst="rect">
-            <a:avLst/>
-          </a:prstGeom>
-          <a:noFill/>
-        </p:spPr>
-        <p:txBody>
-          <a:bodyPr wrap="square" anchor="t" lIns="0" rIns="0" tIns="0" bIns="0">
-            <a:spAutoFit/>
-          </a:bodyPr>
-          <a:lstStyle/>
-          <a:p>
-            <a:pPr algn="l">
+                <a:latin typeface="Inter"/>
+              </a:rPr>
+              <a:t>hūmānus  ·  Q3 2026 Board Meeting  ·  Operations &amp; Impact Update  ·  DRAFT</a:t>
+            </a:r>
+          </a:p>
+        </p:txBody>
+      </p:sp>
+      <p:sp>
+        <p:nvSpPr>
+          <p:cNvPr id="25" name="TextBox 24"/>
+          <p:cNvSpPr txBox="1"/>
+          <p:nvPr/>
+        </p:nvSpPr>
+        <p:spPr>
+          <a:xfrm>
+            <a:off x="10332720" y="6492240"/>
+            <a:ext cx="1371600" cy="274320"/>
+          </a:xfrm>
+          <a:prstGeom prst="rect">
+            <a:avLst/>
+          </a:prstGeom>
+          <a:noFill/>
+        </p:spPr>
+        <p:txBody>
+          <a:bodyPr wrap="square" anchor="t" lIns="0" rIns="0" tIns="0" bIns="0">
+            <a:spAutoFit/>
+          </a:bodyPr>
+          <a:lstStyle/>
+          <a:p>
+            <a:pPr algn="r">
               <a:lnSpc>
                 <a:spcPct val="115000"/>
               </a:lnSpc>
             </a:pPr>
             <a:r>
-              <a:rPr sz="1200" b="0" i="0">
+              <a:rPr sz="900" b="0" i="0">
                 <a:solidFill>
                   <a:srgbClr val="410F37"/>
                 </a:solidFill>
                 <a:latin typeface="Inter"/>
               </a:rPr>
-              <a:t>Connect activities and resource requests to client outcomes; reassess work without a realistic route to impact, including the Rohingya project after the review period; strengthen public storytelling; keep refining strategy and practice as capacity evolves.</a:t>
+              <a:t>11 / 12</a:t>
             </a:r>
           </a:p>
         </p:txBody>
@@ -11680,1035 +11219,6 @@
 </file>
 
 <file path=ppt/slides/slide23.xml><?xml version="1.0" encoding="utf-8"?>
-<p:sld xmlns:a="http://schemas.openxmlformats.org/drawingml/2006/main" xmlns:p="http://schemas.openxmlformats.org/presentationml/2006/main" xmlns:r="http://schemas.openxmlformats.org/officeDocument/2006/relationships">
-  <p:cSld>
-    <p:spTree>
-      <p:nvGrpSpPr>
-        <p:cNvPr id="1" name=""/>
-        <p:cNvGrpSpPr/>
-        <p:nvPr/>
-      </p:nvGrpSpPr>
-      <p:grpSpPr/>
-      <p:sp>
-        <p:nvSpPr>
-          <p:cNvPr id="2" name="Rectangle 1"/>
-          <p:cNvSpPr/>
-          <p:nvPr/>
-        </p:nvSpPr>
-        <p:spPr>
-          <a:xfrm>
-            <a:off x="0" y="0"/>
-            <a:ext cx="12191695" cy="6858000"/>
-          </a:xfrm>
-          <a:prstGeom prst="rect">
-            <a:avLst/>
-          </a:prstGeom>
-          <a:solidFill>
-            <a:srgbClr val="FFFFFF"/>
-          </a:solidFill>
-          <a:ln>
-            <a:noFill/>
-          </a:ln>
-        </p:spPr>
-        <p:style>
-          <a:lnRef idx="1">
-            <a:schemeClr val="accent1"/>
-          </a:lnRef>
-          <a:fillRef idx="3">
-            <a:schemeClr val="accent1"/>
-          </a:fillRef>
-          <a:effectRef idx="2">
-            <a:schemeClr val="accent1"/>
-          </a:effectRef>
-          <a:fontRef idx="minor">
-            <a:schemeClr val="lt1"/>
-          </a:fontRef>
-        </p:style>
-        <p:txBody>
-          <a:bodyPr rtlCol="0" anchor="ctr"/>
-          <a:lstStyle/>
-          <a:p>
-            <a:pPr algn="ctr"/>
-          </a:p>
-        </p:txBody>
-      </p:sp>
-      <p:sp>
-        <p:nvSpPr>
-          <p:cNvPr id="3" name="TextBox 2"/>
-          <p:cNvSpPr txBox="1"/>
-          <p:nvPr/>
-        </p:nvSpPr>
-        <p:spPr>
-          <a:xfrm>
-            <a:off x="640080" y="502920"/>
-            <a:ext cx="10972800" cy="548640"/>
-          </a:xfrm>
-          <a:prstGeom prst="rect">
-            <a:avLst/>
-          </a:prstGeom>
-          <a:noFill/>
-        </p:spPr>
-        <p:txBody>
-          <a:bodyPr wrap="square" anchor="t" lIns="0" rIns="0" tIns="0" bIns="0">
-            <a:spAutoFit/>
-          </a:bodyPr>
-          <a:lstStyle/>
-          <a:p>
-            <a:pPr algn="l">
-              <a:lnSpc>
-                <a:spcPct val="115000"/>
-              </a:lnSpc>
-            </a:pPr>
-            <a:r>
-              <a:rPr sz="2800" b="1" i="0">
-                <a:solidFill>
-                  <a:srgbClr val="410F37"/>
-                </a:solidFill>
-                <a:latin typeface="Fagun Bold"/>
-              </a:rPr>
-              <a:t>Strategic outlook and watch-items</a:t>
-            </a:r>
-          </a:p>
-        </p:txBody>
-      </p:sp>
-      <p:sp>
-        <p:nvSpPr>
-          <p:cNvPr id="4" name="Rectangle 3"/>
-          <p:cNvSpPr/>
-          <p:nvPr/>
-        </p:nvSpPr>
-        <p:spPr>
-          <a:xfrm>
-            <a:off x="640080" y="1097280"/>
-            <a:ext cx="548640" cy="54864"/>
-          </a:xfrm>
-          <a:prstGeom prst="rect">
-            <a:avLst/>
-          </a:prstGeom>
-          <a:solidFill>
-            <a:srgbClr val="E12D64"/>
-          </a:solidFill>
-          <a:ln>
-            <a:noFill/>
-          </a:ln>
-          <a:effectLst/>
-        </p:spPr>
-        <p:style>
-          <a:lnRef idx="1">
-            <a:schemeClr val="accent1"/>
-          </a:lnRef>
-          <a:fillRef idx="3">
-            <a:schemeClr val="accent1"/>
-          </a:fillRef>
-          <a:effectRef idx="2">
-            <a:schemeClr val="accent1"/>
-          </a:effectRef>
-          <a:fontRef idx="minor">
-            <a:schemeClr val="lt1"/>
-          </a:fontRef>
-        </p:style>
-        <p:txBody>
-          <a:bodyPr rtlCol="0" anchor="ctr"/>
-          <a:lstStyle/>
-          <a:p>
-            <a:pPr algn="ctr"/>
-          </a:p>
-        </p:txBody>
-      </p:sp>
-      <p:sp>
-        <p:nvSpPr>
-          <p:cNvPr id="5" name="TextBox 4"/>
-          <p:cNvSpPr txBox="1"/>
-          <p:nvPr/>
-        </p:nvSpPr>
-        <p:spPr>
-          <a:xfrm>
-            <a:off x="640080" y="1280160"/>
-            <a:ext cx="10972800" cy="457200"/>
-          </a:xfrm>
-          <a:prstGeom prst="rect">
-            <a:avLst/>
-          </a:prstGeom>
-          <a:noFill/>
-        </p:spPr>
-        <p:txBody>
-          <a:bodyPr wrap="square" anchor="t" lIns="0" rIns="0" tIns="0" bIns="0">
-            <a:spAutoFit/>
-          </a:bodyPr>
-          <a:lstStyle/>
-          <a:p>
-            <a:pPr algn="l">
-              <a:lnSpc>
-                <a:spcPct val="115000"/>
-              </a:lnSpc>
-            </a:pPr>
-            <a:r>
-              <a:rPr sz="1300" b="0" i="1">
-                <a:solidFill>
-                  <a:srgbClr val="E12D64"/>
-                </a:solidFill>
-                <a:latin typeface="Inter"/>
-              </a:rPr>
-              <a:t>Things to keep in view between now and the February 2027 meeting.</a:t>
-            </a:r>
-          </a:p>
-        </p:txBody>
-      </p:sp>
-      <p:sp>
-        <p:nvSpPr>
-          <p:cNvPr id="6" name="Rectangle 5"/>
-          <p:cNvSpPr/>
-          <p:nvPr/>
-        </p:nvSpPr>
-        <p:spPr>
-          <a:xfrm>
-            <a:off x="640080" y="1737360"/>
-            <a:ext cx="137160" cy="685800"/>
-          </a:xfrm>
-          <a:prstGeom prst="rect">
-            <a:avLst/>
-          </a:prstGeom>
-          <a:solidFill>
-            <a:srgbClr val="E12D64"/>
-          </a:solidFill>
-          <a:ln>
-            <a:noFill/>
-          </a:ln>
-          <a:effectLst/>
-        </p:spPr>
-        <p:style>
-          <a:lnRef idx="1">
-            <a:schemeClr val="accent1"/>
-          </a:lnRef>
-          <a:fillRef idx="3">
-            <a:schemeClr val="accent1"/>
-          </a:fillRef>
-          <a:effectRef idx="2">
-            <a:schemeClr val="accent1"/>
-          </a:effectRef>
-          <a:fontRef idx="minor">
-            <a:schemeClr val="lt1"/>
-          </a:fontRef>
-        </p:style>
-        <p:txBody>
-          <a:bodyPr rtlCol="0" anchor="ctr"/>
-          <a:lstStyle/>
-          <a:p>
-            <a:pPr algn="ctr"/>
-          </a:p>
-        </p:txBody>
-      </p:sp>
-      <p:sp>
-        <p:nvSpPr>
-          <p:cNvPr id="7" name="TextBox 6"/>
-          <p:cNvSpPr txBox="1"/>
-          <p:nvPr/>
-        </p:nvSpPr>
-        <p:spPr>
-          <a:xfrm>
-            <a:off x="914400" y="1737360"/>
-            <a:ext cx="10698480" cy="320040"/>
-          </a:xfrm>
-          <a:prstGeom prst="rect">
-            <a:avLst/>
-          </a:prstGeom>
-          <a:noFill/>
-        </p:spPr>
-        <p:txBody>
-          <a:bodyPr wrap="square" anchor="t" lIns="0" rIns="0" tIns="0" bIns="0">
-            <a:spAutoFit/>
-          </a:bodyPr>
-          <a:lstStyle/>
-          <a:p>
-            <a:pPr algn="l">
-              <a:lnSpc>
-                <a:spcPct val="115000"/>
-              </a:lnSpc>
-            </a:pPr>
-            <a:r>
-              <a:rPr sz="1200" b="1" i="0">
-                <a:solidFill>
-                  <a:srgbClr val="410F37"/>
-                </a:solidFill>
-                <a:latin typeface="Fagun Bold"/>
-              </a:rPr>
-              <a:t>Cash position</a:t>
-            </a:r>
-          </a:p>
-        </p:txBody>
-      </p:sp>
-      <p:sp>
-        <p:nvSpPr>
-          <p:cNvPr id="8" name="TextBox 7"/>
-          <p:cNvSpPr txBox="1"/>
-          <p:nvPr/>
-        </p:nvSpPr>
-        <p:spPr>
-          <a:xfrm>
-            <a:off x="914400" y="2011680"/>
-            <a:ext cx="10698480" cy="457200"/>
-          </a:xfrm>
-          <a:prstGeom prst="rect">
-            <a:avLst/>
-          </a:prstGeom>
-          <a:noFill/>
-        </p:spPr>
-        <p:txBody>
-          <a:bodyPr wrap="square" anchor="t" lIns="0" rIns="0" tIns="0" bIns="0">
-            <a:spAutoFit/>
-          </a:bodyPr>
-          <a:lstStyle/>
-          <a:p>
-            <a:pPr algn="l">
-              <a:lnSpc>
-                <a:spcPct val="115000"/>
-              </a:lnSpc>
-            </a:pPr>
-            <a:r>
-              <a:rPr sz="1000" b="0" i="0">
-                <a:solidFill>
-                  <a:srgbClr val="410F37"/>
-                </a:solidFill>
-                <a:latin typeface="Inter"/>
-              </a:rPr>
-              <a:t>Cash USD 33,679 at 30 September; no contracted receipts until the FCDO Phase II claim (indicatively November) and OSF Year 3 (January 2027). Per Stacy McGill's Q3 Board Finance Report.</a:t>
-            </a:r>
-          </a:p>
-        </p:txBody>
-      </p:sp>
-      <p:sp>
-        <p:nvSpPr>
-          <p:cNvPr id="9" name="Rectangle 8"/>
-          <p:cNvSpPr/>
-          <p:nvPr/>
-        </p:nvSpPr>
-        <p:spPr>
-          <a:xfrm>
-            <a:off x="640080" y="2487168"/>
-            <a:ext cx="137160" cy="685800"/>
-          </a:xfrm>
-          <a:prstGeom prst="rect">
-            <a:avLst/>
-          </a:prstGeom>
-          <a:solidFill>
-            <a:srgbClr val="E12D64"/>
-          </a:solidFill>
-          <a:ln>
-            <a:noFill/>
-          </a:ln>
-          <a:effectLst/>
-        </p:spPr>
-        <p:style>
-          <a:lnRef idx="1">
-            <a:schemeClr val="accent1"/>
-          </a:lnRef>
-          <a:fillRef idx="3">
-            <a:schemeClr val="accent1"/>
-          </a:fillRef>
-          <a:effectRef idx="2">
-            <a:schemeClr val="accent1"/>
-          </a:effectRef>
-          <a:fontRef idx="minor">
-            <a:schemeClr val="lt1"/>
-          </a:fontRef>
-        </p:style>
-        <p:txBody>
-          <a:bodyPr rtlCol="0" anchor="ctr"/>
-          <a:lstStyle/>
-          <a:p>
-            <a:pPr algn="ctr"/>
-          </a:p>
-        </p:txBody>
-      </p:sp>
-      <p:sp>
-        <p:nvSpPr>
-          <p:cNvPr id="10" name="TextBox 9"/>
-          <p:cNvSpPr txBox="1"/>
-          <p:nvPr/>
-        </p:nvSpPr>
-        <p:spPr>
-          <a:xfrm>
-            <a:off x="914400" y="2487168"/>
-            <a:ext cx="10698480" cy="320040"/>
-          </a:xfrm>
-          <a:prstGeom prst="rect">
-            <a:avLst/>
-          </a:prstGeom>
-          <a:noFill/>
-        </p:spPr>
-        <p:txBody>
-          <a:bodyPr wrap="square" anchor="t" lIns="0" rIns="0" tIns="0" bIns="0">
-            <a:spAutoFit/>
-          </a:bodyPr>
-          <a:lstStyle/>
-          <a:p>
-            <a:pPr algn="l">
-              <a:lnSpc>
-                <a:spcPct val="115000"/>
-              </a:lnSpc>
-            </a:pPr>
-            <a:r>
-              <a:rPr sz="1200" b="1" i="0">
-                <a:solidFill>
-                  <a:srgbClr val="410F37"/>
-                </a:solidFill>
-                <a:latin typeface="Fagun Bold"/>
-              </a:rPr>
-              <a:t>Strategic framing</a:t>
-            </a:r>
-          </a:p>
-        </p:txBody>
-      </p:sp>
-      <p:sp>
-        <p:nvSpPr>
-          <p:cNvPr id="11" name="TextBox 10"/>
-          <p:cNvSpPr txBox="1"/>
-          <p:nvPr/>
-        </p:nvSpPr>
-        <p:spPr>
-          <a:xfrm>
-            <a:off x="914400" y="2761488"/>
-            <a:ext cx="10698480" cy="457200"/>
-          </a:xfrm>
-          <a:prstGeom prst="rect">
-            <a:avLst/>
-          </a:prstGeom>
-          <a:noFill/>
-        </p:spPr>
-        <p:txBody>
-          <a:bodyPr wrap="square" anchor="t" lIns="0" rIns="0" tIns="0" bIns="0">
-            <a:spAutoFit/>
-          </a:bodyPr>
-          <a:lstStyle/>
-          <a:p>
-            <a:pPr algn="l">
-              <a:lnSpc>
-                <a:spcPct val="115000"/>
-              </a:lnSpc>
-            </a:pPr>
-            <a:r>
-              <a:rPr sz="1000" b="0" i="0">
-                <a:solidFill>
-                  <a:srgbClr val="410F37"/>
-                </a:solidFill>
-                <a:latin typeface="Inter"/>
-              </a:rPr>
-              <a:t>The retreat proposes broadening the board-approved 2024–29 strategy from serious international crimes to human rights violations. </a:t>
-            </a:r>
-            <a:r>
-              <a:rPr sz="1000" b="0" i="0">
-                <a:solidFill>
-                  <a:srgbClr val="E12D64"/>
-                </a:solidFill>
-                <a:latin typeface="Inter"/>
-              </a:rPr>
-              <a:t>[Eva to confirm: Note or Endorse]</a:t>
-            </a:r>
-          </a:p>
-        </p:txBody>
-      </p:sp>
-      <p:sp>
-        <p:nvSpPr>
-          <p:cNvPr id="12" name="Rectangle 11"/>
-          <p:cNvSpPr/>
-          <p:nvPr/>
-        </p:nvSpPr>
-        <p:spPr>
-          <a:xfrm>
-            <a:off x="640080" y="3236976"/>
-            <a:ext cx="137160" cy="685800"/>
-          </a:xfrm>
-          <a:prstGeom prst="rect">
-            <a:avLst/>
-          </a:prstGeom>
-          <a:solidFill>
-            <a:srgbClr val="E12D64"/>
-          </a:solidFill>
-          <a:ln>
-            <a:noFill/>
-          </a:ln>
-          <a:effectLst/>
-        </p:spPr>
-        <p:style>
-          <a:lnRef idx="1">
-            <a:schemeClr val="accent1"/>
-          </a:lnRef>
-          <a:fillRef idx="3">
-            <a:schemeClr val="accent1"/>
-          </a:fillRef>
-          <a:effectRef idx="2">
-            <a:schemeClr val="accent1"/>
-          </a:effectRef>
-          <a:fontRef idx="minor">
-            <a:schemeClr val="lt1"/>
-          </a:fontRef>
-        </p:style>
-        <p:txBody>
-          <a:bodyPr rtlCol="0" anchor="ctr"/>
-          <a:lstStyle/>
-          <a:p>
-            <a:pPr algn="ctr"/>
-          </a:p>
-        </p:txBody>
-      </p:sp>
-      <p:sp>
-        <p:nvSpPr>
-          <p:cNvPr id="13" name="TextBox 12"/>
-          <p:cNvSpPr txBox="1"/>
-          <p:nvPr/>
-        </p:nvSpPr>
-        <p:spPr>
-          <a:xfrm>
-            <a:off x="914400" y="3236976"/>
-            <a:ext cx="10698480" cy="320040"/>
-          </a:xfrm>
-          <a:prstGeom prst="rect">
-            <a:avLst/>
-          </a:prstGeom>
-          <a:noFill/>
-        </p:spPr>
-        <p:txBody>
-          <a:bodyPr wrap="square" anchor="t" lIns="0" rIns="0" tIns="0" bIns="0">
-            <a:spAutoFit/>
-          </a:bodyPr>
-          <a:lstStyle/>
-          <a:p>
-            <a:pPr algn="l">
-              <a:lnSpc>
-                <a:spcPct val="115000"/>
-              </a:lnSpc>
-            </a:pPr>
-            <a:r>
-              <a:rPr sz="1200" b="1" i="0">
-                <a:solidFill>
-                  <a:srgbClr val="410F37"/>
-                </a:solidFill>
-                <a:latin typeface="Fagun Bold"/>
-              </a:rPr>
-              <a:t>Rohingya programme review</a:t>
-            </a:r>
-          </a:p>
-        </p:txBody>
-      </p:sp>
-      <p:sp>
-        <p:nvSpPr>
-          <p:cNvPr id="14" name="TextBox 13"/>
-          <p:cNvSpPr txBox="1"/>
-          <p:nvPr/>
-        </p:nvSpPr>
-        <p:spPr>
-          <a:xfrm>
-            <a:off x="914400" y="3511296"/>
-            <a:ext cx="10698480" cy="457200"/>
-          </a:xfrm>
-          <a:prstGeom prst="rect">
-            <a:avLst/>
-          </a:prstGeom>
-          <a:noFill/>
-        </p:spPr>
-        <p:txBody>
-          <a:bodyPr wrap="square" anchor="t" lIns="0" rIns="0" tIns="0" bIns="0">
-            <a:spAutoFit/>
-          </a:bodyPr>
-          <a:lstStyle/>
-          <a:p>
-            <a:pPr algn="l">
-              <a:lnSpc>
-                <a:spcPct val="115000"/>
-              </a:lnSpc>
-            </a:pPr>
-            <a:r>
-              <a:rPr sz="1000" b="0" i="0">
-                <a:solidFill>
-                  <a:srgbClr val="410F37"/>
-                </a:solidFill>
-                <a:latin typeface="Inter"/>
-              </a:rPr>
-              <a:t>Six-month reassessment agreed in September falls around March 2027, between board meetings. </a:t>
-            </a:r>
-            <a:r>
-              <a:rPr sz="1000" b="0" i="0">
-                <a:solidFill>
-                  <a:srgbClr val="E12D64"/>
-                </a:solidFill>
-                <a:latin typeface="Inter"/>
-              </a:rPr>
-              <a:t>[Eva to confirm: how and when the board hears the outcome]</a:t>
-            </a:r>
-          </a:p>
-        </p:txBody>
-      </p:sp>
-      <p:sp>
-        <p:nvSpPr>
-          <p:cNvPr id="15" name="Rectangle 14"/>
-          <p:cNvSpPr/>
-          <p:nvPr/>
-        </p:nvSpPr>
-        <p:spPr>
-          <a:xfrm>
-            <a:off x="640080" y="3986784"/>
-            <a:ext cx="137160" cy="685800"/>
-          </a:xfrm>
-          <a:prstGeom prst="rect">
-            <a:avLst/>
-          </a:prstGeom>
-          <a:solidFill>
-            <a:srgbClr val="E12D64"/>
-          </a:solidFill>
-          <a:ln>
-            <a:noFill/>
-          </a:ln>
-          <a:effectLst/>
-        </p:spPr>
-        <p:style>
-          <a:lnRef idx="1">
-            <a:schemeClr val="accent1"/>
-          </a:lnRef>
-          <a:fillRef idx="3">
-            <a:schemeClr val="accent1"/>
-          </a:fillRef>
-          <a:effectRef idx="2">
-            <a:schemeClr val="accent1"/>
-          </a:effectRef>
-          <a:fontRef idx="minor">
-            <a:schemeClr val="lt1"/>
-          </a:fontRef>
-        </p:style>
-        <p:txBody>
-          <a:bodyPr rtlCol="0" anchor="ctr"/>
-          <a:lstStyle/>
-          <a:p>
-            <a:pPr algn="ctr"/>
-          </a:p>
-        </p:txBody>
-      </p:sp>
-      <p:sp>
-        <p:nvSpPr>
-          <p:cNvPr id="16" name="TextBox 15"/>
-          <p:cNvSpPr txBox="1"/>
-          <p:nvPr/>
-        </p:nvSpPr>
-        <p:spPr>
-          <a:xfrm>
-            <a:off x="914400" y="3986784"/>
-            <a:ext cx="10698480" cy="320040"/>
-          </a:xfrm>
-          <a:prstGeom prst="rect">
-            <a:avLst/>
-          </a:prstGeom>
-          <a:noFill/>
-        </p:spPr>
-        <p:txBody>
-          <a:bodyPr wrap="square" anchor="t" lIns="0" rIns="0" tIns="0" bIns="0">
-            <a:spAutoFit/>
-          </a:bodyPr>
-          <a:lstStyle/>
-          <a:p>
-            <a:pPr algn="l">
-              <a:lnSpc>
-                <a:spcPct val="115000"/>
-              </a:lnSpc>
-            </a:pPr>
-            <a:r>
-              <a:rPr sz="1200" b="1" i="0">
-                <a:solidFill>
-                  <a:srgbClr val="410F37"/>
-                </a:solidFill>
-                <a:latin typeface="Fagun Bold"/>
-              </a:rPr>
-              <a:t>Prioritisation</a:t>
-            </a:r>
-          </a:p>
-        </p:txBody>
-      </p:sp>
-      <p:sp>
-        <p:nvSpPr>
-          <p:cNvPr id="17" name="TextBox 16"/>
-          <p:cNvSpPr txBox="1"/>
-          <p:nvPr/>
-        </p:nvSpPr>
-        <p:spPr>
-          <a:xfrm>
-            <a:off x="914400" y="4261104"/>
-            <a:ext cx="10698480" cy="457200"/>
-          </a:xfrm>
-          <a:prstGeom prst="rect">
-            <a:avLst/>
-          </a:prstGeom>
-          <a:noFill/>
-        </p:spPr>
-        <p:txBody>
-          <a:bodyPr wrap="square" anchor="t" lIns="0" rIns="0" tIns="0" bIns="0">
-            <a:spAutoFit/>
-          </a:bodyPr>
-          <a:lstStyle/>
-          <a:p>
-            <a:pPr algn="l">
-              <a:lnSpc>
-                <a:spcPct val="115000"/>
-              </a:lnSpc>
-            </a:pPr>
-            <a:r>
-              <a:rPr sz="1000" b="0" i="0">
-                <a:solidFill>
-                  <a:srgbClr val="410F37"/>
-                </a:solidFill>
-                <a:latin typeface="Inter"/>
-              </a:rPr>
-              <a:t>Dormant or ineffective projects to be closed or refocused. </a:t>
-            </a:r>
-            <a:r>
-              <a:rPr sz="1000" b="0" i="0">
-                <a:solidFill>
-                  <a:srgbClr val="E12D64"/>
-                </a:solidFill>
-                <a:latin typeface="Inter"/>
-              </a:rPr>
-              <a:t>[Eva to confirm: name projects or keep principled]</a:t>
-            </a:r>
-          </a:p>
-        </p:txBody>
-      </p:sp>
-      <p:sp>
-        <p:nvSpPr>
-          <p:cNvPr id="18" name="Rectangle 17"/>
-          <p:cNvSpPr/>
-          <p:nvPr/>
-        </p:nvSpPr>
-        <p:spPr>
-          <a:xfrm>
-            <a:off x="640080" y="4736592"/>
-            <a:ext cx="137160" cy="685800"/>
-          </a:xfrm>
-          <a:prstGeom prst="rect">
-            <a:avLst/>
-          </a:prstGeom>
-          <a:solidFill>
-            <a:srgbClr val="E12D64"/>
-          </a:solidFill>
-          <a:ln>
-            <a:noFill/>
-          </a:ln>
-          <a:effectLst/>
-        </p:spPr>
-        <p:style>
-          <a:lnRef idx="1">
-            <a:schemeClr val="accent1"/>
-          </a:lnRef>
-          <a:fillRef idx="3">
-            <a:schemeClr val="accent1"/>
-          </a:fillRef>
-          <a:effectRef idx="2">
-            <a:schemeClr val="accent1"/>
-          </a:effectRef>
-          <a:fontRef idx="minor">
-            <a:schemeClr val="lt1"/>
-          </a:fontRef>
-        </p:style>
-        <p:txBody>
-          <a:bodyPr rtlCol="0" anchor="ctr"/>
-          <a:lstStyle/>
-          <a:p>
-            <a:pPr algn="ctr"/>
-          </a:p>
-        </p:txBody>
-      </p:sp>
-      <p:sp>
-        <p:nvSpPr>
-          <p:cNvPr id="19" name="TextBox 18"/>
-          <p:cNvSpPr txBox="1"/>
-          <p:nvPr/>
-        </p:nvSpPr>
-        <p:spPr>
-          <a:xfrm>
-            <a:off x="914400" y="4736592"/>
-            <a:ext cx="10698480" cy="320040"/>
-          </a:xfrm>
-          <a:prstGeom prst="rect">
-            <a:avLst/>
-          </a:prstGeom>
-          <a:noFill/>
-        </p:spPr>
-        <p:txBody>
-          <a:bodyPr wrap="square" anchor="t" lIns="0" rIns="0" tIns="0" bIns="0">
-            <a:spAutoFit/>
-          </a:bodyPr>
-          <a:lstStyle/>
-          <a:p>
-            <a:pPr algn="l">
-              <a:lnSpc>
-                <a:spcPct val="115000"/>
-              </a:lnSpc>
-            </a:pPr>
-            <a:r>
-              <a:rPr sz="1200" b="1" i="0">
-                <a:solidFill>
-                  <a:srgbClr val="410F37"/>
-                </a:solidFill>
-                <a:latin typeface="Fagun Bold"/>
-              </a:rPr>
-              <a:t>Fundraising and post-OSF horizon</a:t>
-            </a:r>
-          </a:p>
-        </p:txBody>
-      </p:sp>
-      <p:sp>
-        <p:nvSpPr>
-          <p:cNvPr id="20" name="TextBox 19"/>
-          <p:cNvSpPr txBox="1"/>
-          <p:nvPr/>
-        </p:nvSpPr>
-        <p:spPr>
-          <a:xfrm>
-            <a:off x="914400" y="5010912"/>
-            <a:ext cx="10698480" cy="457200"/>
-          </a:xfrm>
-          <a:prstGeom prst="rect">
-            <a:avLst/>
-          </a:prstGeom>
-          <a:noFill/>
-        </p:spPr>
-        <p:txBody>
-          <a:bodyPr wrap="square" anchor="t" lIns="0" rIns="0" tIns="0" bIns="0">
-            <a:spAutoFit/>
-          </a:bodyPr>
-          <a:lstStyle/>
-          <a:p>
-            <a:pPr algn="l">
-              <a:lnSpc>
-                <a:spcPct val="115000"/>
-              </a:lnSpc>
-            </a:pPr>
-            <a:r>
-              <a:rPr sz="1000" b="0" i="0">
-                <a:solidFill>
-                  <a:srgbClr val="410F37"/>
-                </a:solidFill>
-                <a:latin typeface="Inter"/>
-              </a:rPr>
-              <a:t>Dedicated fundraising capacity under consideration — continues the Q2 item 6 discussion on matching ambition to fundraising. </a:t>
-            </a:r>
-            <a:r>
-              <a:rPr sz="1000" b="0" i="0">
-                <a:solidFill>
-                  <a:srgbClr val="E12D64"/>
-                </a:solidFill>
-                <a:latin typeface="Inter"/>
-              </a:rPr>
-              <a:t>[Eva to confirm: decided or exploratory]</a:t>
-            </a:r>
-          </a:p>
-        </p:txBody>
-      </p:sp>
-      <p:sp>
-        <p:nvSpPr>
-          <p:cNvPr id="21" name="Rectangle 20"/>
-          <p:cNvSpPr/>
-          <p:nvPr/>
-        </p:nvSpPr>
-        <p:spPr>
-          <a:xfrm>
-            <a:off x="640080" y="5486400"/>
-            <a:ext cx="137160" cy="685800"/>
-          </a:xfrm>
-          <a:prstGeom prst="rect">
-            <a:avLst/>
-          </a:prstGeom>
-          <a:solidFill>
-            <a:srgbClr val="E12D64"/>
-          </a:solidFill>
-          <a:ln>
-            <a:noFill/>
-          </a:ln>
-          <a:effectLst/>
-        </p:spPr>
-        <p:style>
-          <a:lnRef idx="1">
-            <a:schemeClr val="accent1"/>
-          </a:lnRef>
-          <a:fillRef idx="3">
-            <a:schemeClr val="accent1"/>
-          </a:fillRef>
-          <a:effectRef idx="2">
-            <a:schemeClr val="accent1"/>
-          </a:effectRef>
-          <a:fontRef idx="minor">
-            <a:schemeClr val="lt1"/>
-          </a:fontRef>
-        </p:style>
-        <p:txBody>
-          <a:bodyPr rtlCol="0" anchor="ctr"/>
-          <a:lstStyle/>
-          <a:p>
-            <a:pPr algn="ctr"/>
-          </a:p>
-        </p:txBody>
-      </p:sp>
-      <p:sp>
-        <p:nvSpPr>
-          <p:cNvPr id="22" name="TextBox 21"/>
-          <p:cNvSpPr txBox="1"/>
-          <p:nvPr/>
-        </p:nvSpPr>
-        <p:spPr>
-          <a:xfrm>
-            <a:off x="914400" y="5486400"/>
-            <a:ext cx="10698480" cy="320040"/>
-          </a:xfrm>
-          <a:prstGeom prst="rect">
-            <a:avLst/>
-          </a:prstGeom>
-          <a:noFill/>
-        </p:spPr>
-        <p:txBody>
-          <a:bodyPr wrap="square" anchor="t" lIns="0" rIns="0" tIns="0" bIns="0">
-            <a:spAutoFit/>
-          </a:bodyPr>
-          <a:lstStyle/>
-          <a:p>
-            <a:pPr algn="l">
-              <a:lnSpc>
-                <a:spcPct val="115000"/>
-              </a:lnSpc>
-            </a:pPr>
-            <a:r>
-              <a:rPr sz="1200" b="1" i="0">
-                <a:solidFill>
-                  <a:srgbClr val="410F37"/>
-                </a:solidFill>
-                <a:latin typeface="Fagun Bold"/>
-              </a:rPr>
-              <a:t>Governance and entity</a:t>
-            </a:r>
-          </a:p>
-        </p:txBody>
-      </p:sp>
-      <p:sp>
-        <p:nvSpPr>
-          <p:cNvPr id="23" name="TextBox 22"/>
-          <p:cNvSpPr txBox="1"/>
-          <p:nvPr/>
-        </p:nvSpPr>
-        <p:spPr>
-          <a:xfrm>
-            <a:off x="914400" y="5760720"/>
-            <a:ext cx="10698480" cy="457200"/>
-          </a:xfrm>
-          <a:prstGeom prst="rect">
-            <a:avLst/>
-          </a:prstGeom>
-          <a:noFill/>
-        </p:spPr>
-        <p:txBody>
-          <a:bodyPr wrap="square" anchor="t" lIns="0" rIns="0" tIns="0" bIns="0">
-            <a:spAutoFit/>
-          </a:bodyPr>
-          <a:lstStyle/>
-          <a:p>
-            <a:pPr algn="l">
-              <a:lnSpc>
-                <a:spcPct val="115000"/>
-              </a:lnSpc>
-            </a:pPr>
-            <a:r>
-              <a:rPr sz="1000" b="0" i="0">
-                <a:solidFill>
-                  <a:srgbClr val="410F37"/>
-                </a:solidFill>
-                <a:latin typeface="Inter"/>
-              </a:rPr>
-              <a:t>Legal name change VAI → hūmānus notified to OSF grant contacts; staff contract renewals in progress. Finance detail in Stacy McGill's papers.</a:t>
-            </a:r>
-          </a:p>
-        </p:txBody>
-      </p:sp>
-      <p:sp>
-        <p:nvSpPr>
-          <p:cNvPr id="24" name="TextBox 23"/>
-          <p:cNvSpPr txBox="1"/>
-          <p:nvPr/>
-        </p:nvSpPr>
-        <p:spPr>
-          <a:xfrm>
-            <a:off x="640080" y="6492240"/>
-            <a:ext cx="7315200" cy="274320"/>
-          </a:xfrm>
-          <a:prstGeom prst="rect">
-            <a:avLst/>
-          </a:prstGeom>
-          <a:noFill/>
-        </p:spPr>
-        <p:txBody>
-          <a:bodyPr wrap="square" anchor="t" lIns="0" rIns="0" tIns="0" bIns="0">
-            <a:spAutoFit/>
-          </a:bodyPr>
-          <a:lstStyle/>
-          <a:p>
-            <a:pPr algn="l">
-              <a:lnSpc>
-                <a:spcPct val="115000"/>
-              </a:lnSpc>
-            </a:pPr>
-            <a:r>
-              <a:rPr sz="900" b="0" i="0">
-                <a:solidFill>
-                  <a:srgbClr val="410F37"/>
-                </a:solidFill>
-                <a:latin typeface="Inter"/>
-              </a:rPr>
-              <a:t>hūmānus  ·  Q3 2026 Board Meeting  ·  Operations &amp; Impact Update  ·  DRAFT</a:t>
-            </a:r>
-          </a:p>
-        </p:txBody>
-      </p:sp>
-      <p:sp>
-        <p:nvSpPr>
-          <p:cNvPr id="25" name="TextBox 24"/>
-          <p:cNvSpPr txBox="1"/>
-          <p:nvPr/>
-        </p:nvSpPr>
-        <p:spPr>
-          <a:xfrm>
-            <a:off x="10332720" y="6492240"/>
-            <a:ext cx="1371600" cy="274320"/>
-          </a:xfrm>
-          <a:prstGeom prst="rect">
-            <a:avLst/>
-          </a:prstGeom>
-          <a:noFill/>
-        </p:spPr>
-        <p:txBody>
-          <a:bodyPr wrap="square" anchor="t" lIns="0" rIns="0" tIns="0" bIns="0">
-            <a:spAutoFit/>
-          </a:bodyPr>
-          <a:lstStyle/>
-          <a:p>
-            <a:pPr algn="r">
-              <a:lnSpc>
-                <a:spcPct val="115000"/>
-              </a:lnSpc>
-            </a:pPr>
-            <a:r>
-              <a:rPr sz="900" b="0" i="0">
-                <a:solidFill>
-                  <a:srgbClr val="410F37"/>
-                </a:solidFill>
-                <a:latin typeface="Inter"/>
-              </a:rPr>
-              <a:t>12 / 13</a:t>
-            </a:r>
-          </a:p>
-        </p:txBody>
-      </p:sp>
-    </p:spTree>
-  </p:cSld>
-  <p:clrMapOvr>
-    <a:masterClrMapping/>
-  </p:clrMapOvr>
-</p:sld>
-</file>
-
-<file path=ppt/slides/slide24.xml><?xml version="1.0" encoding="utf-8"?>
 <p:sld xmlns:a="http://schemas.openxmlformats.org/drawingml/2006/main" xmlns:p="http://schemas.openxmlformats.org/presentationml/2006/main" xmlns:r="http://schemas.openxmlformats.org/officeDocument/2006/relationships">
   <p:cSld>
     <p:spTree>

</xml_diff>

<commit_message>
Add Further activities slide to Q3 2026 ED Operations & Impact Update draft
Co-Authored-By: Claude Opus 5.5 <noreply@anthropic.com>
Co-authored-by: multica-agent <github@multica.ai>
</commit_message>
<xml_diff>
--- a/2026/Q3/ED-Operations-Impact-Q3-2026-DRAFT.pptx
+++ b/2026/Q3/ED-Operations-Impact-Q3-2026-DRAFT.pptx
@@ -17,6 +17,7 @@
     <p:sldId id="276" r:id="rId27"/>
     <p:sldId id="277" r:id="rId28"/>
     <p:sldId id="278" r:id="rId29"/>
+    <p:sldId id="279" r:id="rId30"/>
   </p:sldIdLst>
   <p:sldSz cx="12191695" cy="6858000" type="screen4x3"/>
   <p:notesSz cx="6858000" cy="9144000"/>
@@ -3988,7 +3989,7 @@
                 </a:solidFill>
                 <a:latin typeface="Inter"/>
               </a:rPr>
-              <a:t>The September retreat broadened our framing from serious international crimes to human rights violations (slide 10).</a:t>
+              <a:t>The September retreat broadened our framing from serious international crimes to human rights violations (slide 11).</a:t>
             </a:r>
           </a:p>
         </p:txBody>
@@ -4066,7 +4067,7 @@
                 </a:solidFill>
                 <a:latin typeface="Inter"/>
               </a:rPr>
-              <a:t>2 / 12</a:t>
+              <a:t>2 / 13</a:t>
             </a:r>
           </a:p>
         </p:txBody>
@@ -5493,7 +5494,7 @@
                 </a:solidFill>
                 <a:latin typeface="Inter"/>
               </a:rPr>
-              <a:t>3 / 12</a:t>
+              <a:t>3 / 13</a:t>
             </a:r>
           </a:p>
         </p:txBody>
@@ -5754,7 +5755,7 @@
                 </a:solidFill>
                 <a:latin typeface="Inter"/>
               </a:rPr>
-              <a:t>4 / 12</a:t>
+              <a:t>4 / 13</a:t>
             </a:r>
           </a:p>
         </p:txBody>
@@ -6281,7 +6282,7 @@
                 </a:solidFill>
                 <a:latin typeface="Inter"/>
               </a:rPr>
-              <a:t>The retreat agreed to continue the lawyer-network and coordination approach and to take stock of the Rohingya work after six months, around March 2027 (slide 10). The ED will report the outcome to the board.</a:t>
+              <a:t>The retreat agreed to continue the lawyer-network and coordination approach and to take stock of the Rohingya work after six months, around March 2027 (slide 11). The ED will report the outcome to the board.</a:t>
             </a:r>
           </a:p>
         </p:txBody>
@@ -6542,7 +6543,7 @@
                 </a:solidFill>
                 <a:latin typeface="Inter"/>
               </a:rPr>
-              <a:t>5 / 12</a:t>
+              <a:t>5 / 13</a:t>
             </a:r>
           </a:p>
         </p:txBody>
@@ -7252,7 +7253,7 @@
                 </a:solidFill>
                 <a:latin typeface="Inter"/>
               </a:rPr>
-              <a:t>6 / 12</a:t>
+              <a:t>6 / 13</a:t>
             </a:r>
           </a:p>
         </p:txBody>
@@ -8326,7 +8327,7 @@
                 </a:solidFill>
                 <a:latin typeface="Inter"/>
               </a:rPr>
-              <a:t>7 / 12</a:t>
+              <a:t>7 / 13</a:t>
             </a:r>
           </a:p>
         </p:txBody>
@@ -8587,7 +8588,7 @@
                 </a:solidFill>
                 <a:latin typeface="Inter"/>
               </a:rPr>
-              <a:t>8 / 12</a:t>
+              <a:t>8 / 13</a:t>
             </a:r>
           </a:p>
         </p:txBody>
@@ -9053,7 +9054,7 @@
                 </a:solidFill>
                 <a:latin typeface="Fagun Bold"/>
               </a:rPr>
-              <a:t>Research — Rohingya analysis</a:t>
+              <a:t>Further activities</a:t>
             </a:r>
           </a:p>
         </p:txBody>
@@ -9136,7 +9137,7 @@
                 </a:solidFill>
                 <a:latin typeface="Inter"/>
               </a:rPr>
-              <a:t>Sawyadullah  ·  supporting dialogue activities and Rohingya leadership</a:t>
+              <a:t>Advisory work outside our funded programmes</a:t>
             </a:r>
           </a:p>
         </p:txBody>
@@ -9214,7 +9215,7 @@
                 </a:solidFill>
                 <a:latin typeface="Inter"/>
               </a:rPr>
-              <a:t>9 / 12</a:t>
+              <a:t>9 / 13</a:t>
             </a:r>
           </a:p>
         </p:txBody>
@@ -9253,84 +9254,6 @@
                 </a:solidFill>
                 <a:latin typeface="Fagun Medium"/>
               </a:rPr>
-              <a:t>What the strand is</a:t>
-            </a:r>
-          </a:p>
-        </p:txBody>
-      </p:sp>
-      <p:sp>
-        <p:nvSpPr>
-          <p:cNvPr id="7" name="TextBox 6"/>
-          <p:cNvSpPr txBox="1"/>
-          <p:nvPr/>
-        </p:nvSpPr>
-        <p:spPr>
-          <a:xfrm>
-            <a:off x="640080" y="2285999"/>
-            <a:ext cx="10972800" cy="426719"/>
-          </a:xfrm>
-          <a:prstGeom prst="rect">
-            <a:avLst/>
-          </a:prstGeom>
-          <a:noFill/>
-        </p:spPr>
-        <p:txBody>
-          <a:bodyPr wrap="square" anchor="t" lIns="0" rIns="0" tIns="0" bIns="0">
-            <a:spAutoFit/>
-          </a:bodyPr>
-          <a:lstStyle/>
-          <a:p>
-            <a:pPr algn="l">
-              <a:lnSpc>
-                <a:spcPct val="115000"/>
-              </a:lnSpc>
-            </a:pPr>
-            <a:r>
-              <a:rPr sz="1200" b="0" i="0">
-                <a:solidFill>
-                  <a:srgbClr val="410F37"/>
-                </a:solidFill>
-                <a:latin typeface="Inter"/>
-              </a:rPr>
-              <a:t>Ten analysis reports by Sawyadullah on Rohingya relationships with the United States, China, Bangladesh, India and Pakistan — to aid our dialogue activities and support Rohingya leadership.</a:t>
-            </a:r>
-          </a:p>
-        </p:txBody>
-      </p:sp>
-      <p:sp>
-        <p:nvSpPr>
-          <p:cNvPr id="6" name="TextBox 5"/>
-          <p:cNvSpPr txBox="1"/>
-          <p:nvPr/>
-        </p:nvSpPr>
-        <p:spPr>
-          <a:xfrm>
-            <a:off x="640080" y="2872718"/>
-            <a:ext cx="10972800" cy="457200"/>
-          </a:xfrm>
-          <a:prstGeom prst="rect">
-            <a:avLst/>
-          </a:prstGeom>
-          <a:noFill/>
-        </p:spPr>
-        <p:txBody>
-          <a:bodyPr wrap="square" anchor="t" lIns="0" rIns="0" tIns="0" bIns="0">
-            <a:spAutoFit/>
-          </a:bodyPr>
-          <a:lstStyle/>
-          <a:p>
-            <a:pPr algn="l">
-              <a:lnSpc>
-                <a:spcPct val="115000"/>
-              </a:lnSpc>
-            </a:pPr>
-            <a:r>
-              <a:rPr sz="1500" b="0" i="0">
-                <a:solidFill>
-                  <a:srgbClr val="410F37"/>
-                </a:solidFill>
-                <a:latin typeface="Fagun Medium"/>
-              </a:rPr>
               <a:t>Since 29 June</a:t>
             </a:r>
           </a:p>
@@ -9344,7 +9267,7 @@
         </p:nvSpPr>
         <p:spPr>
           <a:xfrm>
-            <a:off x="640080" y="3403070"/>
+            <a:off x="640080" y="2404871"/>
             <a:ext cx="109728" cy="109728"/>
           </a:xfrm>
           <a:prstGeom prst="rect">
@@ -9388,8 +9311,8 @@
         </p:nvSpPr>
         <p:spPr>
           <a:xfrm>
-            <a:off x="914400" y="3284198"/>
-            <a:ext cx="10698480" cy="231140"/>
+            <a:off x="914400" y="2285999"/>
+            <a:ext cx="10698480" cy="462280"/>
           </a:xfrm>
           <a:prstGeom prst="rect">
             <a:avLst/>
@@ -9414,7 +9337,7 @@
                 </a:solidFill>
                 <a:latin typeface="Inter"/>
               </a:rPr>
-              <a:t>Website to host the work in development, launching November 2026.</a:t>
+              <a:t>Australian war crimes, victim participation — advice to two sets of clients in Australia on victim participation in prosecutions of alleged war crimes committed in Afghanistan.</a:t>
             </a:r>
           </a:p>
         </p:txBody>
@@ -9427,7 +9350,7 @@
         </p:nvSpPr>
         <p:spPr>
           <a:xfrm>
-            <a:off x="640080" y="3784210"/>
+            <a:off x="640080" y="3017151"/>
             <a:ext cx="109728" cy="109728"/>
           </a:xfrm>
           <a:prstGeom prst="rect">
@@ -9471,8 +9394,8 @@
         </p:nvSpPr>
         <p:spPr>
           <a:xfrm>
-            <a:off x="914400" y="3665338"/>
-            <a:ext cx="10698480" cy="231140"/>
+            <a:off x="914400" y="2898279"/>
+            <a:ext cx="10698480" cy="693419"/>
           </a:xfrm>
           <a:prstGeom prst="rect">
             <a:avLst/>
@@ -9497,7 +9420,85 @@
                 </a:solidFill>
                 <a:latin typeface="Inter"/>
               </a:rPr>
-              <a:t>A workshop on the content will be run in the Rohingya language.</a:t>
+              <a:t>Caste-based discrimination — advice on a complaint to the Australian Human Rights Commission against a New South Wales local council, concerning discrimination against Dalit, Bahujan and Adivasi communities. Referred via Salil Shetty; instructed September 2026.</a:t>
+            </a:r>
+          </a:p>
+        </p:txBody>
+      </p:sp>
+      <p:sp>
+        <p:nvSpPr>
+          <p:cNvPr id="6" name="TextBox 5"/>
+          <p:cNvSpPr txBox="1"/>
+          <p:nvPr/>
+        </p:nvSpPr>
+        <p:spPr>
+          <a:xfrm>
+            <a:off x="640080" y="3741698"/>
+            <a:ext cx="10972800" cy="457200"/>
+          </a:xfrm>
+          <a:prstGeom prst="rect">
+            <a:avLst/>
+          </a:prstGeom>
+          <a:noFill/>
+        </p:spPr>
+        <p:txBody>
+          <a:bodyPr wrap="square" anchor="t" lIns="0" rIns="0" tIns="0" bIns="0">
+            <a:spAutoFit/>
+          </a:bodyPr>
+          <a:lstStyle/>
+          <a:p>
+            <a:pPr algn="l">
+              <a:lnSpc>
+                <a:spcPct val="115000"/>
+              </a:lnSpc>
+            </a:pPr>
+            <a:r>
+              <a:rPr sz="1500" b="0" i="0">
+                <a:solidFill>
+                  <a:srgbClr val="410F37"/>
+                </a:solidFill>
+                <a:latin typeface="Fagun Medium"/>
+              </a:rPr>
+              <a:t>Why this matters for the board</a:t>
+            </a:r>
+          </a:p>
+        </p:txBody>
+      </p:sp>
+      <p:sp>
+        <p:nvSpPr>
+          <p:cNvPr id="7" name="TextBox 6"/>
+          <p:cNvSpPr txBox="1"/>
+          <p:nvPr/>
+        </p:nvSpPr>
+        <p:spPr>
+          <a:xfrm>
+            <a:off x="640080" y="4153178"/>
+            <a:ext cx="10972800" cy="426719"/>
+          </a:xfrm>
+          <a:prstGeom prst="rect">
+            <a:avLst/>
+          </a:prstGeom>
+          <a:noFill/>
+        </p:spPr>
+        <p:txBody>
+          <a:bodyPr wrap="square" anchor="t" lIns="0" rIns="0" tIns="0" bIns="0">
+            <a:spAutoFit/>
+          </a:bodyPr>
+          <a:lstStyle/>
+          <a:p>
+            <a:pPr algn="l">
+              <a:lnSpc>
+                <a:spcPct val="115000"/>
+              </a:lnSpc>
+            </a:pPr>
+            <a:r>
+              <a:rPr sz="1200" b="0" i="0">
+                <a:solidFill>
+                  <a:srgbClr val="410F37"/>
+                </a:solidFill>
+                <a:latin typeface="Inter"/>
+              </a:rPr>
+              <a:t>Both matters fall within the broadened human rights violations framing agreed at the retreat (slide 11). They are confidential client matters, so details are held by the ED and are not set out in this paper.</a:t>
             </a:r>
           </a:p>
         </p:txBody>
@@ -9597,7 +9598,7 @@
                 </a:solidFill>
                 <a:latin typeface="Fagun Bold"/>
               </a:rPr>
-              <a:t>Strategy retreat — what we decided</a:t>
+              <a:t>Research — Rohingya analysis</a:t>
             </a:r>
           </a:p>
         </p:txBody>
@@ -9680,7 +9681,7 @@
                 </a:solidFill>
                 <a:latin typeface="Inter"/>
               </a:rPr>
-              <a:t>Team retreat, September 2026  ·  strategy, impact and organisational focus</a:t>
+              <a:t>Sawyadullah  ·  supporting dialogue activities and Rohingya leadership</a:t>
             </a:r>
           </a:p>
         </p:txBody>
@@ -9758,7 +9759,7 @@
                 </a:solidFill>
                 <a:latin typeface="Inter"/>
               </a:rPr>
-              <a:t>10 / 12</a:t>
+              <a:t>10 / 13</a:t>
             </a:r>
           </a:p>
         </p:txBody>
@@ -9797,7 +9798,85 @@
                 </a:solidFill>
                 <a:latin typeface="Fagun Medium"/>
               </a:rPr>
-              <a:t>Strategy and impact</a:t>
+              <a:t>What the strand is</a:t>
+            </a:r>
+          </a:p>
+        </p:txBody>
+      </p:sp>
+      <p:sp>
+        <p:nvSpPr>
+          <p:cNvPr id="7" name="TextBox 6"/>
+          <p:cNvSpPr txBox="1"/>
+          <p:nvPr/>
+        </p:nvSpPr>
+        <p:spPr>
+          <a:xfrm>
+            <a:off x="640080" y="2285999"/>
+            <a:ext cx="10972800" cy="426719"/>
+          </a:xfrm>
+          <a:prstGeom prst="rect">
+            <a:avLst/>
+          </a:prstGeom>
+          <a:noFill/>
+        </p:spPr>
+        <p:txBody>
+          <a:bodyPr wrap="square" anchor="t" lIns="0" rIns="0" tIns="0" bIns="0">
+            <a:spAutoFit/>
+          </a:bodyPr>
+          <a:lstStyle/>
+          <a:p>
+            <a:pPr algn="l">
+              <a:lnSpc>
+                <a:spcPct val="115000"/>
+              </a:lnSpc>
+            </a:pPr>
+            <a:r>
+              <a:rPr sz="1200" b="0" i="0">
+                <a:solidFill>
+                  <a:srgbClr val="410F37"/>
+                </a:solidFill>
+                <a:latin typeface="Inter"/>
+              </a:rPr>
+              <a:t>Ten analysis reports by Sawyadullah on Rohingya relationships with the United States, China, Bangladesh, India and Pakistan — to aid our dialogue activities and support Rohingya leadership.</a:t>
+            </a:r>
+          </a:p>
+        </p:txBody>
+      </p:sp>
+      <p:sp>
+        <p:nvSpPr>
+          <p:cNvPr id="6" name="TextBox 5"/>
+          <p:cNvSpPr txBox="1"/>
+          <p:nvPr/>
+        </p:nvSpPr>
+        <p:spPr>
+          <a:xfrm>
+            <a:off x="640080" y="2872718"/>
+            <a:ext cx="10972800" cy="457200"/>
+          </a:xfrm>
+          <a:prstGeom prst="rect">
+            <a:avLst/>
+          </a:prstGeom>
+          <a:noFill/>
+        </p:spPr>
+        <p:txBody>
+          <a:bodyPr wrap="square" anchor="t" lIns="0" rIns="0" tIns="0" bIns="0">
+            <a:spAutoFit/>
+          </a:bodyPr>
+          <a:lstStyle/>
+          <a:p>
+            <a:pPr algn="l">
+              <a:lnSpc>
+                <a:spcPct val="115000"/>
+              </a:lnSpc>
+            </a:pPr>
+            <a:r>
+              <a:rPr sz="1500" b="0" i="0">
+                <a:solidFill>
+                  <a:srgbClr val="410F37"/>
+                </a:solidFill>
+                <a:latin typeface="Fagun Medium"/>
+              </a:rPr>
+              <a:t>Since 29 June</a:t>
             </a:r>
           </a:p>
         </p:txBody>
@@ -9810,7 +9889,7 @@
         </p:nvSpPr>
         <p:spPr>
           <a:xfrm>
-            <a:off x="640080" y="2404871"/>
+            <a:off x="640080" y="3403070"/>
             <a:ext cx="109728" cy="109728"/>
           </a:xfrm>
           <a:prstGeom prst="rect">
@@ -9854,8 +9933,8 @@
         </p:nvSpPr>
         <p:spPr>
           <a:xfrm>
-            <a:off x="914400" y="2285999"/>
-            <a:ext cx="10698480" cy="213359"/>
+            <a:off x="914400" y="3284198"/>
+            <a:ext cx="10698480" cy="231140"/>
           </a:xfrm>
           <a:prstGeom prst="rect">
             <a:avLst/>
@@ -9880,7 +9959,7 @@
                 </a:solidFill>
                 <a:latin typeface="Inter"/>
               </a:rPr>
-              <a:t>Plan from what clients need — an outcomes ladder linking litigation, mediation and community engagement to meaningful results.</a:t>
+              <a:t>Website to host the work in development, launching November 2026.</a:t>
             </a:r>
           </a:p>
         </p:txBody>
@@ -9893,7 +9972,7 @@
         </p:nvSpPr>
         <p:spPr>
           <a:xfrm>
-            <a:off x="640080" y="2728230"/>
+            <a:off x="640080" y="3784210"/>
             <a:ext cx="109728" cy="109728"/>
           </a:xfrm>
           <a:prstGeom prst="rect">
@@ -9937,8 +10016,8 @@
         </p:nvSpPr>
         <p:spPr>
           <a:xfrm>
-            <a:off x="914400" y="2609358"/>
-            <a:ext cx="10698480" cy="426719"/>
+            <a:off x="914400" y="3665338"/>
+            <a:ext cx="10698480" cy="231140"/>
           </a:xfrm>
           <a:prstGeom prst="rect">
             <a:avLst/>
@@ -9963,378 +10042,7 @@
                 </a:solidFill>
                 <a:latin typeface="Inter"/>
               </a:rPr>
-              <a:t>Broaden the framing from serious international crimes to human rights violations; stay people-focused and prioritise systemic change.</a:t>
-            </a:r>
-          </a:p>
-        </p:txBody>
-      </p:sp>
-      <p:sp>
-        <p:nvSpPr>
-          <p:cNvPr id="9" name="Rectangle 8"/>
-          <p:cNvSpPr/>
-          <p:nvPr/>
-        </p:nvSpPr>
-        <p:spPr>
-          <a:xfrm>
-            <a:off x="640080" y="3264949"/>
-            <a:ext cx="109728" cy="109728"/>
-          </a:xfrm>
-          <a:prstGeom prst="rect">
-            <a:avLst/>
-          </a:prstGeom>
-          <a:solidFill>
-            <a:srgbClr val="96FF14"/>
-          </a:solidFill>
-          <a:ln>
-            <a:noFill/>
-          </a:ln>
-          <a:effectLst/>
-        </p:spPr>
-        <p:style>
-          <a:lnRef idx="1">
-            <a:schemeClr val="accent1"/>
-          </a:lnRef>
-          <a:fillRef idx="3">
-            <a:schemeClr val="accent1"/>
-          </a:fillRef>
-          <a:effectRef idx="2">
-            <a:schemeClr val="accent1"/>
-          </a:effectRef>
-          <a:fontRef idx="minor">
-            <a:schemeClr val="lt1"/>
-          </a:fontRef>
-        </p:style>
-        <p:txBody>
-          <a:bodyPr rtlCol="0" anchor="ctr"/>
-          <a:lstStyle/>
-          <a:p>
-            <a:pPr algn="ctr"/>
-          </a:p>
-        </p:txBody>
-      </p:sp>
-      <p:sp>
-        <p:nvSpPr>
-          <p:cNvPr id="10" name="TextBox 9"/>
-          <p:cNvSpPr txBox="1"/>
-          <p:nvPr/>
-        </p:nvSpPr>
-        <p:spPr>
-          <a:xfrm>
-            <a:off x="914400" y="3146077"/>
-            <a:ext cx="10698480" cy="426719"/>
-          </a:xfrm>
-          <a:prstGeom prst="rect">
-            <a:avLst/>
-          </a:prstGeom>
-          <a:noFill/>
-        </p:spPr>
-        <p:txBody>
-          <a:bodyPr wrap="square" anchor="t" lIns="0" rIns="0" tIns="0" bIns="0">
-            <a:spAutoFit/>
-          </a:bodyPr>
-          <a:lstStyle/>
-          <a:p>
-            <a:pPr algn="l">
-              <a:lnSpc>
-                <a:spcPct val="125000"/>
-              </a:lnSpc>
-            </a:pPr>
-            <a:r>
-              <a:rPr sz="1300" b="0" i="0">
-                <a:solidFill>
-                  <a:srgbClr val="410F37"/>
-                </a:solidFill>
-                <a:latin typeface="Inter"/>
-              </a:rPr>
-              <a:t>Corporate accountability — legal action, regulatory complaints and advocacy — adopted as a core model, including Adani and Facebook.</a:t>
-            </a:r>
-          </a:p>
-        </p:txBody>
-      </p:sp>
-      <p:sp>
-        <p:nvSpPr>
-          <p:cNvPr id="9" name="Rectangle 8"/>
-          <p:cNvSpPr/>
-          <p:nvPr/>
-        </p:nvSpPr>
-        <p:spPr>
-          <a:xfrm>
-            <a:off x="640080" y="3801668"/>
-            <a:ext cx="109728" cy="109728"/>
-          </a:xfrm>
-          <a:prstGeom prst="rect">
-            <a:avLst/>
-          </a:prstGeom>
-          <a:solidFill>
-            <a:srgbClr val="96FF14"/>
-          </a:solidFill>
-          <a:ln>
-            <a:noFill/>
-          </a:ln>
-          <a:effectLst/>
-        </p:spPr>
-        <p:style>
-          <a:lnRef idx="1">
-            <a:schemeClr val="accent1"/>
-          </a:lnRef>
-          <a:fillRef idx="3">
-            <a:schemeClr val="accent1"/>
-          </a:fillRef>
-          <a:effectRef idx="2">
-            <a:schemeClr val="accent1"/>
-          </a:effectRef>
-          <a:fontRef idx="minor">
-            <a:schemeClr val="lt1"/>
-          </a:fontRef>
-        </p:style>
-        <p:txBody>
-          <a:bodyPr rtlCol="0" anchor="ctr"/>
-          <a:lstStyle/>
-          <a:p>
-            <a:pPr algn="ctr"/>
-          </a:p>
-        </p:txBody>
-      </p:sp>
-      <p:sp>
-        <p:nvSpPr>
-          <p:cNvPr id="10" name="TextBox 9"/>
-          <p:cNvSpPr txBox="1"/>
-          <p:nvPr/>
-        </p:nvSpPr>
-        <p:spPr>
-          <a:xfrm>
-            <a:off x="914400" y="3682796"/>
-            <a:ext cx="10698480" cy="213359"/>
-          </a:xfrm>
-          <a:prstGeom prst="rect">
-            <a:avLst/>
-          </a:prstGeom>
-          <a:noFill/>
-        </p:spPr>
-        <p:txBody>
-          <a:bodyPr wrap="square" anchor="t" lIns="0" rIns="0" tIns="0" bIns="0">
-            <a:spAutoFit/>
-          </a:bodyPr>
-          <a:lstStyle/>
-          <a:p>
-            <a:pPr algn="l">
-              <a:lnSpc>
-                <a:spcPct val="125000"/>
-              </a:lnSpc>
-            </a:pPr>
-            <a:r>
-              <a:rPr sz="1300" b="0" i="0">
-                <a:solidFill>
-                  <a:srgbClr val="410F37"/>
-                </a:solidFill>
-                <a:latin typeface="Inter"/>
-              </a:rPr>
-              <a:t>Rohingya — continue the lawyer-network and coordination approach, and take stock of progress after six months.</a:t>
-            </a:r>
-          </a:p>
-        </p:txBody>
-      </p:sp>
-      <p:sp>
-        <p:nvSpPr>
-          <p:cNvPr id="6" name="TextBox 5"/>
-          <p:cNvSpPr txBox="1"/>
-          <p:nvPr/>
-        </p:nvSpPr>
-        <p:spPr>
-          <a:xfrm>
-            <a:off x="640080" y="4006155"/>
-            <a:ext cx="10972800" cy="457200"/>
-          </a:xfrm>
-          <a:prstGeom prst="rect">
-            <a:avLst/>
-          </a:prstGeom>
-          <a:noFill/>
-        </p:spPr>
-        <p:txBody>
-          <a:bodyPr wrap="square" anchor="t" lIns="0" rIns="0" tIns="0" bIns="0">
-            <a:spAutoFit/>
-          </a:bodyPr>
-          <a:lstStyle/>
-          <a:p>
-            <a:pPr algn="l">
-              <a:lnSpc>
-                <a:spcPct val="115000"/>
-              </a:lnSpc>
-            </a:pPr>
-            <a:r>
-              <a:rPr sz="1500" b="0" i="0">
-                <a:solidFill>
-                  <a:srgbClr val="410F37"/>
-                </a:solidFill>
-                <a:latin typeface="Fagun Medium"/>
-              </a:rPr>
-              <a:t>Priorities</a:t>
-            </a:r>
-          </a:p>
-        </p:txBody>
-      </p:sp>
-      <p:sp>
-        <p:nvSpPr>
-          <p:cNvPr id="9" name="Rectangle 8"/>
-          <p:cNvSpPr/>
-          <p:nvPr/>
-        </p:nvSpPr>
-        <p:spPr>
-          <a:xfrm>
-            <a:off x="640080" y="4536507"/>
-            <a:ext cx="109728" cy="109728"/>
-          </a:xfrm>
-          <a:prstGeom prst="rect">
-            <a:avLst/>
-          </a:prstGeom>
-          <a:solidFill>
-            <a:srgbClr val="96FF14"/>
-          </a:solidFill>
-          <a:ln>
-            <a:noFill/>
-          </a:ln>
-          <a:effectLst/>
-        </p:spPr>
-        <p:style>
-          <a:lnRef idx="1">
-            <a:schemeClr val="accent1"/>
-          </a:lnRef>
-          <a:fillRef idx="3">
-            <a:schemeClr val="accent1"/>
-          </a:fillRef>
-          <a:effectRef idx="2">
-            <a:schemeClr val="accent1"/>
-          </a:effectRef>
-          <a:fontRef idx="minor">
-            <a:schemeClr val="lt1"/>
-          </a:fontRef>
-        </p:style>
-        <p:txBody>
-          <a:bodyPr rtlCol="0" anchor="ctr"/>
-          <a:lstStyle/>
-          <a:p>
-            <a:pPr algn="ctr"/>
-          </a:p>
-        </p:txBody>
-      </p:sp>
-      <p:sp>
-        <p:nvSpPr>
-          <p:cNvPr id="10" name="TextBox 9"/>
-          <p:cNvSpPr txBox="1"/>
-          <p:nvPr/>
-        </p:nvSpPr>
-        <p:spPr>
-          <a:xfrm>
-            <a:off x="914400" y="4417635"/>
-            <a:ext cx="10698480" cy="213359"/>
-          </a:xfrm>
-          <a:prstGeom prst="rect">
-            <a:avLst/>
-          </a:prstGeom>
-          <a:noFill/>
-        </p:spPr>
-        <p:txBody>
-          <a:bodyPr wrap="square" anchor="t" lIns="0" rIns="0" tIns="0" bIns="0">
-            <a:spAutoFit/>
-          </a:bodyPr>
-          <a:lstStyle/>
-          <a:p>
-            <a:pPr algn="l">
-              <a:lnSpc>
-                <a:spcPct val="125000"/>
-              </a:lnSpc>
-            </a:pPr>
-            <a:r>
-              <a:rPr sz="1300" b="0" i="0">
-                <a:solidFill>
-                  <a:srgbClr val="410F37"/>
-                </a:solidFill>
-                <a:latin typeface="Inter"/>
-              </a:rPr>
-              <a:t>Keep excellence, rigour and clear accountability central; new geographies only where needs-driven.</a:t>
-            </a:r>
-          </a:p>
-        </p:txBody>
-      </p:sp>
-      <p:sp>
-        <p:nvSpPr>
-          <p:cNvPr id="9" name="Rectangle 8"/>
-          <p:cNvSpPr/>
-          <p:nvPr/>
-        </p:nvSpPr>
-        <p:spPr>
-          <a:xfrm>
-            <a:off x="640080" y="4859866"/>
-            <a:ext cx="109728" cy="109728"/>
-          </a:xfrm>
-          <a:prstGeom prst="rect">
-            <a:avLst/>
-          </a:prstGeom>
-          <a:solidFill>
-            <a:srgbClr val="96FF14"/>
-          </a:solidFill>
-          <a:ln>
-            <a:noFill/>
-          </a:ln>
-          <a:effectLst/>
-        </p:spPr>
-        <p:style>
-          <a:lnRef idx="1">
-            <a:schemeClr val="accent1"/>
-          </a:lnRef>
-          <a:fillRef idx="3">
-            <a:schemeClr val="accent1"/>
-          </a:fillRef>
-          <a:effectRef idx="2">
-            <a:schemeClr val="accent1"/>
-          </a:effectRef>
-          <a:fontRef idx="minor">
-            <a:schemeClr val="lt1"/>
-          </a:fontRef>
-        </p:style>
-        <p:txBody>
-          <a:bodyPr rtlCol="0" anchor="ctr"/>
-          <a:lstStyle/>
-          <a:p>
-            <a:pPr algn="ctr"/>
-          </a:p>
-        </p:txBody>
-      </p:sp>
-      <p:sp>
-        <p:nvSpPr>
-          <p:cNvPr id="10" name="TextBox 9"/>
-          <p:cNvSpPr txBox="1"/>
-          <p:nvPr/>
-        </p:nvSpPr>
-        <p:spPr>
-          <a:xfrm>
-            <a:off x="914400" y="4740994"/>
-            <a:ext cx="10698480" cy="213359"/>
-          </a:xfrm>
-          <a:prstGeom prst="rect">
-            <a:avLst/>
-          </a:prstGeom>
-          <a:noFill/>
-        </p:spPr>
-        <p:txBody>
-          <a:bodyPr wrap="square" anchor="t" lIns="0" rIns="0" tIns="0" bIns="0">
-            <a:spAutoFit/>
-          </a:bodyPr>
-          <a:lstStyle/>
-          <a:p>
-            <a:pPr algn="l">
-              <a:lnSpc>
-                <a:spcPct val="125000"/>
-              </a:lnSpc>
-            </a:pPr>
-            <a:r>
-              <a:rPr sz="1300" b="0" i="0">
-                <a:solidFill>
-                  <a:srgbClr val="410F37"/>
-                </a:solidFill>
-                <a:latin typeface="Inter"/>
-              </a:rPr>
-              <a:t>Tell the organisation's story well and show impact to clients and funders; consider dedicated fundraising capacity.</a:t>
+              <a:t>A workshop on the content will be run in the Rohingya language.</a:t>
             </a:r>
           </a:p>
         </p:txBody>
@@ -10434,7 +10142,7 @@
                 </a:solidFill>
                 <a:latin typeface="Fagun Bold"/>
               </a:rPr>
-              <a:t>Strategic outlook and watch-items</a:t>
+              <a:t>Strategy retreat — what we decided</a:t>
             </a:r>
           </a:p>
         </p:txBody>
@@ -10517,27 +10225,144 @@
                 </a:solidFill>
                 <a:latin typeface="Inter"/>
               </a:rPr>
-              <a:t>Things to keep in view between now and the February 2027 meeting.</a:t>
-            </a:r>
-          </a:p>
-        </p:txBody>
-      </p:sp>
-      <p:sp>
-        <p:nvSpPr>
-          <p:cNvPr id="6" name="Rectangle 5"/>
+              <a:t>Team retreat, September 2026  ·  strategy, impact and organisational focus</a:t>
+            </a:r>
+          </a:p>
+        </p:txBody>
+      </p:sp>
+      <p:sp>
+        <p:nvSpPr>
+          <p:cNvPr id="19" name="TextBox 18"/>
+          <p:cNvSpPr txBox="1"/>
+          <p:nvPr/>
+        </p:nvSpPr>
+        <p:spPr>
+          <a:xfrm>
+            <a:off x="640080" y="6492240"/>
+            <a:ext cx="7315200" cy="274320"/>
+          </a:xfrm>
+          <a:prstGeom prst="rect">
+            <a:avLst/>
+          </a:prstGeom>
+          <a:noFill/>
+        </p:spPr>
+        <p:txBody>
+          <a:bodyPr wrap="square" anchor="t" lIns="0" rIns="0" tIns="0" bIns="0">
+            <a:spAutoFit/>
+          </a:bodyPr>
+          <a:lstStyle/>
+          <a:p>
+            <a:pPr algn="l">
+              <a:lnSpc>
+                <a:spcPct val="115000"/>
+              </a:lnSpc>
+            </a:pPr>
+            <a:r>
+              <a:rPr sz="900" b="0" i="0">
+                <a:solidFill>
+                  <a:srgbClr val="410F37"/>
+                </a:solidFill>
+                <a:latin typeface="Inter"/>
+              </a:rPr>
+              <a:t>hūmānus  ·  Q3 2026 Board Meeting  ·  Operations &amp; Impact Update  ·  DRAFT</a:t>
+            </a:r>
+          </a:p>
+        </p:txBody>
+      </p:sp>
+      <p:sp>
+        <p:nvSpPr>
+          <p:cNvPr id="20" name="TextBox 19"/>
+          <p:cNvSpPr txBox="1"/>
+          <p:nvPr/>
+        </p:nvSpPr>
+        <p:spPr>
+          <a:xfrm>
+            <a:off x="10332720" y="6492240"/>
+            <a:ext cx="1371600" cy="274320"/>
+          </a:xfrm>
+          <a:prstGeom prst="rect">
+            <a:avLst/>
+          </a:prstGeom>
+          <a:noFill/>
+        </p:spPr>
+        <p:txBody>
+          <a:bodyPr wrap="square" anchor="t" lIns="0" rIns="0" tIns="0" bIns="0">
+            <a:spAutoFit/>
+          </a:bodyPr>
+          <a:lstStyle/>
+          <a:p>
+            <a:pPr algn="r">
+              <a:lnSpc>
+                <a:spcPct val="115000"/>
+              </a:lnSpc>
+            </a:pPr>
+            <a:r>
+              <a:rPr sz="900" b="0" i="0">
+                <a:solidFill>
+                  <a:srgbClr val="410F37"/>
+                </a:solidFill>
+                <a:latin typeface="Inter"/>
+              </a:rPr>
+              <a:t>11 / 13</a:t>
+            </a:r>
+          </a:p>
+        </p:txBody>
+      </p:sp>
+      <p:sp>
+        <p:nvSpPr>
+          <p:cNvPr id="6" name="TextBox 5"/>
+          <p:cNvSpPr txBox="1"/>
+          <p:nvPr/>
+        </p:nvSpPr>
+        <p:spPr>
+          <a:xfrm>
+            <a:off x="640080" y="1874519"/>
+            <a:ext cx="10972800" cy="457200"/>
+          </a:xfrm>
+          <a:prstGeom prst="rect">
+            <a:avLst/>
+          </a:prstGeom>
+          <a:noFill/>
+        </p:spPr>
+        <p:txBody>
+          <a:bodyPr wrap="square" anchor="t" lIns="0" rIns="0" tIns="0" bIns="0">
+            <a:spAutoFit/>
+          </a:bodyPr>
+          <a:lstStyle/>
+          <a:p>
+            <a:pPr algn="l">
+              <a:lnSpc>
+                <a:spcPct val="115000"/>
+              </a:lnSpc>
+            </a:pPr>
+            <a:r>
+              <a:rPr sz="1500" b="0" i="0">
+                <a:solidFill>
+                  <a:srgbClr val="410F37"/>
+                </a:solidFill>
+                <a:latin typeface="Fagun Medium"/>
+              </a:rPr>
+              <a:t>Strategy and impact</a:t>
+            </a:r>
+          </a:p>
+        </p:txBody>
+      </p:sp>
+      <p:sp>
+        <p:nvSpPr>
+          <p:cNvPr id="9" name="Rectangle 8"/>
           <p:cNvSpPr/>
           <p:nvPr/>
         </p:nvSpPr>
         <p:spPr>
           <a:xfrm>
-            <a:off x="640080" y="1737360"/>
-            <a:ext cx="137160" cy="685800"/>
+            <a:off x="640080" y="2404871"/>
+            <a:ext cx="109728" cy="109728"/>
           </a:xfrm>
           <a:prstGeom prst="rect">
             <a:avLst/>
           </a:prstGeom>
           <a:solidFill>
-            <a:srgbClr val="E12D64"/>
+            <a:srgbClr val="96FF14"/>
           </a:solidFill>
           <a:ln>
             <a:noFill/>
@@ -10568,78 +10393,39 @@
       </p:sp>
       <p:sp>
         <p:nvSpPr>
-          <p:cNvPr id="7" name="TextBox 6"/>
-          <p:cNvSpPr txBox="1"/>
-          <p:nvPr/>
-        </p:nvSpPr>
-        <p:spPr>
-          <a:xfrm>
-            <a:off x="914400" y="1737360"/>
-            <a:ext cx="10698480" cy="320040"/>
-          </a:xfrm>
-          <a:prstGeom prst="rect">
-            <a:avLst/>
-          </a:prstGeom>
-          <a:noFill/>
-        </p:spPr>
-        <p:txBody>
-          <a:bodyPr wrap="square" anchor="t" lIns="0" rIns="0" tIns="0" bIns="0">
-            <a:spAutoFit/>
-          </a:bodyPr>
-          <a:lstStyle/>
-          <a:p>
-            <a:pPr algn="l">
-              <a:lnSpc>
-                <a:spcPct val="115000"/>
-              </a:lnSpc>
-            </a:pPr>
-            <a:r>
-              <a:rPr sz="1200" b="1" i="0">
+          <p:cNvPr id="10" name="TextBox 9"/>
+          <p:cNvSpPr txBox="1"/>
+          <p:nvPr/>
+        </p:nvSpPr>
+        <p:spPr>
+          <a:xfrm>
+            <a:off x="914400" y="2285999"/>
+            <a:ext cx="10698480" cy="213359"/>
+          </a:xfrm>
+          <a:prstGeom prst="rect">
+            <a:avLst/>
+          </a:prstGeom>
+          <a:noFill/>
+        </p:spPr>
+        <p:txBody>
+          <a:bodyPr wrap="square" anchor="t" lIns="0" rIns="0" tIns="0" bIns="0">
+            <a:spAutoFit/>
+          </a:bodyPr>
+          <a:lstStyle/>
+          <a:p>
+            <a:pPr algn="l">
+              <a:lnSpc>
+                <a:spcPct val="125000"/>
+              </a:lnSpc>
+            </a:pPr>
+            <a:r>
+              <a:rPr sz="1300" b="0" i="0">
                 <a:solidFill>
                   <a:srgbClr val="410F37"/>
                 </a:solidFill>
-                <a:latin typeface="Fagun Bold"/>
-              </a:rPr>
-              <a:t>Cash position</a:t>
-            </a:r>
-          </a:p>
-        </p:txBody>
-      </p:sp>
-      <p:sp>
-        <p:nvSpPr>
-          <p:cNvPr id="8" name="TextBox 7"/>
-          <p:cNvSpPr txBox="1"/>
-          <p:nvPr/>
-        </p:nvSpPr>
-        <p:spPr>
-          <a:xfrm>
-            <a:off x="914400" y="2011680"/>
-            <a:ext cx="10698480" cy="457200"/>
-          </a:xfrm>
-          <a:prstGeom prst="rect">
-            <a:avLst/>
-          </a:prstGeom>
-          <a:noFill/>
-        </p:spPr>
-        <p:txBody>
-          <a:bodyPr wrap="square" anchor="t" lIns="0" rIns="0" tIns="0" bIns="0">
-            <a:spAutoFit/>
-          </a:bodyPr>
-          <a:lstStyle/>
-          <a:p>
-            <a:pPr algn="l">
-              <a:lnSpc>
-                <a:spcPct val="115000"/>
-              </a:lnSpc>
-            </a:pPr>
-            <a:r>
-              <a:rPr sz="1000" b="0" i="0">
-                <a:solidFill>
-                  <a:srgbClr val="410F37"/>
-                </a:solidFill>
                 <a:latin typeface="Inter"/>
               </a:rPr>
-              <a:t>Cash USD 33,679 at 30 September; no contracted receipts until the FCDO Phase II claim (indicatively November) and OSF Year 3 (January 2027). Per Stacy McGill's Q3 Board Finance Report.</a:t>
+              <a:t>Plan from what clients need — an outcomes ladder linking litigation, mediation and community engagement to meaningful results.</a:t>
             </a:r>
           </a:p>
         </p:txBody>
@@ -10652,14 +10438,14 @@
         </p:nvSpPr>
         <p:spPr>
           <a:xfrm>
-            <a:off x="640080" y="2487168"/>
-            <a:ext cx="137160" cy="685800"/>
+            <a:off x="640080" y="2728230"/>
+            <a:ext cx="109728" cy="109728"/>
           </a:xfrm>
           <a:prstGeom prst="rect">
             <a:avLst/>
           </a:prstGeom>
           <a:solidFill>
-            <a:srgbClr val="E12D64"/>
+            <a:srgbClr val="96FF14"/>
           </a:solidFill>
           <a:ln>
             <a:noFill/>
@@ -10696,92 +10482,53 @@
         </p:nvSpPr>
         <p:spPr>
           <a:xfrm>
-            <a:off x="914400" y="2487168"/>
-            <a:ext cx="10698480" cy="320040"/>
-          </a:xfrm>
-          <a:prstGeom prst="rect">
-            <a:avLst/>
-          </a:prstGeom>
-          <a:noFill/>
-        </p:spPr>
-        <p:txBody>
-          <a:bodyPr wrap="square" anchor="t" lIns="0" rIns="0" tIns="0" bIns="0">
-            <a:spAutoFit/>
-          </a:bodyPr>
-          <a:lstStyle/>
-          <a:p>
-            <a:pPr algn="l">
-              <a:lnSpc>
-                <a:spcPct val="115000"/>
-              </a:lnSpc>
-            </a:pPr>
-            <a:r>
-              <a:rPr sz="1200" b="1" i="0">
+            <a:off x="914400" y="2609358"/>
+            <a:ext cx="10698480" cy="426719"/>
+          </a:xfrm>
+          <a:prstGeom prst="rect">
+            <a:avLst/>
+          </a:prstGeom>
+          <a:noFill/>
+        </p:spPr>
+        <p:txBody>
+          <a:bodyPr wrap="square" anchor="t" lIns="0" rIns="0" tIns="0" bIns="0">
+            <a:spAutoFit/>
+          </a:bodyPr>
+          <a:lstStyle/>
+          <a:p>
+            <a:pPr algn="l">
+              <a:lnSpc>
+                <a:spcPct val="125000"/>
+              </a:lnSpc>
+            </a:pPr>
+            <a:r>
+              <a:rPr sz="1300" b="0" i="0">
                 <a:solidFill>
                   <a:srgbClr val="410F37"/>
                 </a:solidFill>
-                <a:latin typeface="Fagun Bold"/>
-              </a:rPr>
-              <a:t>Strategic framing</a:t>
-            </a:r>
-          </a:p>
-        </p:txBody>
-      </p:sp>
-      <p:sp>
-        <p:nvSpPr>
-          <p:cNvPr id="11" name="TextBox 10"/>
-          <p:cNvSpPr txBox="1"/>
-          <p:nvPr/>
-        </p:nvSpPr>
-        <p:spPr>
-          <a:xfrm>
-            <a:off x="914400" y="2761488"/>
-            <a:ext cx="10698480" cy="457200"/>
-          </a:xfrm>
-          <a:prstGeom prst="rect">
-            <a:avLst/>
-          </a:prstGeom>
-          <a:noFill/>
-        </p:spPr>
-        <p:txBody>
-          <a:bodyPr wrap="square" anchor="t" lIns="0" rIns="0" tIns="0" bIns="0">
-            <a:spAutoFit/>
-          </a:bodyPr>
-          <a:lstStyle/>
-          <a:p>
-            <a:pPr algn="l">
-              <a:lnSpc>
-                <a:spcPct val="115000"/>
-              </a:lnSpc>
-            </a:pPr>
-            <a:r>
-              <a:rPr sz="1000" b="0" i="0">
-                <a:solidFill>
-                  <a:srgbClr val="410F37"/>
-                </a:solidFill>
                 <a:latin typeface="Inter"/>
               </a:rPr>
-              <a:t>The retreat broadened the framing of the board-approved 2024–29 strategy from serious international crimes to human rights violations — brought to the board for discussion.</a:t>
-            </a:r>
-          </a:p>
-        </p:txBody>
-      </p:sp>
-      <p:sp>
-        <p:nvSpPr>
-          <p:cNvPr id="12" name="Rectangle 11"/>
+              <a:t>Broaden the framing from serious international crimes to human rights violations; stay people-focused and prioritise systemic change.</a:t>
+            </a:r>
+          </a:p>
+        </p:txBody>
+      </p:sp>
+      <p:sp>
+        <p:nvSpPr>
+          <p:cNvPr id="9" name="Rectangle 8"/>
           <p:cNvSpPr/>
           <p:nvPr/>
         </p:nvSpPr>
         <p:spPr>
           <a:xfrm>
-            <a:off x="640080" y="3236976"/>
-            <a:ext cx="137160" cy="685800"/>
+            <a:off x="640080" y="3264949"/>
+            <a:ext cx="109728" cy="109728"/>
           </a:xfrm>
           <a:prstGeom prst="rect">
             <a:avLst/>
           </a:prstGeom>
           <a:solidFill>
-            <a:srgbClr val="E12D64"/>
+            <a:srgbClr val="96FF14"/>
           </a:solidFill>
           <a:ln>
             <a:noFill/>
@@ -10812,98 +10559,59 @@
       </p:sp>
       <p:sp>
         <p:nvSpPr>
-          <p:cNvPr id="13" name="TextBox 12"/>
-          <p:cNvSpPr txBox="1"/>
-          <p:nvPr/>
-        </p:nvSpPr>
-        <p:spPr>
-          <a:xfrm>
-            <a:off x="914400" y="3236976"/>
-            <a:ext cx="10698480" cy="320040"/>
-          </a:xfrm>
-          <a:prstGeom prst="rect">
-            <a:avLst/>
-          </a:prstGeom>
-          <a:noFill/>
-        </p:spPr>
-        <p:txBody>
-          <a:bodyPr wrap="square" anchor="t" lIns="0" rIns="0" tIns="0" bIns="0">
-            <a:spAutoFit/>
-          </a:bodyPr>
-          <a:lstStyle/>
-          <a:p>
-            <a:pPr algn="l">
-              <a:lnSpc>
-                <a:spcPct val="115000"/>
-              </a:lnSpc>
-            </a:pPr>
-            <a:r>
-              <a:rPr sz="1200" b="1" i="0">
+          <p:cNvPr id="10" name="TextBox 9"/>
+          <p:cNvSpPr txBox="1"/>
+          <p:nvPr/>
+        </p:nvSpPr>
+        <p:spPr>
+          <a:xfrm>
+            <a:off x="914400" y="3146077"/>
+            <a:ext cx="10698480" cy="426719"/>
+          </a:xfrm>
+          <a:prstGeom prst="rect">
+            <a:avLst/>
+          </a:prstGeom>
+          <a:noFill/>
+        </p:spPr>
+        <p:txBody>
+          <a:bodyPr wrap="square" anchor="t" lIns="0" rIns="0" tIns="0" bIns="0">
+            <a:spAutoFit/>
+          </a:bodyPr>
+          <a:lstStyle/>
+          <a:p>
+            <a:pPr algn="l">
+              <a:lnSpc>
+                <a:spcPct val="125000"/>
+              </a:lnSpc>
+            </a:pPr>
+            <a:r>
+              <a:rPr sz="1300" b="0" i="0">
                 <a:solidFill>
                   <a:srgbClr val="410F37"/>
                 </a:solidFill>
-                <a:latin typeface="Fagun Bold"/>
-              </a:rPr>
-              <a:t>Rohingya work</a:t>
-            </a:r>
-          </a:p>
-        </p:txBody>
-      </p:sp>
-      <p:sp>
-        <p:nvSpPr>
-          <p:cNvPr id="14" name="TextBox 13"/>
-          <p:cNvSpPr txBox="1"/>
-          <p:nvPr/>
-        </p:nvSpPr>
-        <p:spPr>
-          <a:xfrm>
-            <a:off x="914400" y="3511296"/>
-            <a:ext cx="10698480" cy="457200"/>
-          </a:xfrm>
-          <a:prstGeom prst="rect">
-            <a:avLst/>
-          </a:prstGeom>
-          <a:noFill/>
-        </p:spPr>
-        <p:txBody>
-          <a:bodyPr wrap="square" anchor="t" lIns="0" rIns="0" tIns="0" bIns="0">
-            <a:spAutoFit/>
-          </a:bodyPr>
-          <a:lstStyle/>
-          <a:p>
-            <a:pPr algn="l">
-              <a:lnSpc>
-                <a:spcPct val="115000"/>
-              </a:lnSpc>
-            </a:pPr>
-            <a:r>
-              <a:rPr sz="1000" b="0" i="0">
-                <a:solidFill>
-                  <a:srgbClr val="410F37"/>
-                </a:solidFill>
                 <a:latin typeface="Inter"/>
               </a:rPr>
-              <a:t>Progress to be taken stock of around March 2027, between board meetings; the ED will report the outcome to the board.</a:t>
-            </a:r>
-          </a:p>
-        </p:txBody>
-      </p:sp>
-      <p:sp>
-        <p:nvSpPr>
-          <p:cNvPr id="15" name="Rectangle 14"/>
+              <a:t>Corporate accountability — legal action, regulatory complaints and advocacy — adopted as a core model, including Adani and Facebook.</a:t>
+            </a:r>
+          </a:p>
+        </p:txBody>
+      </p:sp>
+      <p:sp>
+        <p:nvSpPr>
+          <p:cNvPr id="9" name="Rectangle 8"/>
           <p:cNvSpPr/>
           <p:nvPr/>
         </p:nvSpPr>
         <p:spPr>
           <a:xfrm>
-            <a:off x="640080" y="3986784"/>
-            <a:ext cx="137160" cy="685800"/>
+            <a:off x="640080" y="3801668"/>
+            <a:ext cx="109728" cy="109728"/>
           </a:xfrm>
           <a:prstGeom prst="rect">
             <a:avLst/>
           </a:prstGeom>
           <a:solidFill>
-            <a:srgbClr val="E12D64"/>
+            <a:srgbClr val="96FF14"/>
           </a:solidFill>
           <a:ln>
             <a:noFill/>
@@ -10934,98 +10642,98 @@
       </p:sp>
       <p:sp>
         <p:nvSpPr>
-          <p:cNvPr id="16" name="TextBox 15"/>
-          <p:cNvSpPr txBox="1"/>
-          <p:nvPr/>
-        </p:nvSpPr>
-        <p:spPr>
-          <a:xfrm>
-            <a:off x="914400" y="3986784"/>
-            <a:ext cx="10698480" cy="320040"/>
-          </a:xfrm>
-          <a:prstGeom prst="rect">
-            <a:avLst/>
-          </a:prstGeom>
-          <a:noFill/>
-        </p:spPr>
-        <p:txBody>
-          <a:bodyPr wrap="square" anchor="t" lIns="0" rIns="0" tIns="0" bIns="0">
-            <a:spAutoFit/>
-          </a:bodyPr>
-          <a:lstStyle/>
-          <a:p>
-            <a:pPr algn="l">
-              <a:lnSpc>
-                <a:spcPct val="115000"/>
-              </a:lnSpc>
-            </a:pPr>
-            <a:r>
-              <a:rPr sz="1200" b="1" i="0">
+          <p:cNvPr id="10" name="TextBox 9"/>
+          <p:cNvSpPr txBox="1"/>
+          <p:nvPr/>
+        </p:nvSpPr>
+        <p:spPr>
+          <a:xfrm>
+            <a:off x="914400" y="3682796"/>
+            <a:ext cx="10698480" cy="213359"/>
+          </a:xfrm>
+          <a:prstGeom prst="rect">
+            <a:avLst/>
+          </a:prstGeom>
+          <a:noFill/>
+        </p:spPr>
+        <p:txBody>
+          <a:bodyPr wrap="square" anchor="t" lIns="0" rIns="0" tIns="0" bIns="0">
+            <a:spAutoFit/>
+          </a:bodyPr>
+          <a:lstStyle/>
+          <a:p>
+            <a:pPr algn="l">
+              <a:lnSpc>
+                <a:spcPct val="125000"/>
+              </a:lnSpc>
+            </a:pPr>
+            <a:r>
+              <a:rPr sz="1300" b="0" i="0">
                 <a:solidFill>
                   <a:srgbClr val="410F37"/>
                 </a:solidFill>
-                <a:latin typeface="Fagun Bold"/>
-              </a:rPr>
-              <a:t>Fundraising and post-OSF horizon</a:t>
-            </a:r>
-          </a:p>
-        </p:txBody>
-      </p:sp>
-      <p:sp>
-        <p:nvSpPr>
-          <p:cNvPr id="17" name="TextBox 16"/>
-          <p:cNvSpPr txBox="1"/>
-          <p:nvPr/>
-        </p:nvSpPr>
-        <p:spPr>
-          <a:xfrm>
-            <a:off x="914400" y="4261104"/>
-            <a:ext cx="10698480" cy="457200"/>
-          </a:xfrm>
-          <a:prstGeom prst="rect">
-            <a:avLst/>
-          </a:prstGeom>
-          <a:noFill/>
-        </p:spPr>
-        <p:txBody>
-          <a:bodyPr wrap="square" anchor="t" lIns="0" rIns="0" tIns="0" bIns="0">
-            <a:spAutoFit/>
-          </a:bodyPr>
-          <a:lstStyle/>
-          <a:p>
-            <a:pPr algn="l">
-              <a:lnSpc>
-                <a:spcPct val="115000"/>
-              </a:lnSpc>
-            </a:pPr>
-            <a:r>
-              <a:rPr sz="1000" b="0" i="0">
+                <a:latin typeface="Inter"/>
+              </a:rPr>
+              <a:t>Rohingya — continue the lawyer-network and coordination approach, and take stock of progress after six months.</a:t>
+            </a:r>
+          </a:p>
+        </p:txBody>
+      </p:sp>
+      <p:sp>
+        <p:nvSpPr>
+          <p:cNvPr id="6" name="TextBox 5"/>
+          <p:cNvSpPr txBox="1"/>
+          <p:nvPr/>
+        </p:nvSpPr>
+        <p:spPr>
+          <a:xfrm>
+            <a:off x="640080" y="4006155"/>
+            <a:ext cx="10972800" cy="457200"/>
+          </a:xfrm>
+          <a:prstGeom prst="rect">
+            <a:avLst/>
+          </a:prstGeom>
+          <a:noFill/>
+        </p:spPr>
+        <p:txBody>
+          <a:bodyPr wrap="square" anchor="t" lIns="0" rIns="0" tIns="0" bIns="0">
+            <a:spAutoFit/>
+          </a:bodyPr>
+          <a:lstStyle/>
+          <a:p>
+            <a:pPr algn="l">
+              <a:lnSpc>
+                <a:spcPct val="115000"/>
+              </a:lnSpc>
+            </a:pPr>
+            <a:r>
+              <a:rPr sz="1500" b="0" i="0">
                 <a:solidFill>
                   <a:srgbClr val="410F37"/>
                 </a:solidFill>
-                <a:latin typeface="Inter"/>
-              </a:rPr>
-              <a:t>Dedicated fundraising capacity under consideration — continues the Q2 item 6 discussion on matching ambition to fundraising.</a:t>
-            </a:r>
-          </a:p>
-        </p:txBody>
-      </p:sp>
-      <p:sp>
-        <p:nvSpPr>
-          <p:cNvPr id="18" name="Rectangle 17"/>
+                <a:latin typeface="Fagun Medium"/>
+              </a:rPr>
+              <a:t>Priorities</a:t>
+            </a:r>
+          </a:p>
+        </p:txBody>
+      </p:sp>
+      <p:sp>
+        <p:nvSpPr>
+          <p:cNvPr id="9" name="Rectangle 8"/>
           <p:cNvSpPr/>
           <p:nvPr/>
         </p:nvSpPr>
         <p:spPr>
           <a:xfrm>
-            <a:off x="640080" y="4736592"/>
-            <a:ext cx="137160" cy="685800"/>
+            <a:off x="640080" y="4536507"/>
+            <a:ext cx="109728" cy="109728"/>
           </a:xfrm>
           <a:prstGeom prst="rect">
             <a:avLst/>
           </a:prstGeom>
           <a:solidFill>
-            <a:srgbClr val="E12D64"/>
+            <a:srgbClr val="96FF14"/>
           </a:solidFill>
           <a:ln>
             <a:noFill/>
@@ -11056,156 +10764,122 @@
       </p:sp>
       <p:sp>
         <p:nvSpPr>
-          <p:cNvPr id="19" name="TextBox 18"/>
-          <p:cNvSpPr txBox="1"/>
-          <p:nvPr/>
-        </p:nvSpPr>
-        <p:spPr>
-          <a:xfrm>
-            <a:off x="914400" y="4736592"/>
-            <a:ext cx="10698480" cy="320040"/>
-          </a:xfrm>
-          <a:prstGeom prst="rect">
-            <a:avLst/>
-          </a:prstGeom>
-          <a:noFill/>
-        </p:spPr>
-        <p:txBody>
-          <a:bodyPr wrap="square" anchor="t" lIns="0" rIns="0" tIns="0" bIns="0">
-            <a:spAutoFit/>
-          </a:bodyPr>
-          <a:lstStyle/>
-          <a:p>
-            <a:pPr algn="l">
-              <a:lnSpc>
-                <a:spcPct val="115000"/>
-              </a:lnSpc>
-            </a:pPr>
-            <a:r>
-              <a:rPr sz="1200" b="1" i="0">
+          <p:cNvPr id="10" name="TextBox 9"/>
+          <p:cNvSpPr txBox="1"/>
+          <p:nvPr/>
+        </p:nvSpPr>
+        <p:spPr>
+          <a:xfrm>
+            <a:off x="914400" y="4417635"/>
+            <a:ext cx="10698480" cy="213359"/>
+          </a:xfrm>
+          <a:prstGeom prst="rect">
+            <a:avLst/>
+          </a:prstGeom>
+          <a:noFill/>
+        </p:spPr>
+        <p:txBody>
+          <a:bodyPr wrap="square" anchor="t" lIns="0" rIns="0" tIns="0" bIns="0">
+            <a:spAutoFit/>
+          </a:bodyPr>
+          <a:lstStyle/>
+          <a:p>
+            <a:pPr algn="l">
+              <a:lnSpc>
+                <a:spcPct val="125000"/>
+              </a:lnSpc>
+            </a:pPr>
+            <a:r>
+              <a:rPr sz="1300" b="0" i="0">
                 <a:solidFill>
                   <a:srgbClr val="410F37"/>
                 </a:solidFill>
-                <a:latin typeface="Fagun Bold"/>
-              </a:rPr>
-              <a:t>Governance and entity</a:t>
-            </a:r>
-          </a:p>
-        </p:txBody>
-      </p:sp>
-      <p:sp>
-        <p:nvSpPr>
-          <p:cNvPr id="20" name="TextBox 19"/>
-          <p:cNvSpPr txBox="1"/>
-          <p:nvPr/>
-        </p:nvSpPr>
-        <p:spPr>
-          <a:xfrm>
-            <a:off x="914400" y="5010912"/>
-            <a:ext cx="10698480" cy="457200"/>
-          </a:xfrm>
-          <a:prstGeom prst="rect">
-            <a:avLst/>
-          </a:prstGeom>
-          <a:noFill/>
-        </p:spPr>
-        <p:txBody>
-          <a:bodyPr wrap="square" anchor="t" lIns="0" rIns="0" tIns="0" bIns="0">
-            <a:spAutoFit/>
-          </a:bodyPr>
-          <a:lstStyle/>
-          <a:p>
-            <a:pPr algn="l">
-              <a:lnSpc>
-                <a:spcPct val="115000"/>
-              </a:lnSpc>
-            </a:pPr>
-            <a:r>
-              <a:rPr sz="1000" b="0" i="0">
+                <a:latin typeface="Inter"/>
+              </a:rPr>
+              <a:t>Keep excellence, rigour and clear accountability central; new geographies only where needs-driven.</a:t>
+            </a:r>
+          </a:p>
+        </p:txBody>
+      </p:sp>
+      <p:sp>
+        <p:nvSpPr>
+          <p:cNvPr id="9" name="Rectangle 8"/>
+          <p:cNvSpPr/>
+          <p:nvPr/>
+        </p:nvSpPr>
+        <p:spPr>
+          <a:xfrm>
+            <a:off x="640080" y="4859866"/>
+            <a:ext cx="109728" cy="109728"/>
+          </a:xfrm>
+          <a:prstGeom prst="rect">
+            <a:avLst/>
+          </a:prstGeom>
+          <a:solidFill>
+            <a:srgbClr val="96FF14"/>
+          </a:solidFill>
+          <a:ln>
+            <a:noFill/>
+          </a:ln>
+          <a:effectLst/>
+        </p:spPr>
+        <p:style>
+          <a:lnRef idx="1">
+            <a:schemeClr val="accent1"/>
+          </a:lnRef>
+          <a:fillRef idx="3">
+            <a:schemeClr val="accent1"/>
+          </a:fillRef>
+          <a:effectRef idx="2">
+            <a:schemeClr val="accent1"/>
+          </a:effectRef>
+          <a:fontRef idx="minor">
+            <a:schemeClr val="lt1"/>
+          </a:fontRef>
+        </p:style>
+        <p:txBody>
+          <a:bodyPr rtlCol="0" anchor="ctr"/>
+          <a:lstStyle/>
+          <a:p>
+            <a:pPr algn="ctr"/>
+          </a:p>
+        </p:txBody>
+      </p:sp>
+      <p:sp>
+        <p:nvSpPr>
+          <p:cNvPr id="10" name="TextBox 9"/>
+          <p:cNvSpPr txBox="1"/>
+          <p:nvPr/>
+        </p:nvSpPr>
+        <p:spPr>
+          <a:xfrm>
+            <a:off x="914400" y="4740994"/>
+            <a:ext cx="10698480" cy="213359"/>
+          </a:xfrm>
+          <a:prstGeom prst="rect">
+            <a:avLst/>
+          </a:prstGeom>
+          <a:noFill/>
+        </p:spPr>
+        <p:txBody>
+          <a:bodyPr wrap="square" anchor="t" lIns="0" rIns="0" tIns="0" bIns="0">
+            <a:spAutoFit/>
+          </a:bodyPr>
+          <a:lstStyle/>
+          <a:p>
+            <a:pPr algn="l">
+              <a:lnSpc>
+                <a:spcPct val="125000"/>
+              </a:lnSpc>
+            </a:pPr>
+            <a:r>
+              <a:rPr sz="1300" b="0" i="0">
                 <a:solidFill>
                   <a:srgbClr val="410F37"/>
                 </a:solidFill>
                 <a:latin typeface="Inter"/>
               </a:rPr>
-              <a:t>Legal name change VAI → hūmānus notified to OSF grant contacts; staff contract renewals in progress. Finance detail in Stacy McGill's papers.</a:t>
-            </a:r>
-          </a:p>
-        </p:txBody>
-      </p:sp>
-      <p:sp>
-        <p:nvSpPr>
-          <p:cNvPr id="24" name="TextBox 23"/>
-          <p:cNvSpPr txBox="1"/>
-          <p:nvPr/>
-        </p:nvSpPr>
-        <p:spPr>
-          <a:xfrm>
-            <a:off x="640080" y="6492240"/>
-            <a:ext cx="7315200" cy="274320"/>
-          </a:xfrm>
-          <a:prstGeom prst="rect">
-            <a:avLst/>
-          </a:prstGeom>
-          <a:noFill/>
-        </p:spPr>
-        <p:txBody>
-          <a:bodyPr wrap="square" anchor="t" lIns="0" rIns="0" tIns="0" bIns="0">
-            <a:spAutoFit/>
-          </a:bodyPr>
-          <a:lstStyle/>
-          <a:p>
-            <a:pPr algn="l">
-              <a:lnSpc>
-                <a:spcPct val="115000"/>
-              </a:lnSpc>
-            </a:pPr>
-            <a:r>
-              <a:rPr sz="900" b="0" i="0">
-                <a:solidFill>
-                  <a:srgbClr val="410F37"/>
-                </a:solidFill>
-                <a:latin typeface="Inter"/>
-              </a:rPr>
-              <a:t>hūmānus  ·  Q3 2026 Board Meeting  ·  Operations &amp; Impact Update  ·  DRAFT</a:t>
-            </a:r>
-          </a:p>
-        </p:txBody>
-      </p:sp>
-      <p:sp>
-        <p:nvSpPr>
-          <p:cNvPr id="25" name="TextBox 24"/>
-          <p:cNvSpPr txBox="1"/>
-          <p:nvPr/>
-        </p:nvSpPr>
-        <p:spPr>
-          <a:xfrm>
-            <a:off x="10332720" y="6492240"/>
-            <a:ext cx="1371600" cy="274320"/>
-          </a:xfrm>
-          <a:prstGeom prst="rect">
-            <a:avLst/>
-          </a:prstGeom>
-          <a:noFill/>
-        </p:spPr>
-        <p:txBody>
-          <a:bodyPr wrap="square" anchor="t" lIns="0" rIns="0" tIns="0" bIns="0">
-            <a:spAutoFit/>
-          </a:bodyPr>
-          <a:lstStyle/>
-          <a:p>
-            <a:pPr algn="r">
-              <a:lnSpc>
-                <a:spcPct val="115000"/>
-              </a:lnSpc>
-            </a:pPr>
-            <a:r>
-              <a:rPr sz="900" b="0" i="0">
-                <a:solidFill>
-                  <a:srgbClr val="410F37"/>
-                </a:solidFill>
-                <a:latin typeface="Inter"/>
-              </a:rPr>
-              <a:t>11 / 12</a:t>
+              <a:t>Tell the organisation's story well and show impact to clients and funders; consider dedicated fundraising capacity.</a:t>
             </a:r>
           </a:p>
         </p:txBody>
@@ -11219,6 +10893,877 @@
 </file>
 
 <file path=ppt/slides/slide23.xml><?xml version="1.0" encoding="utf-8"?>
+<p:sld xmlns:a="http://schemas.openxmlformats.org/drawingml/2006/main" xmlns:p="http://schemas.openxmlformats.org/presentationml/2006/main" xmlns:r="http://schemas.openxmlformats.org/officeDocument/2006/relationships">
+  <p:cSld>
+    <p:spTree>
+      <p:nvGrpSpPr>
+        <p:cNvPr id="1" name=""/>
+        <p:cNvGrpSpPr/>
+        <p:nvPr/>
+      </p:nvGrpSpPr>
+      <p:grpSpPr/>
+      <p:sp>
+        <p:nvSpPr>
+          <p:cNvPr id="2" name="Rectangle 1"/>
+          <p:cNvSpPr/>
+          <p:nvPr/>
+        </p:nvSpPr>
+        <p:spPr>
+          <a:xfrm>
+            <a:off x="0" y="0"/>
+            <a:ext cx="12191695" cy="6858000"/>
+          </a:xfrm>
+          <a:prstGeom prst="rect">
+            <a:avLst/>
+          </a:prstGeom>
+          <a:solidFill>
+            <a:srgbClr val="FFFFFF"/>
+          </a:solidFill>
+          <a:ln>
+            <a:noFill/>
+          </a:ln>
+        </p:spPr>
+        <p:style>
+          <a:lnRef idx="1">
+            <a:schemeClr val="accent1"/>
+          </a:lnRef>
+          <a:fillRef idx="3">
+            <a:schemeClr val="accent1"/>
+          </a:fillRef>
+          <a:effectRef idx="2">
+            <a:schemeClr val="accent1"/>
+          </a:effectRef>
+          <a:fontRef idx="minor">
+            <a:schemeClr val="lt1"/>
+          </a:fontRef>
+        </p:style>
+        <p:txBody>
+          <a:bodyPr rtlCol="0" anchor="ctr"/>
+          <a:lstStyle/>
+          <a:p>
+            <a:pPr algn="ctr"/>
+          </a:p>
+        </p:txBody>
+      </p:sp>
+      <p:sp>
+        <p:nvSpPr>
+          <p:cNvPr id="3" name="TextBox 2"/>
+          <p:cNvSpPr txBox="1"/>
+          <p:nvPr/>
+        </p:nvSpPr>
+        <p:spPr>
+          <a:xfrm>
+            <a:off x="640080" y="502920"/>
+            <a:ext cx="10972800" cy="548640"/>
+          </a:xfrm>
+          <a:prstGeom prst="rect">
+            <a:avLst/>
+          </a:prstGeom>
+          <a:noFill/>
+        </p:spPr>
+        <p:txBody>
+          <a:bodyPr wrap="square" anchor="t" lIns="0" rIns="0" tIns="0" bIns="0">
+            <a:spAutoFit/>
+          </a:bodyPr>
+          <a:lstStyle/>
+          <a:p>
+            <a:pPr algn="l">
+              <a:lnSpc>
+                <a:spcPct val="115000"/>
+              </a:lnSpc>
+            </a:pPr>
+            <a:r>
+              <a:rPr sz="2800" b="1" i="0">
+                <a:solidFill>
+                  <a:srgbClr val="410F37"/>
+                </a:solidFill>
+                <a:latin typeface="Fagun Bold"/>
+              </a:rPr>
+              <a:t>Strategic outlook and watch-items</a:t>
+            </a:r>
+          </a:p>
+        </p:txBody>
+      </p:sp>
+      <p:sp>
+        <p:nvSpPr>
+          <p:cNvPr id="4" name="Rectangle 3"/>
+          <p:cNvSpPr/>
+          <p:nvPr/>
+        </p:nvSpPr>
+        <p:spPr>
+          <a:xfrm>
+            <a:off x="640080" y="1097280"/>
+            <a:ext cx="548640" cy="54864"/>
+          </a:xfrm>
+          <a:prstGeom prst="rect">
+            <a:avLst/>
+          </a:prstGeom>
+          <a:solidFill>
+            <a:srgbClr val="E12D64"/>
+          </a:solidFill>
+          <a:ln>
+            <a:noFill/>
+          </a:ln>
+          <a:effectLst/>
+        </p:spPr>
+        <p:style>
+          <a:lnRef idx="1">
+            <a:schemeClr val="accent1"/>
+          </a:lnRef>
+          <a:fillRef idx="3">
+            <a:schemeClr val="accent1"/>
+          </a:fillRef>
+          <a:effectRef idx="2">
+            <a:schemeClr val="accent1"/>
+          </a:effectRef>
+          <a:fontRef idx="minor">
+            <a:schemeClr val="lt1"/>
+          </a:fontRef>
+        </p:style>
+        <p:txBody>
+          <a:bodyPr rtlCol="0" anchor="ctr"/>
+          <a:lstStyle/>
+          <a:p>
+            <a:pPr algn="ctr"/>
+          </a:p>
+        </p:txBody>
+      </p:sp>
+      <p:sp>
+        <p:nvSpPr>
+          <p:cNvPr id="5" name="TextBox 4"/>
+          <p:cNvSpPr txBox="1"/>
+          <p:nvPr/>
+        </p:nvSpPr>
+        <p:spPr>
+          <a:xfrm>
+            <a:off x="640080" y="1280160"/>
+            <a:ext cx="10972800" cy="457200"/>
+          </a:xfrm>
+          <a:prstGeom prst="rect">
+            <a:avLst/>
+          </a:prstGeom>
+          <a:noFill/>
+        </p:spPr>
+        <p:txBody>
+          <a:bodyPr wrap="square" anchor="t" lIns="0" rIns="0" tIns="0" bIns="0">
+            <a:spAutoFit/>
+          </a:bodyPr>
+          <a:lstStyle/>
+          <a:p>
+            <a:pPr algn="l">
+              <a:lnSpc>
+                <a:spcPct val="115000"/>
+              </a:lnSpc>
+            </a:pPr>
+            <a:r>
+              <a:rPr sz="1300" b="0" i="1">
+                <a:solidFill>
+                  <a:srgbClr val="E12D64"/>
+                </a:solidFill>
+                <a:latin typeface="Inter"/>
+              </a:rPr>
+              <a:t>Things to keep in view between now and the February 2027 meeting.</a:t>
+            </a:r>
+          </a:p>
+        </p:txBody>
+      </p:sp>
+      <p:sp>
+        <p:nvSpPr>
+          <p:cNvPr id="6" name="Rectangle 5"/>
+          <p:cNvSpPr/>
+          <p:nvPr/>
+        </p:nvSpPr>
+        <p:spPr>
+          <a:xfrm>
+            <a:off x="640080" y="1737360"/>
+            <a:ext cx="137160" cy="685800"/>
+          </a:xfrm>
+          <a:prstGeom prst="rect">
+            <a:avLst/>
+          </a:prstGeom>
+          <a:solidFill>
+            <a:srgbClr val="E12D64"/>
+          </a:solidFill>
+          <a:ln>
+            <a:noFill/>
+          </a:ln>
+          <a:effectLst/>
+        </p:spPr>
+        <p:style>
+          <a:lnRef idx="1">
+            <a:schemeClr val="accent1"/>
+          </a:lnRef>
+          <a:fillRef idx="3">
+            <a:schemeClr val="accent1"/>
+          </a:fillRef>
+          <a:effectRef idx="2">
+            <a:schemeClr val="accent1"/>
+          </a:effectRef>
+          <a:fontRef idx="minor">
+            <a:schemeClr val="lt1"/>
+          </a:fontRef>
+        </p:style>
+        <p:txBody>
+          <a:bodyPr rtlCol="0" anchor="ctr"/>
+          <a:lstStyle/>
+          <a:p>
+            <a:pPr algn="ctr"/>
+          </a:p>
+        </p:txBody>
+      </p:sp>
+      <p:sp>
+        <p:nvSpPr>
+          <p:cNvPr id="7" name="TextBox 6"/>
+          <p:cNvSpPr txBox="1"/>
+          <p:nvPr/>
+        </p:nvSpPr>
+        <p:spPr>
+          <a:xfrm>
+            <a:off x="914400" y="1737360"/>
+            <a:ext cx="10698480" cy="320040"/>
+          </a:xfrm>
+          <a:prstGeom prst="rect">
+            <a:avLst/>
+          </a:prstGeom>
+          <a:noFill/>
+        </p:spPr>
+        <p:txBody>
+          <a:bodyPr wrap="square" anchor="t" lIns="0" rIns="0" tIns="0" bIns="0">
+            <a:spAutoFit/>
+          </a:bodyPr>
+          <a:lstStyle/>
+          <a:p>
+            <a:pPr algn="l">
+              <a:lnSpc>
+                <a:spcPct val="115000"/>
+              </a:lnSpc>
+            </a:pPr>
+            <a:r>
+              <a:rPr sz="1200" b="1" i="0">
+                <a:solidFill>
+                  <a:srgbClr val="410F37"/>
+                </a:solidFill>
+                <a:latin typeface="Fagun Bold"/>
+              </a:rPr>
+              <a:t>Cash position</a:t>
+            </a:r>
+          </a:p>
+        </p:txBody>
+      </p:sp>
+      <p:sp>
+        <p:nvSpPr>
+          <p:cNvPr id="8" name="TextBox 7"/>
+          <p:cNvSpPr txBox="1"/>
+          <p:nvPr/>
+        </p:nvSpPr>
+        <p:spPr>
+          <a:xfrm>
+            <a:off x="914400" y="2011680"/>
+            <a:ext cx="10698480" cy="457200"/>
+          </a:xfrm>
+          <a:prstGeom prst="rect">
+            <a:avLst/>
+          </a:prstGeom>
+          <a:noFill/>
+        </p:spPr>
+        <p:txBody>
+          <a:bodyPr wrap="square" anchor="t" lIns="0" rIns="0" tIns="0" bIns="0">
+            <a:spAutoFit/>
+          </a:bodyPr>
+          <a:lstStyle/>
+          <a:p>
+            <a:pPr algn="l">
+              <a:lnSpc>
+                <a:spcPct val="115000"/>
+              </a:lnSpc>
+            </a:pPr>
+            <a:r>
+              <a:rPr sz="1000" b="0" i="0">
+                <a:solidFill>
+                  <a:srgbClr val="410F37"/>
+                </a:solidFill>
+                <a:latin typeface="Inter"/>
+              </a:rPr>
+              <a:t>Cash USD 33,679 at 30 September; no contracted receipts until the FCDO Phase II claim (indicatively November) and OSF Year 3 (January 2027). Per Stacy McGill's Q3 Board Finance Report.</a:t>
+            </a:r>
+          </a:p>
+        </p:txBody>
+      </p:sp>
+      <p:sp>
+        <p:nvSpPr>
+          <p:cNvPr id="9" name="Rectangle 8"/>
+          <p:cNvSpPr/>
+          <p:nvPr/>
+        </p:nvSpPr>
+        <p:spPr>
+          <a:xfrm>
+            <a:off x="640080" y="2487168"/>
+            <a:ext cx="137160" cy="685800"/>
+          </a:xfrm>
+          <a:prstGeom prst="rect">
+            <a:avLst/>
+          </a:prstGeom>
+          <a:solidFill>
+            <a:srgbClr val="E12D64"/>
+          </a:solidFill>
+          <a:ln>
+            <a:noFill/>
+          </a:ln>
+          <a:effectLst/>
+        </p:spPr>
+        <p:style>
+          <a:lnRef idx="1">
+            <a:schemeClr val="accent1"/>
+          </a:lnRef>
+          <a:fillRef idx="3">
+            <a:schemeClr val="accent1"/>
+          </a:fillRef>
+          <a:effectRef idx="2">
+            <a:schemeClr val="accent1"/>
+          </a:effectRef>
+          <a:fontRef idx="minor">
+            <a:schemeClr val="lt1"/>
+          </a:fontRef>
+        </p:style>
+        <p:txBody>
+          <a:bodyPr rtlCol="0" anchor="ctr"/>
+          <a:lstStyle/>
+          <a:p>
+            <a:pPr algn="ctr"/>
+          </a:p>
+        </p:txBody>
+      </p:sp>
+      <p:sp>
+        <p:nvSpPr>
+          <p:cNvPr id="10" name="TextBox 9"/>
+          <p:cNvSpPr txBox="1"/>
+          <p:nvPr/>
+        </p:nvSpPr>
+        <p:spPr>
+          <a:xfrm>
+            <a:off x="914400" y="2487168"/>
+            <a:ext cx="10698480" cy="320040"/>
+          </a:xfrm>
+          <a:prstGeom prst="rect">
+            <a:avLst/>
+          </a:prstGeom>
+          <a:noFill/>
+        </p:spPr>
+        <p:txBody>
+          <a:bodyPr wrap="square" anchor="t" lIns="0" rIns="0" tIns="0" bIns="0">
+            <a:spAutoFit/>
+          </a:bodyPr>
+          <a:lstStyle/>
+          <a:p>
+            <a:pPr algn="l">
+              <a:lnSpc>
+                <a:spcPct val="115000"/>
+              </a:lnSpc>
+            </a:pPr>
+            <a:r>
+              <a:rPr sz="1200" b="1" i="0">
+                <a:solidFill>
+                  <a:srgbClr val="410F37"/>
+                </a:solidFill>
+                <a:latin typeface="Fagun Bold"/>
+              </a:rPr>
+              <a:t>Strategic framing</a:t>
+            </a:r>
+          </a:p>
+        </p:txBody>
+      </p:sp>
+      <p:sp>
+        <p:nvSpPr>
+          <p:cNvPr id="11" name="TextBox 10"/>
+          <p:cNvSpPr txBox="1"/>
+          <p:nvPr/>
+        </p:nvSpPr>
+        <p:spPr>
+          <a:xfrm>
+            <a:off x="914400" y="2761488"/>
+            <a:ext cx="10698480" cy="457200"/>
+          </a:xfrm>
+          <a:prstGeom prst="rect">
+            <a:avLst/>
+          </a:prstGeom>
+          <a:noFill/>
+        </p:spPr>
+        <p:txBody>
+          <a:bodyPr wrap="square" anchor="t" lIns="0" rIns="0" tIns="0" bIns="0">
+            <a:spAutoFit/>
+          </a:bodyPr>
+          <a:lstStyle/>
+          <a:p>
+            <a:pPr algn="l">
+              <a:lnSpc>
+                <a:spcPct val="115000"/>
+              </a:lnSpc>
+            </a:pPr>
+            <a:r>
+              <a:rPr sz="1000" b="0" i="0">
+                <a:solidFill>
+                  <a:srgbClr val="410F37"/>
+                </a:solidFill>
+                <a:latin typeface="Inter"/>
+              </a:rPr>
+              <a:t>The retreat broadened the framing of the board-approved 2024–29 strategy from serious international crimes to human rights violations — brought to the board for discussion.</a:t>
+            </a:r>
+          </a:p>
+        </p:txBody>
+      </p:sp>
+      <p:sp>
+        <p:nvSpPr>
+          <p:cNvPr id="12" name="Rectangle 11"/>
+          <p:cNvSpPr/>
+          <p:nvPr/>
+        </p:nvSpPr>
+        <p:spPr>
+          <a:xfrm>
+            <a:off x="640080" y="3236976"/>
+            <a:ext cx="137160" cy="685800"/>
+          </a:xfrm>
+          <a:prstGeom prst="rect">
+            <a:avLst/>
+          </a:prstGeom>
+          <a:solidFill>
+            <a:srgbClr val="E12D64"/>
+          </a:solidFill>
+          <a:ln>
+            <a:noFill/>
+          </a:ln>
+          <a:effectLst/>
+        </p:spPr>
+        <p:style>
+          <a:lnRef idx="1">
+            <a:schemeClr val="accent1"/>
+          </a:lnRef>
+          <a:fillRef idx="3">
+            <a:schemeClr val="accent1"/>
+          </a:fillRef>
+          <a:effectRef idx="2">
+            <a:schemeClr val="accent1"/>
+          </a:effectRef>
+          <a:fontRef idx="minor">
+            <a:schemeClr val="lt1"/>
+          </a:fontRef>
+        </p:style>
+        <p:txBody>
+          <a:bodyPr rtlCol="0" anchor="ctr"/>
+          <a:lstStyle/>
+          <a:p>
+            <a:pPr algn="ctr"/>
+          </a:p>
+        </p:txBody>
+      </p:sp>
+      <p:sp>
+        <p:nvSpPr>
+          <p:cNvPr id="13" name="TextBox 12"/>
+          <p:cNvSpPr txBox="1"/>
+          <p:nvPr/>
+        </p:nvSpPr>
+        <p:spPr>
+          <a:xfrm>
+            <a:off x="914400" y="3236976"/>
+            <a:ext cx="10698480" cy="320040"/>
+          </a:xfrm>
+          <a:prstGeom prst="rect">
+            <a:avLst/>
+          </a:prstGeom>
+          <a:noFill/>
+        </p:spPr>
+        <p:txBody>
+          <a:bodyPr wrap="square" anchor="t" lIns="0" rIns="0" tIns="0" bIns="0">
+            <a:spAutoFit/>
+          </a:bodyPr>
+          <a:lstStyle/>
+          <a:p>
+            <a:pPr algn="l">
+              <a:lnSpc>
+                <a:spcPct val="115000"/>
+              </a:lnSpc>
+            </a:pPr>
+            <a:r>
+              <a:rPr sz="1200" b="1" i="0">
+                <a:solidFill>
+                  <a:srgbClr val="410F37"/>
+                </a:solidFill>
+                <a:latin typeface="Fagun Bold"/>
+              </a:rPr>
+              <a:t>Rohingya work</a:t>
+            </a:r>
+          </a:p>
+        </p:txBody>
+      </p:sp>
+      <p:sp>
+        <p:nvSpPr>
+          <p:cNvPr id="14" name="TextBox 13"/>
+          <p:cNvSpPr txBox="1"/>
+          <p:nvPr/>
+        </p:nvSpPr>
+        <p:spPr>
+          <a:xfrm>
+            <a:off x="914400" y="3511296"/>
+            <a:ext cx="10698480" cy="457200"/>
+          </a:xfrm>
+          <a:prstGeom prst="rect">
+            <a:avLst/>
+          </a:prstGeom>
+          <a:noFill/>
+        </p:spPr>
+        <p:txBody>
+          <a:bodyPr wrap="square" anchor="t" lIns="0" rIns="0" tIns="0" bIns="0">
+            <a:spAutoFit/>
+          </a:bodyPr>
+          <a:lstStyle/>
+          <a:p>
+            <a:pPr algn="l">
+              <a:lnSpc>
+                <a:spcPct val="115000"/>
+              </a:lnSpc>
+            </a:pPr>
+            <a:r>
+              <a:rPr sz="1000" b="0" i="0">
+                <a:solidFill>
+                  <a:srgbClr val="410F37"/>
+                </a:solidFill>
+                <a:latin typeface="Inter"/>
+              </a:rPr>
+              <a:t>Progress to be taken stock of around March 2027, between board meetings; the ED will report the outcome to the board.</a:t>
+            </a:r>
+          </a:p>
+        </p:txBody>
+      </p:sp>
+      <p:sp>
+        <p:nvSpPr>
+          <p:cNvPr id="15" name="Rectangle 14"/>
+          <p:cNvSpPr/>
+          <p:nvPr/>
+        </p:nvSpPr>
+        <p:spPr>
+          <a:xfrm>
+            <a:off x="640080" y="3986784"/>
+            <a:ext cx="137160" cy="685800"/>
+          </a:xfrm>
+          <a:prstGeom prst="rect">
+            <a:avLst/>
+          </a:prstGeom>
+          <a:solidFill>
+            <a:srgbClr val="E12D64"/>
+          </a:solidFill>
+          <a:ln>
+            <a:noFill/>
+          </a:ln>
+          <a:effectLst/>
+        </p:spPr>
+        <p:style>
+          <a:lnRef idx="1">
+            <a:schemeClr val="accent1"/>
+          </a:lnRef>
+          <a:fillRef idx="3">
+            <a:schemeClr val="accent1"/>
+          </a:fillRef>
+          <a:effectRef idx="2">
+            <a:schemeClr val="accent1"/>
+          </a:effectRef>
+          <a:fontRef idx="minor">
+            <a:schemeClr val="lt1"/>
+          </a:fontRef>
+        </p:style>
+        <p:txBody>
+          <a:bodyPr rtlCol="0" anchor="ctr"/>
+          <a:lstStyle/>
+          <a:p>
+            <a:pPr algn="ctr"/>
+          </a:p>
+        </p:txBody>
+      </p:sp>
+      <p:sp>
+        <p:nvSpPr>
+          <p:cNvPr id="16" name="TextBox 15"/>
+          <p:cNvSpPr txBox="1"/>
+          <p:nvPr/>
+        </p:nvSpPr>
+        <p:spPr>
+          <a:xfrm>
+            <a:off x="914400" y="3986784"/>
+            <a:ext cx="10698480" cy="320040"/>
+          </a:xfrm>
+          <a:prstGeom prst="rect">
+            <a:avLst/>
+          </a:prstGeom>
+          <a:noFill/>
+        </p:spPr>
+        <p:txBody>
+          <a:bodyPr wrap="square" anchor="t" lIns="0" rIns="0" tIns="0" bIns="0">
+            <a:spAutoFit/>
+          </a:bodyPr>
+          <a:lstStyle/>
+          <a:p>
+            <a:pPr algn="l">
+              <a:lnSpc>
+                <a:spcPct val="115000"/>
+              </a:lnSpc>
+            </a:pPr>
+            <a:r>
+              <a:rPr sz="1200" b="1" i="0">
+                <a:solidFill>
+                  <a:srgbClr val="410F37"/>
+                </a:solidFill>
+                <a:latin typeface="Fagun Bold"/>
+              </a:rPr>
+              <a:t>Fundraising and post-OSF horizon</a:t>
+            </a:r>
+          </a:p>
+        </p:txBody>
+      </p:sp>
+      <p:sp>
+        <p:nvSpPr>
+          <p:cNvPr id="17" name="TextBox 16"/>
+          <p:cNvSpPr txBox="1"/>
+          <p:nvPr/>
+        </p:nvSpPr>
+        <p:spPr>
+          <a:xfrm>
+            <a:off x="914400" y="4261104"/>
+            <a:ext cx="10698480" cy="457200"/>
+          </a:xfrm>
+          <a:prstGeom prst="rect">
+            <a:avLst/>
+          </a:prstGeom>
+          <a:noFill/>
+        </p:spPr>
+        <p:txBody>
+          <a:bodyPr wrap="square" anchor="t" lIns="0" rIns="0" tIns="0" bIns="0">
+            <a:spAutoFit/>
+          </a:bodyPr>
+          <a:lstStyle/>
+          <a:p>
+            <a:pPr algn="l">
+              <a:lnSpc>
+                <a:spcPct val="115000"/>
+              </a:lnSpc>
+            </a:pPr>
+            <a:r>
+              <a:rPr sz="1000" b="0" i="0">
+                <a:solidFill>
+                  <a:srgbClr val="410F37"/>
+                </a:solidFill>
+                <a:latin typeface="Inter"/>
+              </a:rPr>
+              <a:t>Dedicated fundraising capacity under consideration — continues the Q2 item 6 discussion on matching ambition to fundraising.</a:t>
+            </a:r>
+          </a:p>
+        </p:txBody>
+      </p:sp>
+      <p:sp>
+        <p:nvSpPr>
+          <p:cNvPr id="18" name="Rectangle 17"/>
+          <p:cNvSpPr/>
+          <p:nvPr/>
+        </p:nvSpPr>
+        <p:spPr>
+          <a:xfrm>
+            <a:off x="640080" y="4736592"/>
+            <a:ext cx="137160" cy="685800"/>
+          </a:xfrm>
+          <a:prstGeom prst="rect">
+            <a:avLst/>
+          </a:prstGeom>
+          <a:solidFill>
+            <a:srgbClr val="E12D64"/>
+          </a:solidFill>
+          <a:ln>
+            <a:noFill/>
+          </a:ln>
+          <a:effectLst/>
+        </p:spPr>
+        <p:style>
+          <a:lnRef idx="1">
+            <a:schemeClr val="accent1"/>
+          </a:lnRef>
+          <a:fillRef idx="3">
+            <a:schemeClr val="accent1"/>
+          </a:fillRef>
+          <a:effectRef idx="2">
+            <a:schemeClr val="accent1"/>
+          </a:effectRef>
+          <a:fontRef idx="minor">
+            <a:schemeClr val="lt1"/>
+          </a:fontRef>
+        </p:style>
+        <p:txBody>
+          <a:bodyPr rtlCol="0" anchor="ctr"/>
+          <a:lstStyle/>
+          <a:p>
+            <a:pPr algn="ctr"/>
+          </a:p>
+        </p:txBody>
+      </p:sp>
+      <p:sp>
+        <p:nvSpPr>
+          <p:cNvPr id="19" name="TextBox 18"/>
+          <p:cNvSpPr txBox="1"/>
+          <p:nvPr/>
+        </p:nvSpPr>
+        <p:spPr>
+          <a:xfrm>
+            <a:off x="914400" y="4736592"/>
+            <a:ext cx="10698480" cy="320040"/>
+          </a:xfrm>
+          <a:prstGeom prst="rect">
+            <a:avLst/>
+          </a:prstGeom>
+          <a:noFill/>
+        </p:spPr>
+        <p:txBody>
+          <a:bodyPr wrap="square" anchor="t" lIns="0" rIns="0" tIns="0" bIns="0">
+            <a:spAutoFit/>
+          </a:bodyPr>
+          <a:lstStyle/>
+          <a:p>
+            <a:pPr algn="l">
+              <a:lnSpc>
+                <a:spcPct val="115000"/>
+              </a:lnSpc>
+            </a:pPr>
+            <a:r>
+              <a:rPr sz="1200" b="1" i="0">
+                <a:solidFill>
+                  <a:srgbClr val="410F37"/>
+                </a:solidFill>
+                <a:latin typeface="Fagun Bold"/>
+              </a:rPr>
+              <a:t>Governance and entity</a:t>
+            </a:r>
+          </a:p>
+        </p:txBody>
+      </p:sp>
+      <p:sp>
+        <p:nvSpPr>
+          <p:cNvPr id="20" name="TextBox 19"/>
+          <p:cNvSpPr txBox="1"/>
+          <p:nvPr/>
+        </p:nvSpPr>
+        <p:spPr>
+          <a:xfrm>
+            <a:off x="914400" y="5010912"/>
+            <a:ext cx="10698480" cy="457200"/>
+          </a:xfrm>
+          <a:prstGeom prst="rect">
+            <a:avLst/>
+          </a:prstGeom>
+          <a:noFill/>
+        </p:spPr>
+        <p:txBody>
+          <a:bodyPr wrap="square" anchor="t" lIns="0" rIns="0" tIns="0" bIns="0">
+            <a:spAutoFit/>
+          </a:bodyPr>
+          <a:lstStyle/>
+          <a:p>
+            <a:pPr algn="l">
+              <a:lnSpc>
+                <a:spcPct val="115000"/>
+              </a:lnSpc>
+            </a:pPr>
+            <a:r>
+              <a:rPr sz="1000" b="0" i="0">
+                <a:solidFill>
+                  <a:srgbClr val="410F37"/>
+                </a:solidFill>
+                <a:latin typeface="Inter"/>
+              </a:rPr>
+              <a:t>Legal name change VAI → hūmānus notified to OSF grant contacts; staff contract renewals in progress. Finance detail in Stacy McGill's papers.</a:t>
+            </a:r>
+          </a:p>
+        </p:txBody>
+      </p:sp>
+      <p:sp>
+        <p:nvSpPr>
+          <p:cNvPr id="24" name="TextBox 23"/>
+          <p:cNvSpPr txBox="1"/>
+          <p:nvPr/>
+        </p:nvSpPr>
+        <p:spPr>
+          <a:xfrm>
+            <a:off x="640080" y="6492240"/>
+            <a:ext cx="7315200" cy="274320"/>
+          </a:xfrm>
+          <a:prstGeom prst="rect">
+            <a:avLst/>
+          </a:prstGeom>
+          <a:noFill/>
+        </p:spPr>
+        <p:txBody>
+          <a:bodyPr wrap="square" anchor="t" lIns="0" rIns="0" tIns="0" bIns="0">
+            <a:spAutoFit/>
+          </a:bodyPr>
+          <a:lstStyle/>
+          <a:p>
+            <a:pPr algn="l">
+              <a:lnSpc>
+                <a:spcPct val="115000"/>
+              </a:lnSpc>
+            </a:pPr>
+            <a:r>
+              <a:rPr sz="900" b="0" i="0">
+                <a:solidFill>
+                  <a:srgbClr val="410F37"/>
+                </a:solidFill>
+                <a:latin typeface="Inter"/>
+              </a:rPr>
+              <a:t>hūmānus  ·  Q3 2026 Board Meeting  ·  Operations &amp; Impact Update  ·  DRAFT</a:t>
+            </a:r>
+          </a:p>
+        </p:txBody>
+      </p:sp>
+      <p:sp>
+        <p:nvSpPr>
+          <p:cNvPr id="25" name="TextBox 24"/>
+          <p:cNvSpPr txBox="1"/>
+          <p:nvPr/>
+        </p:nvSpPr>
+        <p:spPr>
+          <a:xfrm>
+            <a:off x="10332720" y="6492240"/>
+            <a:ext cx="1371600" cy="274320"/>
+          </a:xfrm>
+          <a:prstGeom prst="rect">
+            <a:avLst/>
+          </a:prstGeom>
+          <a:noFill/>
+        </p:spPr>
+        <p:txBody>
+          <a:bodyPr wrap="square" anchor="t" lIns="0" rIns="0" tIns="0" bIns="0">
+            <a:spAutoFit/>
+          </a:bodyPr>
+          <a:lstStyle/>
+          <a:p>
+            <a:pPr algn="r">
+              <a:lnSpc>
+                <a:spcPct val="115000"/>
+              </a:lnSpc>
+            </a:pPr>
+            <a:r>
+              <a:rPr sz="900" b="0" i="0">
+                <a:solidFill>
+                  <a:srgbClr val="410F37"/>
+                </a:solidFill>
+                <a:latin typeface="Inter"/>
+              </a:rPr>
+              <a:t>12 / 13</a:t>
+            </a:r>
+          </a:p>
+        </p:txBody>
+      </p:sp>
+    </p:spTree>
+  </p:cSld>
+  <p:clrMapOvr>
+    <a:masterClrMapping/>
+  </p:clrMapOvr>
+</p:sld>
+</file>
+
+<file path=ppt/slides/slide24.xml><?xml version="1.0" encoding="utf-8"?>
 <p:sld xmlns:a="http://schemas.openxmlformats.org/drawingml/2006/main" xmlns:p="http://schemas.openxmlformats.org/presentationml/2006/main" xmlns:r="http://schemas.openxmlformats.org/officeDocument/2006/relationships">
   <p:cSld>
     <p:spTree>

</xml_diff>